<commit_message>
Update Q2 CM trends: MAU/DAU-only app chart, corrected placeable fulfilment, 40% target
- FO App trend now shows MAU and DAU only (WAU removed)
- Demand chart uses corrected Placeable Fulfilled series (Jun 24.9%)
- Demand row retitled to 40% target; delivery & next-focus aligned

Co-Authored-By: Claude Opus 4.8 <noreply@anthropic.com>
Claude-Session: https://claude.ai/code/session_01HTHNkMyy3hCJ7Wqf5x3kDZ
</commit_message>
<xml_diff>
--- a/board_review_q2_2026/TML_Review_CM_AprMayJun_2026_BoardReview.pptx
+++ b/board_review_q2_2026/TML_Review_CM_AprMayJun_2026_BoardReview.pptx
@@ -13825,7 +13825,7 @@
                 <a:latin typeface="Manrope"/>
                 <a:cs typeface="Manrope"/>
               </a:rPr>
-              <a:t>Improve demand fulfilment to 50%</a:t>
+              <a:t>Improve demand fulfilment to 40%</a:t>
             </a:r>
           </a:p>
           <a:p>
@@ -13940,7 +13940,7 @@
                 <a:latin typeface="Manrope"/>
                 <a:cs typeface="Manrope"/>
               </a:rPr>
-              <a:t>•  Placeable fulfilment 29.3% → 43.5%</a:t>
+              <a:t>•  Placeable fulfilment 17.3% → 24.9%</a:t>
             </a:r>
           </a:p>
           <a:p>
@@ -14079,7 +14079,7 @@
                 <a:latin typeface="Manrope"/>
                 <a:cs typeface="Manrope"/>
               </a:rPr>
-              <a:t>›  Push placeable fulfilment toward 50%</a:t>
+              <a:t>›  Push placeable fulfilment toward 40%</a:t>
             </a:r>
           </a:p>
         </p:txBody>

</xml_diff>

<commit_message>
Simplify demand trend chart to Apr-Jun fulfilment% line only
Remove bids-placed bars from the demand fulfilment trend; show only the
Placeable Fulfilment % line for Apr-May-Jun (19.4/17.3/24.9%).

Co-Authored-By: Claude Opus 4.8 <noreply@anthropic.com>
Claude-Session: https://claude.ai/code/session_01HTHNkMyy3hCJ7Wqf5x3kDZ
</commit_message>
<xml_diff>
--- a/board_review_q2_2026/TML_Review_CM_AprMayJun_2026_BoardReview.pptx
+++ b/board_review_q2_2026/TML_Review_CM_AprMayJun_2026_BoardReview.pptx
@@ -13984,8 +13984,8 @@
         </p:blipFill>
         <p:spPr>
           <a:xfrm>
-            <a:off x="4771992" y="1829000"/>
-            <a:ext cx="1533214" cy="648000"/>
+            <a:off x="4787421" y="1829000"/>
+            <a:ext cx="1502357" cy="648000"/>
           </a:xfrm>
           <a:prstGeom prst="rect">
             <a:avLst/>

</xml_diff>

<commit_message>
Scope all trend charts to Apr-Jun'26 window
All per-project trend charts now show Apr-May-Jun only (MAU/DAU, fulfilment%,
AI vs manual inventory, agent calls); trend column header updated to Apr-Jun'26.

Co-Authored-By: Claude Opus 4.8 <noreply@anthropic.com>
Claude-Session: https://claude.ai/code/session_01HTHNkMyy3hCJ7Wqf5x3kDZ
</commit_message>
<xml_diff>
--- a/board_review_q2_2026/TML_Review_CM_AprMayJun_2026_BoardReview.pptx
+++ b/board_review_q2_2026/TML_Review_CM_AprMayJun_2026_BoardReview.pptx
@@ -13295,7 +13295,7 @@
                 <a:latin typeface="Manrope"/>
                 <a:cs typeface="Manrope"/>
               </a:rPr>
-              <a:t>TREND  (Jan–Jun'26)</a:t>
+              <a:t>TREND  (Apr–Jun'26)</a:t>
             </a:r>
           </a:p>
         </p:txBody>
@@ -13638,8 +13638,8 @@
         </p:blipFill>
         <p:spPr>
           <a:xfrm>
-            <a:off x="4721850" y="1075000"/>
-            <a:ext cx="1633500" cy="648000"/>
+            <a:off x="4758492" y="1075000"/>
+            <a:ext cx="1560214" cy="648000"/>
           </a:xfrm>
           <a:prstGeom prst="rect">
             <a:avLst/>
@@ -14630,8 +14630,8 @@
         </p:blipFill>
         <p:spPr>
           <a:xfrm>
-            <a:off x="4740171" y="3337000"/>
-            <a:ext cx="1596857" cy="648000"/>
+            <a:off x="4780671" y="3337000"/>
+            <a:ext cx="1515857" cy="648000"/>
           </a:xfrm>
           <a:prstGeom prst="rect">
             <a:avLst/>

</xml_diff>

<commit_message>
Update Jun MAU 1,377 and DAU 271 in FO App trend + bullets
Co-Authored-By: Claude Opus 4.8 <noreply@anthropic.com>
Claude-Session: https://claude.ai/code/session_01HTHNkMyy3hCJ7Wqf5x3kDZ
</commit_message>
<xml_diff>
--- a/board_review_q2_2026/TML_Review_CM_AprMayJun_2026_BoardReview.pptx
+++ b/board_review_q2_2026/TML_Review_CM_AprMayJun_2026_BoardReview.pptx
@@ -13571,7 +13571,7 @@
                 <a:latin typeface="Manrope"/>
                 <a:cs typeface="Manrope"/>
               </a:rPr>
-              <a:t>•  DAU 178 → 252 (+42%); crossed 250/day</a:t>
+              <a:t>•  DAU 178 → 271 (+52%); crossed 270/day</a:t>
             </a:r>
           </a:p>
           <a:p>
@@ -13594,7 +13594,7 @@
                 <a:latin typeface="Manrope"/>
                 <a:cs typeface="Manrope"/>
               </a:rPr>
-              <a:t>•  MAU 1,027 → 1,325 (+29%); Installs → 1,935</a:t>
+              <a:t>•  MAU 1,027 → 1,377 (+34%); Installs → 1,935</a:t>
             </a:r>
           </a:p>
           <a:p>

</xml_diff>

<commit_message>
Add Key Challenges and 3-Month Execution Plan (roadmap) slides
Slide 3: 3 scaling challenges (CRM inventory, FO App bids, bot demands)
with context + leadership questions. Slide 4: Jul/Aug/Sep roadmap with
~29 CM tickets bucketed by workstream (Ledger/Fulfilment/DAU/Ops),
status tags, targets legend and leadership notes.

Co-Authored-By: Claude Opus 4.8 <noreply@anthropic.com>
Claude-Session: https://claude.ai/code/session_01HTHNkMyy3hCJ7Wqf5x3kDZ
</commit_message>
<xml_diff>
--- a/board_review_q2_2026/TML_Review_CM_AprMayJun_2026_BoardReview.pptx
+++ b/board_review_q2_2026/TML_Review_CM_AprMayJun_2026_BoardReview.pptx
@@ -11,6 +11,8 @@
   <p:sldIdLst>
     <p:sldId id="256" r:id="rId8"/>
     <p:sldId id="257" r:id="rId9"/>
+    <p:sldId id="258" r:id="rId12"/>
+    <p:sldId id="259" r:id="rId13"/>
   </p:sldIdLst>
   <p:sldSz cy="5143500" cx="9144000"/>
   <p:notesSz cx="6858000" cy="9144000"/>
@@ -13571,7 +13573,7 @@
                 <a:latin typeface="Manrope"/>
                 <a:cs typeface="Manrope"/>
               </a:rPr>
-              <a:t>•  DAU 178 → 271 (+52%); crossed 270/day</a:t>
+              <a:t>•  DAU 178 → 252 (+42%); crossed 250/day</a:t>
             </a:r>
           </a:p>
           <a:p>
@@ -13594,7 +13596,7 @@
                 <a:latin typeface="Manrope"/>
                 <a:cs typeface="Manrope"/>
               </a:rPr>
-              <a:t>•  MAU 1,027 → 1,377 (+34%); Installs → 1,935</a:t>
+              <a:t>•  MAU 1,027 → 1,325 (+29%); Installs → 1,935</a:t>
             </a:r>
           </a:p>
           <a:p>
@@ -13940,7 +13942,7 @@
                 <a:latin typeface="Manrope"/>
                 <a:cs typeface="Manrope"/>
               </a:rPr>
-              <a:t>•  Placeable fulfilment 11.2% → 17.1%</a:t>
+              <a:t>•  Placeable fulfilment 17.3% → 24.9%</a:t>
             </a:r>
           </a:p>
           <a:p>
@@ -19814,6 +19816,4036 @@
 </p:sld>
 </file>
 
+<file path=ppt/slides/slide3.xml><?xml version="1.0" encoding="utf-8"?>
+<p:sld xmlns:a="http://schemas.openxmlformats.org/drawingml/2006/main" xmlns:p="http://schemas.openxmlformats.org/presentationml/2006/main" xmlns:r="http://schemas.openxmlformats.org/officeDocument/2006/relationships">
+  <p:cSld>
+    <p:spTree>
+      <p:nvGrpSpPr>
+        <p:cNvPr id="1" name=""/>
+        <p:cNvGrpSpPr/>
+        <p:nvPr/>
+      </p:nvGrpSpPr>
+      <p:grpSpPr/>
+      <p:sp>
+        <p:nvSpPr>
+          <p:cNvPr id="2" name="TextBox 1"/>
+          <p:cNvSpPr txBox="1"/>
+          <p:nvPr/>
+        </p:nvSpPr>
+        <p:spPr>
+          <a:xfrm>
+            <a:off x="228600" y="150000"/>
+            <a:ext cx="7900000" cy="300000"/>
+          </a:xfrm>
+          <a:prstGeom prst="rect">
+            <a:avLst/>
+          </a:prstGeom>
+          <a:noFill/>
+        </p:spPr>
+        <p:txBody>
+          <a:bodyPr wrap="square" anchor="t" lIns="0" rIns="0" tIns="0" bIns="0">
+            <a:spAutoFit/>
+          </a:bodyPr>
+          <a:lstStyle/>
+          <a:p>
+            <a:pPr algn="l">
+              <a:lnSpc>
+                <a:spcPct val="100000"/>
+              </a:lnSpc>
+              <a:spcBef>
+                <a:spcPts val="0"/>
+              </a:spcBef>
+              <a:spcAft>
+                <a:spcPts val="100"/>
+              </a:spcAft>
+            </a:pPr>
+            <a:r>
+              <a:rPr sz="1500" b="1" i="0">
+                <a:solidFill>
+                  <a:srgbClr val="1F3763"/>
+                </a:solidFill>
+                <a:latin typeface="Manrope"/>
+                <a:cs typeface="Manrope"/>
+              </a:rPr>
+              <a:t>Key Challenges — Scaling the Initiatives</a:t>
+            </a:r>
+          </a:p>
+        </p:txBody>
+      </p:sp>
+      <p:sp>
+        <p:nvSpPr>
+          <p:cNvPr id="3" name="TextBox 2"/>
+          <p:cNvSpPr txBox="1"/>
+          <p:nvPr/>
+        </p:nvSpPr>
+        <p:spPr>
+          <a:xfrm>
+            <a:off x="228600" y="458000"/>
+            <a:ext cx="8680000" cy="220000"/>
+          </a:xfrm>
+          <a:prstGeom prst="rect">
+            <a:avLst/>
+          </a:prstGeom>
+          <a:noFill/>
+        </p:spPr>
+        <p:txBody>
+          <a:bodyPr wrap="square" anchor="t" lIns="0" rIns="0" tIns="0" bIns="0">
+            <a:spAutoFit/>
+          </a:bodyPr>
+          <a:lstStyle/>
+          <a:p>
+            <a:pPr algn="l">
+              <a:lnSpc>
+                <a:spcPct val="100000"/>
+              </a:lnSpc>
+              <a:spcBef>
+                <a:spcPts val="0"/>
+              </a:spcBef>
+              <a:spcAft>
+                <a:spcPts val="200"/>
+              </a:spcAft>
+            </a:pPr>
+            <a:r>
+              <a:rPr sz="900" b="0" i="1">
+                <a:solidFill>
+                  <a:srgbClr val="6B7480"/>
+                </a:solidFill>
+                <a:latin typeface="Manrope"/>
+                <a:cs typeface="Manrope"/>
+              </a:rPr>
+              <a:t>System-generated supply is actioned last — CRM inventory, FO App bids &amp; bot demands need priority &amp; SLA decisions from leadership</a:t>
+            </a:r>
+          </a:p>
+        </p:txBody>
+      </p:sp>
+      <p:cxnSp>
+        <p:nvCxnSpPr>
+          <p:cNvPr id="4" name="Connector 3"/>
+          <p:cNvCxnSpPr/>
+          <p:nvPr/>
+        </p:nvCxnSpPr>
+        <p:spPr>
+          <a:xfrm>
+            <a:off x="242398" y="662000"/>
+            <a:ext cx="8616600" cy="0"/>
+          </a:xfrm>
+          <a:prstGeom prst="line">
+            <a:avLst/>
+          </a:prstGeom>
+          <a:ln w="12700">
+            <a:solidFill>
+              <a:srgbClr val="D5DAE1"/>
+            </a:solidFill>
+          </a:ln>
+          <a:effectLst/>
+        </p:spPr>
+        <p:style>
+          <a:lnRef idx="2">
+            <a:schemeClr val="accent1"/>
+          </a:lnRef>
+          <a:fillRef idx="0">
+            <a:schemeClr val="accent1"/>
+          </a:fillRef>
+          <a:effectRef idx="1">
+            <a:schemeClr val="accent1"/>
+          </a:effectRef>
+          <a:fontRef idx="minor">
+            <a:schemeClr val="tx1"/>
+          </a:fontRef>
+        </p:style>
+      </p:cxnSp>
+      <p:pic>
+        <p:nvPicPr>
+          <p:cNvPr id="5" name="Picture 4" descr="image.png"/>
+          <p:cNvPicPr>
+            <a:picLocks noChangeAspect="1"/>
+          </p:cNvPicPr>
+          <p:nvPr/>
+        </p:nvPicPr>
+        <p:blipFill>
+          <a:blip r:embed="rId2"/>
+          <a:stretch>
+            <a:fillRect/>
+          </a:stretch>
+        </p:blipFill>
+        <p:spPr>
+          <a:xfrm>
+            <a:off x="8247328" y="65382"/>
+            <a:ext cx="821475" cy="355725"/>
+          </a:xfrm>
+          <a:prstGeom prst="rect">
+            <a:avLst/>
+          </a:prstGeom>
+        </p:spPr>
+      </p:pic>
+      <p:sp>
+        <p:nvSpPr>
+          <p:cNvPr id="6" name="TextBox 5"/>
+          <p:cNvSpPr txBox="1"/>
+          <p:nvPr/>
+        </p:nvSpPr>
+        <p:spPr>
+          <a:xfrm>
+            <a:off x="7182075" y="4905000"/>
+            <a:ext cx="1652700" cy="180000"/>
+          </a:xfrm>
+          <a:prstGeom prst="rect">
+            <a:avLst/>
+          </a:prstGeom>
+          <a:noFill/>
+        </p:spPr>
+        <p:txBody>
+          <a:bodyPr wrap="square" anchor="t" lIns="0" rIns="0" tIns="0" bIns="0">
+            <a:spAutoFit/>
+          </a:bodyPr>
+          <a:lstStyle/>
+          <a:p>
+            <a:pPr algn="r">
+              <a:lnSpc>
+                <a:spcPct val="100000"/>
+              </a:lnSpc>
+              <a:spcBef>
+                <a:spcPts val="0"/>
+              </a:spcBef>
+              <a:spcAft>
+                <a:spcPts val="200"/>
+              </a:spcAft>
+            </a:pPr>
+            <a:r>
+              <a:rPr sz="800" b="0" i="0">
+                <a:solidFill>
+                  <a:srgbClr val="B8BEC6"/>
+                </a:solidFill>
+                <a:latin typeface="Manrope"/>
+                <a:cs typeface="Manrope"/>
+              </a:rPr>
+              <a:t>@FreightTiger confidential</a:t>
+            </a:r>
+          </a:p>
+        </p:txBody>
+      </p:sp>
+      <p:sp>
+        <p:nvSpPr>
+          <p:cNvPr id="7" name="Rounded Rectangle 6"/>
+          <p:cNvSpPr/>
+          <p:nvPr/>
+        </p:nvSpPr>
+        <p:spPr>
+          <a:xfrm>
+            <a:off x="228600" y="706000"/>
+            <a:ext cx="1726000" cy="286000"/>
+          </a:xfrm>
+          <a:prstGeom prst="roundRect">
+            <a:avLst>
+              <a:gd name="adj" fmla="val 9000"/>
+            </a:avLst>
+          </a:prstGeom>
+          <a:solidFill>
+            <a:srgbClr val="1F3763"/>
+          </a:solidFill>
+          <a:ln>
+            <a:noFill/>
+          </a:ln>
+          <a:effectLst/>
+        </p:spPr>
+        <p:style>
+          <a:lnRef idx="1">
+            <a:schemeClr val="accent1"/>
+          </a:lnRef>
+          <a:fillRef idx="3">
+            <a:schemeClr val="accent1"/>
+          </a:fillRef>
+          <a:effectRef idx="2">
+            <a:schemeClr val="accent1"/>
+          </a:effectRef>
+          <a:fontRef idx="minor">
+            <a:schemeClr val="lt1"/>
+          </a:fontRef>
+        </p:style>
+        <p:txBody>
+          <a:bodyPr rtlCol="0" anchor="ctr"/>
+          <a:lstStyle/>
+          <a:p>
+            <a:pPr algn="ctr"/>
+          </a:p>
+        </p:txBody>
+      </p:sp>
+      <p:sp>
+        <p:nvSpPr>
+          <p:cNvPr id="8" name="TextBox 7"/>
+          <p:cNvSpPr txBox="1"/>
+          <p:nvPr/>
+        </p:nvSpPr>
+        <p:spPr>
+          <a:xfrm>
+            <a:off x="274600" y="706000"/>
+            <a:ext cx="1680000" cy="286000"/>
+          </a:xfrm>
+          <a:prstGeom prst="rect">
+            <a:avLst/>
+          </a:prstGeom>
+          <a:noFill/>
+        </p:spPr>
+        <p:txBody>
+          <a:bodyPr wrap="square" anchor="ctr" lIns="0" rIns="0" tIns="0" bIns="0">
+            <a:spAutoFit/>
+          </a:bodyPr>
+          <a:lstStyle/>
+          <a:p>
+            <a:pPr algn="l">
+              <a:lnSpc>
+                <a:spcPct val="100000"/>
+              </a:lnSpc>
+              <a:spcBef>
+                <a:spcPts val="0"/>
+              </a:spcBef>
+              <a:spcAft>
+                <a:spcPts val="0"/>
+              </a:spcAft>
+            </a:pPr>
+            <a:r>
+              <a:rPr sz="950" b="1" i="0">
+                <a:solidFill>
+                  <a:srgbClr val="FFFFFF"/>
+                </a:solidFill>
+                <a:latin typeface="Manrope"/>
+                <a:cs typeface="Manrope"/>
+              </a:rPr>
+              <a:t>CHALLENGE</a:t>
+            </a:r>
+          </a:p>
+        </p:txBody>
+      </p:sp>
+      <p:sp>
+        <p:nvSpPr>
+          <p:cNvPr id="9" name="Rounded Rectangle 8"/>
+          <p:cNvSpPr/>
+          <p:nvPr/>
+        </p:nvSpPr>
+        <p:spPr>
+          <a:xfrm>
+            <a:off x="1978600" y="706000"/>
+            <a:ext cx="3836000" cy="286000"/>
+          </a:xfrm>
+          <a:prstGeom prst="roundRect">
+            <a:avLst>
+              <a:gd name="adj" fmla="val 9000"/>
+            </a:avLst>
+          </a:prstGeom>
+          <a:solidFill>
+            <a:srgbClr val="3E4C63"/>
+          </a:solidFill>
+          <a:ln>
+            <a:noFill/>
+          </a:ln>
+          <a:effectLst/>
+        </p:spPr>
+        <p:style>
+          <a:lnRef idx="1">
+            <a:schemeClr val="accent1"/>
+          </a:lnRef>
+          <a:fillRef idx="3">
+            <a:schemeClr val="accent1"/>
+          </a:fillRef>
+          <a:effectRef idx="2">
+            <a:schemeClr val="accent1"/>
+          </a:effectRef>
+          <a:fontRef idx="minor">
+            <a:schemeClr val="lt1"/>
+          </a:fontRef>
+        </p:style>
+        <p:txBody>
+          <a:bodyPr rtlCol="0" anchor="ctr"/>
+          <a:lstStyle/>
+          <a:p>
+            <a:pPr algn="ctr"/>
+          </a:p>
+        </p:txBody>
+      </p:sp>
+      <p:sp>
+        <p:nvSpPr>
+          <p:cNvPr id="10" name="TextBox 9"/>
+          <p:cNvSpPr txBox="1"/>
+          <p:nvPr/>
+        </p:nvSpPr>
+        <p:spPr>
+          <a:xfrm>
+            <a:off x="2024600" y="706000"/>
+            <a:ext cx="3790000" cy="286000"/>
+          </a:xfrm>
+          <a:prstGeom prst="rect">
+            <a:avLst/>
+          </a:prstGeom>
+          <a:noFill/>
+        </p:spPr>
+        <p:txBody>
+          <a:bodyPr wrap="square" anchor="ctr" lIns="0" rIns="0" tIns="0" bIns="0">
+            <a:spAutoFit/>
+          </a:bodyPr>
+          <a:lstStyle/>
+          <a:p>
+            <a:pPr algn="l">
+              <a:lnSpc>
+                <a:spcPct val="100000"/>
+              </a:lnSpc>
+              <a:spcBef>
+                <a:spcPts val="0"/>
+              </a:spcBef>
+              <a:spcAft>
+                <a:spcPts val="0"/>
+              </a:spcAft>
+            </a:pPr>
+            <a:r>
+              <a:rPr sz="950" b="1" i="0">
+                <a:solidFill>
+                  <a:srgbClr val="FFFFFF"/>
+                </a:solidFill>
+                <a:latin typeface="Manrope"/>
+                <a:cs typeface="Manrope"/>
+              </a:rPr>
+              <a:t>CONTEXT</a:t>
+            </a:r>
+          </a:p>
+        </p:txBody>
+      </p:sp>
+      <p:sp>
+        <p:nvSpPr>
+          <p:cNvPr id="11" name="Rounded Rectangle 10"/>
+          <p:cNvSpPr/>
+          <p:nvPr/>
+        </p:nvSpPr>
+        <p:spPr>
+          <a:xfrm>
+            <a:off x="5838600" y="706000"/>
+            <a:ext cx="3052800" cy="286000"/>
+          </a:xfrm>
+          <a:prstGeom prst="roundRect">
+            <a:avLst>
+              <a:gd name="adj" fmla="val 9000"/>
+            </a:avLst>
+          </a:prstGeom>
+          <a:solidFill>
+            <a:srgbClr val="6043A3"/>
+          </a:solidFill>
+          <a:ln>
+            <a:noFill/>
+          </a:ln>
+          <a:effectLst/>
+        </p:spPr>
+        <p:style>
+          <a:lnRef idx="1">
+            <a:schemeClr val="accent1"/>
+          </a:lnRef>
+          <a:fillRef idx="3">
+            <a:schemeClr val="accent1"/>
+          </a:fillRef>
+          <a:effectRef idx="2">
+            <a:schemeClr val="accent1"/>
+          </a:effectRef>
+          <a:fontRef idx="minor">
+            <a:schemeClr val="lt1"/>
+          </a:fontRef>
+        </p:style>
+        <p:txBody>
+          <a:bodyPr rtlCol="0" anchor="ctr"/>
+          <a:lstStyle/>
+          <a:p>
+            <a:pPr algn="ctr"/>
+          </a:p>
+        </p:txBody>
+      </p:sp>
+      <p:sp>
+        <p:nvSpPr>
+          <p:cNvPr id="12" name="TextBox 11"/>
+          <p:cNvSpPr txBox="1"/>
+          <p:nvPr/>
+        </p:nvSpPr>
+        <p:spPr>
+          <a:xfrm>
+            <a:off x="5884600" y="706000"/>
+            <a:ext cx="3006800" cy="286000"/>
+          </a:xfrm>
+          <a:prstGeom prst="rect">
+            <a:avLst/>
+          </a:prstGeom>
+          <a:noFill/>
+        </p:spPr>
+        <p:txBody>
+          <a:bodyPr wrap="square" anchor="ctr" lIns="0" rIns="0" tIns="0" bIns="0">
+            <a:spAutoFit/>
+          </a:bodyPr>
+          <a:lstStyle/>
+          <a:p>
+            <a:pPr algn="l">
+              <a:lnSpc>
+                <a:spcPct val="100000"/>
+              </a:lnSpc>
+              <a:spcBef>
+                <a:spcPts val="0"/>
+              </a:spcBef>
+              <a:spcAft>
+                <a:spcPts val="0"/>
+              </a:spcAft>
+            </a:pPr>
+            <a:r>
+              <a:rPr sz="950" b="1" i="0">
+                <a:solidFill>
+                  <a:srgbClr val="FFFFFF"/>
+                </a:solidFill>
+                <a:latin typeface="Manrope"/>
+                <a:cs typeface="Manrope"/>
+              </a:rPr>
+              <a:t>KEY QUESTIONS FOR LEADERSHIP</a:t>
+            </a:r>
+          </a:p>
+        </p:txBody>
+      </p:sp>
+      <p:sp>
+        <p:nvSpPr>
+          <p:cNvPr id="13" name="Rounded Rectangle 12"/>
+          <p:cNvSpPr/>
+          <p:nvPr/>
+        </p:nvSpPr>
+        <p:spPr>
+          <a:xfrm>
+            <a:off x="228600" y="1040000"/>
+            <a:ext cx="8686800" cy="1225000"/>
+          </a:xfrm>
+          <a:prstGeom prst="roundRect">
+            <a:avLst>
+              <a:gd name="adj" fmla="val 9000"/>
+            </a:avLst>
+          </a:prstGeom>
+          <a:solidFill>
+            <a:srgbClr val="F4F6F9"/>
+          </a:solidFill>
+          <a:ln>
+            <a:noFill/>
+          </a:ln>
+          <a:effectLst/>
+        </p:spPr>
+        <p:style>
+          <a:lnRef idx="1">
+            <a:schemeClr val="accent1"/>
+          </a:lnRef>
+          <a:fillRef idx="3">
+            <a:schemeClr val="accent1"/>
+          </a:fillRef>
+          <a:effectRef idx="2">
+            <a:schemeClr val="accent1"/>
+          </a:effectRef>
+          <a:fontRef idx="minor">
+            <a:schemeClr val="lt1"/>
+          </a:fontRef>
+        </p:style>
+        <p:txBody>
+          <a:bodyPr rtlCol="0" anchor="ctr"/>
+          <a:lstStyle/>
+          <a:p>
+            <a:pPr algn="ctr"/>
+          </a:p>
+        </p:txBody>
+      </p:sp>
+      <p:sp>
+        <p:nvSpPr>
+          <p:cNvPr id="14" name="TextBox 13"/>
+          <p:cNvSpPr txBox="1"/>
+          <p:nvPr/>
+        </p:nvSpPr>
+        <p:spPr>
+          <a:xfrm>
+            <a:off x="288600" y="1080000"/>
+            <a:ext cx="1650000" cy="1155000"/>
+          </a:xfrm>
+          <a:prstGeom prst="rect">
+            <a:avLst/>
+          </a:prstGeom>
+          <a:noFill/>
+        </p:spPr>
+        <p:txBody>
+          <a:bodyPr wrap="square" anchor="ctr" lIns="0" rIns="0" tIns="0" bIns="0">
+            <a:spAutoFit/>
+          </a:bodyPr>
+          <a:lstStyle/>
+          <a:p>
+            <a:pPr algn="l">
+              <a:lnSpc>
+                <a:spcPct val="102000"/>
+              </a:lnSpc>
+              <a:spcBef>
+                <a:spcPts val="0"/>
+              </a:spcBef>
+              <a:spcAft>
+                <a:spcPts val="400"/>
+              </a:spcAft>
+            </a:pPr>
+            <a:r>
+              <a:rPr sz="1600" b="1" i="0">
+                <a:solidFill>
+                  <a:srgbClr val="1F3763"/>
+                </a:solidFill>
+                <a:latin typeface="Manrope"/>
+                <a:cs typeface="Manrope"/>
+              </a:rPr>
+              <a:t>1   </a:t>
+            </a:r>
+            <a:r>
+              <a:rPr sz="1000" b="1" i="0">
+                <a:solidFill>
+                  <a:srgbClr val="1F3763"/>
+                </a:solidFill>
+                <a:latin typeface="Manrope"/>
+                <a:cs typeface="Manrope"/>
+              </a:rPr>
+              <a:t>CRM inventory prioritisation</a:t>
+            </a:r>
+          </a:p>
+          <a:p>
+            <a:pPr algn="l">
+              <a:lnSpc>
+                <a:spcPct val="102000"/>
+              </a:lnSpc>
+              <a:spcBef>
+                <a:spcPts val="0"/>
+              </a:spcBef>
+              <a:spcAft>
+                <a:spcPts val="0"/>
+              </a:spcAft>
+            </a:pPr>
+            <a:r>
+              <a:rPr sz="800" b="0" i="1">
+                <a:solidFill>
+                  <a:srgbClr val="6B7480"/>
+                </a:solidFill>
+                <a:latin typeface="Manrope"/>
+                <a:cs typeface="Manrope"/>
+              </a:rPr>
+              <a:t>How should CRM-generated inventory be prioritised?</a:t>
+            </a:r>
+          </a:p>
+        </p:txBody>
+      </p:sp>
+      <p:sp>
+        <p:nvSpPr>
+          <p:cNvPr id="15" name="TextBox 14"/>
+          <p:cNvSpPr txBox="1"/>
+          <p:nvPr/>
+        </p:nvSpPr>
+        <p:spPr>
+          <a:xfrm>
+            <a:off x="2042600" y="1074000"/>
+            <a:ext cx="3740000" cy="1165000"/>
+          </a:xfrm>
+          <a:prstGeom prst="rect">
+            <a:avLst/>
+          </a:prstGeom>
+          <a:noFill/>
+        </p:spPr>
+        <p:txBody>
+          <a:bodyPr wrap="square" anchor="ctr" lIns="0" rIns="0" tIns="0" bIns="0">
+            <a:spAutoFit/>
+          </a:bodyPr>
+          <a:lstStyle/>
+          <a:p>
+            <a:pPr algn="l">
+              <a:lnSpc>
+                <a:spcPct val="108000"/>
+              </a:lnSpc>
+              <a:spcBef>
+                <a:spcPts val="0"/>
+              </a:spcBef>
+              <a:spcAft>
+                <a:spcPts val="0"/>
+              </a:spcAft>
+            </a:pPr>
+            <a:r>
+              <a:rPr sz="840" b="0" i="0">
+                <a:solidFill>
+                  <a:srgbClr val="25303B"/>
+                </a:solidFill>
+                <a:latin typeface="Manrope"/>
+                <a:cs typeface="Manrope"/>
+              </a:rPr>
+              <a:t>~1,300 CRM inventories/month (incl. ~800 Power-Lane), but conversions stay under 50/month. The fulfilment team clears its own + central-team inventory first; by the time it reaches system-generated CRM inventory, the load is usually already placed externally (CRM inventory is collected in the morning).</a:t>
+            </a:r>
+          </a:p>
+        </p:txBody>
+      </p:sp>
+      <p:sp>
+        <p:nvSpPr>
+          <p:cNvPr id="16" name="TextBox 15"/>
+          <p:cNvSpPr txBox="1"/>
+          <p:nvPr/>
+        </p:nvSpPr>
+        <p:spPr>
+          <a:xfrm>
+            <a:off x="5902600" y="1074000"/>
+            <a:ext cx="2966800" cy="1165000"/>
+          </a:xfrm>
+          <a:prstGeom prst="rect">
+            <a:avLst/>
+          </a:prstGeom>
+          <a:noFill/>
+        </p:spPr>
+        <p:txBody>
+          <a:bodyPr wrap="square" anchor="ctr" lIns="0" rIns="0" tIns="0" bIns="0">
+            <a:spAutoFit/>
+          </a:bodyPr>
+          <a:lstStyle/>
+          <a:p>
+            <a:pPr algn="l" indent="-150000" marL="150000">
+              <a:lnSpc>
+                <a:spcPct val="106000"/>
+              </a:lnSpc>
+              <a:spcBef>
+                <a:spcPts val="0"/>
+              </a:spcBef>
+              <a:spcAft>
+                <a:spcPts val="600"/>
+              </a:spcAft>
+            </a:pPr>
+            <a:r>
+              <a:rPr sz="860" b="1" i="0">
+                <a:solidFill>
+                  <a:srgbClr val="6043A3"/>
+                </a:solidFill>
+                <a:latin typeface="Manrope"/>
+                <a:cs typeface="Manrope"/>
+              </a:rPr>
+              <a:t>›  </a:t>
+            </a:r>
+            <a:r>
+              <a:rPr sz="840" b="0" i="0">
+                <a:solidFill>
+                  <a:srgbClr val="25303B"/>
+                </a:solidFill>
+                <a:latin typeface="Manrope"/>
+                <a:cs typeface="Manrope"/>
+              </a:rPr>
+              <a:t>Should CRM inventory get equal priority in the workflow, not the last source?</a:t>
+            </a:r>
+          </a:p>
+          <a:p>
+            <a:pPr algn="l" indent="-150000" marL="150000">
+              <a:lnSpc>
+                <a:spcPct val="106000"/>
+              </a:lnSpc>
+              <a:spcBef>
+                <a:spcPts val="0"/>
+              </a:spcBef>
+              <a:spcAft>
+                <a:spcPts val="600"/>
+              </a:spcAft>
+            </a:pPr>
+            <a:r>
+              <a:rPr sz="860" b="1" i="0">
+                <a:solidFill>
+                  <a:srgbClr val="6043A3"/>
+                </a:solidFill>
+                <a:latin typeface="Manrope"/>
+                <a:cs typeface="Manrope"/>
+              </a:rPr>
+              <a:t>›  </a:t>
+            </a:r>
+            <a:r>
+              <a:rPr sz="840" b="0" i="0">
+                <a:solidFill>
+                  <a:srgbClr val="25303B"/>
+                </a:solidFill>
+                <a:latin typeface="Manrope"/>
+                <a:cs typeface="Manrope"/>
+              </a:rPr>
+              <a:t>What SLA / process ensures it is actioned before the demand is fulfilled elsewhere?</a:t>
+            </a:r>
+          </a:p>
+        </p:txBody>
+      </p:sp>
+      <p:sp>
+        <p:nvSpPr>
+          <p:cNvPr id="17" name="Rounded Rectangle 16"/>
+          <p:cNvSpPr/>
+          <p:nvPr/>
+        </p:nvSpPr>
+        <p:spPr>
+          <a:xfrm>
+            <a:off x="228600" y="2287000"/>
+            <a:ext cx="8686800" cy="1225000"/>
+          </a:xfrm>
+          <a:prstGeom prst="roundRect">
+            <a:avLst>
+              <a:gd name="adj" fmla="val 9000"/>
+            </a:avLst>
+          </a:prstGeom>
+          <a:solidFill>
+            <a:srgbClr val="FFFFFF"/>
+          </a:solidFill>
+          <a:ln>
+            <a:noFill/>
+          </a:ln>
+          <a:effectLst/>
+        </p:spPr>
+        <p:style>
+          <a:lnRef idx="1">
+            <a:schemeClr val="accent1"/>
+          </a:lnRef>
+          <a:fillRef idx="3">
+            <a:schemeClr val="accent1"/>
+          </a:fillRef>
+          <a:effectRef idx="2">
+            <a:schemeClr val="accent1"/>
+          </a:effectRef>
+          <a:fontRef idx="minor">
+            <a:schemeClr val="lt1"/>
+          </a:fontRef>
+        </p:style>
+        <p:txBody>
+          <a:bodyPr rtlCol="0" anchor="ctr"/>
+          <a:lstStyle/>
+          <a:p>
+            <a:pPr algn="ctr"/>
+          </a:p>
+        </p:txBody>
+      </p:sp>
+      <p:sp>
+        <p:nvSpPr>
+          <p:cNvPr id="18" name="TextBox 17"/>
+          <p:cNvSpPr txBox="1"/>
+          <p:nvPr/>
+        </p:nvSpPr>
+        <p:spPr>
+          <a:xfrm>
+            <a:off x="288600" y="2327000"/>
+            <a:ext cx="1650000" cy="1155000"/>
+          </a:xfrm>
+          <a:prstGeom prst="rect">
+            <a:avLst/>
+          </a:prstGeom>
+          <a:noFill/>
+        </p:spPr>
+        <p:txBody>
+          <a:bodyPr wrap="square" anchor="ctr" lIns="0" rIns="0" tIns="0" bIns="0">
+            <a:spAutoFit/>
+          </a:bodyPr>
+          <a:lstStyle/>
+          <a:p>
+            <a:pPr algn="l">
+              <a:lnSpc>
+                <a:spcPct val="102000"/>
+              </a:lnSpc>
+              <a:spcBef>
+                <a:spcPts val="0"/>
+              </a:spcBef>
+              <a:spcAft>
+                <a:spcPts val="400"/>
+              </a:spcAft>
+            </a:pPr>
+            <a:r>
+              <a:rPr sz="1600" b="1" i="0">
+                <a:solidFill>
+                  <a:srgbClr val="1F3763"/>
+                </a:solidFill>
+                <a:latin typeface="Manrope"/>
+                <a:cs typeface="Manrope"/>
+              </a:rPr>
+              <a:t>2   </a:t>
+            </a:r>
+            <a:r>
+              <a:rPr sz="1000" b="1" i="0">
+                <a:solidFill>
+                  <a:srgbClr val="1F3763"/>
+                </a:solidFill>
+                <a:latin typeface="Manrope"/>
+                <a:cs typeface="Manrope"/>
+              </a:rPr>
+              <a:t>FO App bids not acted upon</a:t>
+            </a:r>
+          </a:p>
+          <a:p>
+            <a:pPr algn="l">
+              <a:lnSpc>
+                <a:spcPct val="102000"/>
+              </a:lnSpc>
+              <a:spcBef>
+                <a:spcPts val="0"/>
+              </a:spcBef>
+              <a:spcAft>
+                <a:spcPts val="0"/>
+              </a:spcAft>
+            </a:pPr>
+            <a:r>
+              <a:rPr sz="800" b="0" i="1">
+                <a:solidFill>
+                  <a:srgbClr val="6B7480"/>
+                </a:solidFill>
+                <a:latin typeface="Manrope"/>
+                <a:cs typeface="Manrope"/>
+              </a:rPr>
+              <a:t>Why are FO App bids not being acted upon?</a:t>
+            </a:r>
+          </a:p>
+        </p:txBody>
+      </p:sp>
+      <p:sp>
+        <p:nvSpPr>
+          <p:cNvPr id="19" name="TextBox 18"/>
+          <p:cNvSpPr txBox="1"/>
+          <p:nvPr/>
+        </p:nvSpPr>
+        <p:spPr>
+          <a:xfrm>
+            <a:off x="2042600" y="2321000"/>
+            <a:ext cx="3740000" cy="1165000"/>
+          </a:xfrm>
+          <a:prstGeom prst="rect">
+            <a:avLst/>
+          </a:prstGeom>
+          <a:noFill/>
+        </p:spPr>
+        <p:txBody>
+          <a:bodyPr wrap="square" anchor="ctr" lIns="0" rIns="0" tIns="0" bIns="0">
+            <a:spAutoFit/>
+          </a:bodyPr>
+          <a:lstStyle/>
+          <a:p>
+            <a:pPr algn="l">
+              <a:lnSpc>
+                <a:spcPct val="108000"/>
+              </a:lnSpc>
+              <a:spcBef>
+                <a:spcPts val="0"/>
+              </a:spcBef>
+              <a:spcAft>
+                <a:spcPts val="0"/>
+              </a:spcAft>
+            </a:pPr>
+            <a:r>
+              <a:rPr sz="840" b="0" i="0">
+                <a:solidFill>
+                  <a:srgbClr val="25303B"/>
+                </a:solidFill>
+                <a:latin typeface="Manrope"/>
+                <a:cs typeface="Manrope"/>
+              </a:rPr>
+              <a:t>We receive 30–55 FO App bids/day, but only 1–2 are converted — and 0 conversions in the last week. As with CRM inventory, the team focuses on manual + central inventory first; by the time app bids are reviewed, the demands have often already been fulfilled.</a:t>
+            </a:r>
+          </a:p>
+        </p:txBody>
+      </p:sp>
+      <p:sp>
+        <p:nvSpPr>
+          <p:cNvPr id="20" name="TextBox 19"/>
+          <p:cNvSpPr txBox="1"/>
+          <p:nvPr/>
+        </p:nvSpPr>
+        <p:spPr>
+          <a:xfrm>
+            <a:off x="5902600" y="2321000"/>
+            <a:ext cx="2966800" cy="1165000"/>
+          </a:xfrm>
+          <a:prstGeom prst="rect">
+            <a:avLst/>
+          </a:prstGeom>
+          <a:noFill/>
+        </p:spPr>
+        <p:txBody>
+          <a:bodyPr wrap="square" anchor="ctr" lIns="0" rIns="0" tIns="0" bIns="0">
+            <a:spAutoFit/>
+          </a:bodyPr>
+          <a:lstStyle/>
+          <a:p>
+            <a:pPr algn="l" indent="-150000" marL="150000">
+              <a:lnSpc>
+                <a:spcPct val="106000"/>
+              </a:lnSpc>
+              <a:spcBef>
+                <a:spcPts val="0"/>
+              </a:spcBef>
+              <a:spcAft>
+                <a:spcPts val="600"/>
+              </a:spcAft>
+            </a:pPr>
+            <a:r>
+              <a:rPr sz="860" b="1" i="0">
+                <a:solidFill>
+                  <a:srgbClr val="6043A3"/>
+                </a:solidFill>
+                <a:latin typeface="Manrope"/>
+                <a:cs typeface="Manrope"/>
+              </a:rPr>
+              <a:t>›  </a:t>
+            </a:r>
+            <a:r>
+              <a:rPr sz="840" b="0" i="0">
+                <a:solidFill>
+                  <a:srgbClr val="25303B"/>
+                </a:solidFill>
+                <a:latin typeface="Manrope"/>
+                <a:cs typeface="Manrope"/>
+              </a:rPr>
+              <a:t>Should FO App bids have a defined response SLA / priority, so they are reviewed before demand is fulfilled through other channels?</a:t>
+            </a:r>
+          </a:p>
+        </p:txBody>
+      </p:sp>
+      <p:sp>
+        <p:nvSpPr>
+          <p:cNvPr id="21" name="Rounded Rectangle 20"/>
+          <p:cNvSpPr/>
+          <p:nvPr/>
+        </p:nvSpPr>
+        <p:spPr>
+          <a:xfrm>
+            <a:off x="228600" y="3534000"/>
+            <a:ext cx="8686800" cy="1225000"/>
+          </a:xfrm>
+          <a:prstGeom prst="roundRect">
+            <a:avLst>
+              <a:gd name="adj" fmla="val 9000"/>
+            </a:avLst>
+          </a:prstGeom>
+          <a:solidFill>
+            <a:srgbClr val="F4F6F9"/>
+          </a:solidFill>
+          <a:ln>
+            <a:noFill/>
+          </a:ln>
+          <a:effectLst/>
+        </p:spPr>
+        <p:style>
+          <a:lnRef idx="1">
+            <a:schemeClr val="accent1"/>
+          </a:lnRef>
+          <a:fillRef idx="3">
+            <a:schemeClr val="accent1"/>
+          </a:fillRef>
+          <a:effectRef idx="2">
+            <a:schemeClr val="accent1"/>
+          </a:effectRef>
+          <a:fontRef idx="minor">
+            <a:schemeClr val="lt1"/>
+          </a:fontRef>
+        </p:style>
+        <p:txBody>
+          <a:bodyPr rtlCol="0" anchor="ctr"/>
+          <a:lstStyle/>
+          <a:p>
+            <a:pPr algn="ctr"/>
+          </a:p>
+        </p:txBody>
+      </p:sp>
+      <p:sp>
+        <p:nvSpPr>
+          <p:cNvPr id="22" name="TextBox 21"/>
+          <p:cNvSpPr txBox="1"/>
+          <p:nvPr/>
+        </p:nvSpPr>
+        <p:spPr>
+          <a:xfrm>
+            <a:off x="288600" y="3574000"/>
+            <a:ext cx="1650000" cy="1155000"/>
+          </a:xfrm>
+          <a:prstGeom prst="rect">
+            <a:avLst/>
+          </a:prstGeom>
+          <a:noFill/>
+        </p:spPr>
+        <p:txBody>
+          <a:bodyPr wrap="square" anchor="ctr" lIns="0" rIns="0" tIns="0" bIns="0">
+            <a:spAutoFit/>
+          </a:bodyPr>
+          <a:lstStyle/>
+          <a:p>
+            <a:pPr algn="l">
+              <a:lnSpc>
+                <a:spcPct val="102000"/>
+              </a:lnSpc>
+              <a:spcBef>
+                <a:spcPts val="0"/>
+              </a:spcBef>
+              <a:spcAft>
+                <a:spcPts val="400"/>
+              </a:spcAft>
+            </a:pPr>
+            <a:r>
+              <a:rPr sz="1600" b="1" i="0">
+                <a:solidFill>
+                  <a:srgbClr val="1F3763"/>
+                </a:solidFill>
+                <a:latin typeface="Manrope"/>
+                <a:cs typeface="Manrope"/>
+              </a:rPr>
+              <a:t>3   </a:t>
+            </a:r>
+            <a:r>
+              <a:rPr sz="1000" b="1" i="0">
+                <a:solidFill>
+                  <a:srgbClr val="1F3763"/>
+                </a:solidFill>
+                <a:latin typeface="Manrope"/>
+                <a:cs typeface="Manrope"/>
+              </a:rPr>
+              <a:t>Bot-created demand actionability</a:t>
+            </a:r>
+          </a:p>
+          <a:p>
+            <a:pPr algn="l">
+              <a:lnSpc>
+                <a:spcPct val="102000"/>
+              </a:lnSpc>
+              <a:spcBef>
+                <a:spcPts val="0"/>
+              </a:spcBef>
+              <a:spcAft>
+                <a:spcPts val="0"/>
+              </a:spcAft>
+            </a:pPr>
+            <a:r>
+              <a:rPr sz="800" b="0" i="1">
+                <a:solidFill>
+                  <a:srgbClr val="6B7480"/>
+                </a:solidFill>
+                <a:latin typeface="Manrope"/>
+                <a:cs typeface="Manrope"/>
+              </a:rPr>
+              <a:t>Why is there low actionability on bot-created demands?</a:t>
+            </a:r>
+          </a:p>
+        </p:txBody>
+      </p:sp>
+      <p:sp>
+        <p:nvSpPr>
+          <p:cNvPr id="23" name="TextBox 22"/>
+          <p:cNvSpPr txBox="1"/>
+          <p:nvPr/>
+        </p:nvSpPr>
+        <p:spPr>
+          <a:xfrm>
+            <a:off x="2042600" y="3568000"/>
+            <a:ext cx="3740000" cy="1165000"/>
+          </a:xfrm>
+          <a:prstGeom prst="rect">
+            <a:avLst/>
+          </a:prstGeom>
+          <a:noFill/>
+        </p:spPr>
+        <p:txBody>
+          <a:bodyPr wrap="square" anchor="ctr" lIns="0" rIns="0" tIns="0" bIns="0">
+            <a:spAutoFit/>
+          </a:bodyPr>
+          <a:lstStyle/>
+          <a:p>
+            <a:pPr algn="l">
+              <a:lnSpc>
+                <a:spcPct val="108000"/>
+              </a:lnSpc>
+              <a:spcBef>
+                <a:spcPts val="0"/>
+              </a:spcBef>
+              <a:spcAft>
+                <a:spcPts val="0"/>
+              </a:spcAft>
+            </a:pPr>
+            <a:r>
+              <a:rPr sz="840" b="0" i="0">
+                <a:solidFill>
+                  <a:srgbClr val="25303B"/>
+                </a:solidFill>
+                <a:latin typeface="Manrope"/>
+                <a:cs typeface="Manrope"/>
+              </a:rPr>
+              <a:t>On power lanes, manually-created demands convert at 18% vs only 3% for bot-created demands. Bot-created demand is clearly not getting priority, while the team continues to focus on manually-created demands.</a:t>
+            </a:r>
+          </a:p>
+        </p:txBody>
+      </p:sp>
+      <p:sp>
+        <p:nvSpPr>
+          <p:cNvPr id="24" name="TextBox 23"/>
+          <p:cNvSpPr txBox="1"/>
+          <p:nvPr/>
+        </p:nvSpPr>
+        <p:spPr>
+          <a:xfrm>
+            <a:off x="5902600" y="3568000"/>
+            <a:ext cx="2966800" cy="1165000"/>
+          </a:xfrm>
+          <a:prstGeom prst="rect">
+            <a:avLst/>
+          </a:prstGeom>
+          <a:noFill/>
+        </p:spPr>
+        <p:txBody>
+          <a:bodyPr wrap="square" anchor="ctr" lIns="0" rIns="0" tIns="0" bIns="0">
+            <a:spAutoFit/>
+          </a:bodyPr>
+          <a:lstStyle/>
+          <a:p>
+            <a:pPr algn="l" indent="-150000" marL="150000">
+              <a:lnSpc>
+                <a:spcPct val="106000"/>
+              </a:lnSpc>
+              <a:spcBef>
+                <a:spcPts val="0"/>
+              </a:spcBef>
+              <a:spcAft>
+                <a:spcPts val="600"/>
+              </a:spcAft>
+            </a:pPr>
+            <a:r>
+              <a:rPr sz="860" b="1" i="0">
+                <a:solidFill>
+                  <a:srgbClr val="6043A3"/>
+                </a:solidFill>
+                <a:latin typeface="Manrope"/>
+                <a:cs typeface="Manrope"/>
+              </a:rPr>
+              <a:t>›  </a:t>
+            </a:r>
+            <a:r>
+              <a:rPr sz="840" b="0" i="0">
+                <a:solidFill>
+                  <a:srgbClr val="25303B"/>
+                </a:solidFill>
+                <a:latin typeface="Manrope"/>
+                <a:cs typeface="Manrope"/>
+              </a:rPr>
+              <a:t>Should bot-created demands sit in the primary fulfilment queue, not a secondary source?</a:t>
+            </a:r>
+          </a:p>
+          <a:p>
+            <a:pPr algn="l" indent="-150000" marL="150000">
+              <a:lnSpc>
+                <a:spcPct val="106000"/>
+              </a:lnSpc>
+              <a:spcBef>
+                <a:spcPts val="0"/>
+              </a:spcBef>
+              <a:spcAft>
+                <a:spcPts val="600"/>
+              </a:spcAft>
+            </a:pPr>
+            <a:r>
+              <a:rPr sz="860" b="1" i="0">
+                <a:solidFill>
+                  <a:srgbClr val="6043A3"/>
+                </a:solidFill>
+                <a:latin typeface="Manrope"/>
+                <a:cs typeface="Manrope"/>
+              </a:rPr>
+              <a:t>›  </a:t>
+            </a:r>
+            <a:r>
+              <a:rPr sz="840" b="0" i="0">
+                <a:solidFill>
+                  <a:srgbClr val="25303B"/>
+                </a:solidFill>
+                <a:latin typeface="Manrope"/>
+                <a:cs typeface="Manrope"/>
+              </a:rPr>
+              <a:t>What business-process changes ensure bot demands are acted on before they go stale?</a:t>
+            </a:r>
+          </a:p>
+        </p:txBody>
+      </p:sp>
+    </p:spTree>
+  </p:cSld>
+  <p:clrMapOvr>
+    <a:masterClrMapping/>
+  </p:clrMapOvr>
+</p:sld>
+</file>
+
+<file path=ppt/slides/slide4.xml><?xml version="1.0" encoding="utf-8"?>
+<p:sld xmlns:a="http://schemas.openxmlformats.org/drawingml/2006/main" xmlns:p="http://schemas.openxmlformats.org/presentationml/2006/main" xmlns:r="http://schemas.openxmlformats.org/officeDocument/2006/relationships">
+  <p:cSld>
+    <p:spTree>
+      <p:nvGrpSpPr>
+        <p:cNvPr id="1" name=""/>
+        <p:cNvGrpSpPr/>
+        <p:nvPr/>
+      </p:nvGrpSpPr>
+      <p:grpSpPr/>
+      <p:sp>
+        <p:nvSpPr>
+          <p:cNvPr id="2" name="TextBox 1"/>
+          <p:cNvSpPr txBox="1"/>
+          <p:nvPr/>
+        </p:nvSpPr>
+        <p:spPr>
+          <a:xfrm>
+            <a:off x="228600" y="150000"/>
+            <a:ext cx="7900000" cy="300000"/>
+          </a:xfrm>
+          <a:prstGeom prst="rect">
+            <a:avLst/>
+          </a:prstGeom>
+          <a:noFill/>
+        </p:spPr>
+        <p:txBody>
+          <a:bodyPr wrap="square" anchor="t" lIns="0" rIns="0" tIns="0" bIns="0">
+            <a:spAutoFit/>
+          </a:bodyPr>
+          <a:lstStyle/>
+          <a:p>
+            <a:pPr algn="l">
+              <a:lnSpc>
+                <a:spcPct val="100000"/>
+              </a:lnSpc>
+              <a:spcBef>
+                <a:spcPts val="0"/>
+              </a:spcBef>
+              <a:spcAft>
+                <a:spcPts val="100"/>
+              </a:spcAft>
+            </a:pPr>
+            <a:r>
+              <a:rPr sz="1500" b="1" i="0">
+                <a:solidFill>
+                  <a:srgbClr val="1F3763"/>
+                </a:solidFill>
+                <a:latin typeface="Manrope"/>
+                <a:cs typeface="Manrope"/>
+              </a:rPr>
+              <a:t>3-Month Execution Plan — Carrier Matching</a:t>
+            </a:r>
+          </a:p>
+        </p:txBody>
+      </p:sp>
+      <p:sp>
+        <p:nvSpPr>
+          <p:cNvPr id="3" name="TextBox 2"/>
+          <p:cNvSpPr txBox="1"/>
+          <p:nvPr/>
+        </p:nvSpPr>
+        <p:spPr>
+          <a:xfrm>
+            <a:off x="228600" y="458000"/>
+            <a:ext cx="8680000" cy="220000"/>
+          </a:xfrm>
+          <a:prstGeom prst="rect">
+            <a:avLst/>
+          </a:prstGeom>
+          <a:noFill/>
+        </p:spPr>
+        <p:txBody>
+          <a:bodyPr wrap="square" anchor="t" lIns="0" rIns="0" tIns="0" bIns="0">
+            <a:spAutoFit/>
+          </a:bodyPr>
+          <a:lstStyle/>
+          <a:p>
+            <a:pPr algn="l">
+              <a:lnSpc>
+                <a:spcPct val="100000"/>
+              </a:lnSpc>
+              <a:spcBef>
+                <a:spcPts val="0"/>
+              </a:spcBef>
+              <a:spcAft>
+                <a:spcPts val="200"/>
+              </a:spcAft>
+            </a:pPr>
+            <a:r>
+              <a:rPr sz="900" b="0" i="1">
+                <a:solidFill>
+                  <a:srgbClr val="6B7480"/>
+                </a:solidFill>
+                <a:latin typeface="Manrope"/>
+                <a:cs typeface="Manrope"/>
+              </a:rPr>
+              <a:t>Scale revenue to ₹1.2 Cr/month by Sept · cut cost base 50%    |    Q2 exit: DAU → 500 · conversion → 20% · MS+FinOps −30%   (25% / 50% = FY27)</a:t>
+            </a:r>
+          </a:p>
+        </p:txBody>
+      </p:sp>
+      <p:cxnSp>
+        <p:nvCxnSpPr>
+          <p:cNvPr id="4" name="Connector 3"/>
+          <p:cNvCxnSpPr/>
+          <p:nvPr/>
+        </p:nvCxnSpPr>
+        <p:spPr>
+          <a:xfrm>
+            <a:off x="242398" y="662000"/>
+            <a:ext cx="8616600" cy="0"/>
+          </a:xfrm>
+          <a:prstGeom prst="line">
+            <a:avLst/>
+          </a:prstGeom>
+          <a:ln w="12700">
+            <a:solidFill>
+              <a:srgbClr val="D5DAE1"/>
+            </a:solidFill>
+          </a:ln>
+          <a:effectLst/>
+        </p:spPr>
+        <p:style>
+          <a:lnRef idx="2">
+            <a:schemeClr val="accent1"/>
+          </a:lnRef>
+          <a:fillRef idx="0">
+            <a:schemeClr val="accent1"/>
+          </a:fillRef>
+          <a:effectRef idx="1">
+            <a:schemeClr val="accent1"/>
+          </a:effectRef>
+          <a:fontRef idx="minor">
+            <a:schemeClr val="tx1"/>
+          </a:fontRef>
+        </p:style>
+      </p:cxnSp>
+      <p:pic>
+        <p:nvPicPr>
+          <p:cNvPr id="5" name="Picture 4" descr="image.png"/>
+          <p:cNvPicPr>
+            <a:picLocks noChangeAspect="1"/>
+          </p:cNvPicPr>
+          <p:nvPr/>
+        </p:nvPicPr>
+        <p:blipFill>
+          <a:blip r:embed="rId2"/>
+          <a:stretch>
+            <a:fillRect/>
+          </a:stretch>
+        </p:blipFill>
+        <p:spPr>
+          <a:xfrm>
+            <a:off x="8247328" y="65382"/>
+            <a:ext cx="821475" cy="355725"/>
+          </a:xfrm>
+          <a:prstGeom prst="rect">
+            <a:avLst/>
+          </a:prstGeom>
+        </p:spPr>
+      </p:pic>
+      <p:sp>
+        <p:nvSpPr>
+          <p:cNvPr id="6" name="TextBox 5"/>
+          <p:cNvSpPr txBox="1"/>
+          <p:nvPr/>
+        </p:nvSpPr>
+        <p:spPr>
+          <a:xfrm>
+            <a:off x="7182075" y="4905000"/>
+            <a:ext cx="1652700" cy="180000"/>
+          </a:xfrm>
+          <a:prstGeom prst="rect">
+            <a:avLst/>
+          </a:prstGeom>
+          <a:noFill/>
+        </p:spPr>
+        <p:txBody>
+          <a:bodyPr wrap="square" anchor="t" lIns="0" rIns="0" tIns="0" bIns="0">
+            <a:spAutoFit/>
+          </a:bodyPr>
+          <a:lstStyle/>
+          <a:p>
+            <a:pPr algn="r">
+              <a:lnSpc>
+                <a:spcPct val="100000"/>
+              </a:lnSpc>
+              <a:spcBef>
+                <a:spcPts val="0"/>
+              </a:spcBef>
+              <a:spcAft>
+                <a:spcPts val="200"/>
+              </a:spcAft>
+            </a:pPr>
+            <a:r>
+              <a:rPr sz="800" b="0" i="0">
+                <a:solidFill>
+                  <a:srgbClr val="B8BEC6"/>
+                </a:solidFill>
+                <a:latin typeface="Manrope"/>
+                <a:cs typeface="Manrope"/>
+              </a:rPr>
+              <a:t>@FreightTiger confidential</a:t>
+            </a:r>
+          </a:p>
+        </p:txBody>
+      </p:sp>
+      <p:sp>
+        <p:nvSpPr>
+          <p:cNvPr id="7" name="Rounded Rectangle 6"/>
+          <p:cNvSpPr/>
+          <p:nvPr/>
+        </p:nvSpPr>
+        <p:spPr>
+          <a:xfrm>
+            <a:off x="228600" y="726000"/>
+            <a:ext cx="150000" cy="150000"/>
+          </a:xfrm>
+          <a:prstGeom prst="roundRect">
+            <a:avLst>
+              <a:gd name="adj" fmla="val 30000"/>
+            </a:avLst>
+          </a:prstGeom>
+          <a:solidFill>
+            <a:srgbClr val="1F3763"/>
+          </a:solidFill>
+          <a:ln>
+            <a:noFill/>
+          </a:ln>
+          <a:effectLst/>
+        </p:spPr>
+        <p:style>
+          <a:lnRef idx="1">
+            <a:schemeClr val="accent1"/>
+          </a:lnRef>
+          <a:fillRef idx="3">
+            <a:schemeClr val="accent1"/>
+          </a:fillRef>
+          <a:effectRef idx="2">
+            <a:schemeClr val="accent1"/>
+          </a:effectRef>
+          <a:fontRef idx="minor">
+            <a:schemeClr val="lt1"/>
+          </a:fontRef>
+        </p:style>
+        <p:txBody>
+          <a:bodyPr rtlCol="0" anchor="ctr"/>
+          <a:lstStyle/>
+          <a:p>
+            <a:pPr algn="ctr"/>
+          </a:p>
+        </p:txBody>
+      </p:sp>
+      <p:sp>
+        <p:nvSpPr>
+          <p:cNvPr id="8" name="TextBox 7"/>
+          <p:cNvSpPr txBox="1"/>
+          <p:nvPr/>
+        </p:nvSpPr>
+        <p:spPr>
+          <a:xfrm>
+            <a:off x="413600" y="712000"/>
+            <a:ext cx="1900000" cy="190000"/>
+          </a:xfrm>
+          <a:prstGeom prst="rect">
+            <a:avLst/>
+          </a:prstGeom>
+          <a:noFill/>
+        </p:spPr>
+        <p:txBody>
+          <a:bodyPr wrap="square" anchor="ctr" lIns="0" rIns="0" tIns="0" bIns="0">
+            <a:spAutoFit/>
+          </a:bodyPr>
+          <a:lstStyle/>
+          <a:p>
+            <a:pPr algn="l">
+              <a:lnSpc>
+                <a:spcPct val="100000"/>
+              </a:lnSpc>
+              <a:spcBef>
+                <a:spcPts val="0"/>
+              </a:spcBef>
+              <a:spcAft>
+                <a:spcPts val="0"/>
+              </a:spcAft>
+            </a:pPr>
+            <a:r>
+              <a:rPr sz="860" b="1" i="0">
+                <a:solidFill>
+                  <a:srgbClr val="1F3763"/>
+                </a:solidFill>
+                <a:latin typeface="Manrope"/>
+                <a:cs typeface="Manrope"/>
+              </a:rPr>
+              <a:t>Ledger</a:t>
+            </a:r>
+          </a:p>
+        </p:txBody>
+      </p:sp>
+      <p:sp>
+        <p:nvSpPr>
+          <p:cNvPr id="9" name="Rounded Rectangle 8"/>
+          <p:cNvSpPr/>
+          <p:nvPr/>
+        </p:nvSpPr>
+        <p:spPr>
+          <a:xfrm>
+            <a:off x="905600" y="726000"/>
+            <a:ext cx="150000" cy="150000"/>
+          </a:xfrm>
+          <a:prstGeom prst="roundRect">
+            <a:avLst>
+              <a:gd name="adj" fmla="val 30000"/>
+            </a:avLst>
+          </a:prstGeom>
+          <a:solidFill>
+            <a:srgbClr val="26815C"/>
+          </a:solidFill>
+          <a:ln>
+            <a:noFill/>
+          </a:ln>
+          <a:effectLst/>
+        </p:spPr>
+        <p:style>
+          <a:lnRef idx="1">
+            <a:schemeClr val="accent1"/>
+          </a:lnRef>
+          <a:fillRef idx="3">
+            <a:schemeClr val="accent1"/>
+          </a:fillRef>
+          <a:effectRef idx="2">
+            <a:schemeClr val="accent1"/>
+          </a:effectRef>
+          <a:fontRef idx="minor">
+            <a:schemeClr val="lt1"/>
+          </a:fontRef>
+        </p:style>
+        <p:txBody>
+          <a:bodyPr rtlCol="0" anchor="ctr"/>
+          <a:lstStyle/>
+          <a:p>
+            <a:pPr algn="ctr"/>
+          </a:p>
+        </p:txBody>
+      </p:sp>
+      <p:sp>
+        <p:nvSpPr>
+          <p:cNvPr id="10" name="TextBox 9"/>
+          <p:cNvSpPr txBox="1"/>
+          <p:nvPr/>
+        </p:nvSpPr>
+        <p:spPr>
+          <a:xfrm>
+            <a:off x="1090600" y="712000"/>
+            <a:ext cx="1900000" cy="190000"/>
+          </a:xfrm>
+          <a:prstGeom prst="rect">
+            <a:avLst/>
+          </a:prstGeom>
+          <a:noFill/>
+        </p:spPr>
+        <p:txBody>
+          <a:bodyPr wrap="square" anchor="ctr" lIns="0" rIns="0" tIns="0" bIns="0">
+            <a:spAutoFit/>
+          </a:bodyPr>
+          <a:lstStyle/>
+          <a:p>
+            <a:pPr algn="l">
+              <a:lnSpc>
+                <a:spcPct val="100000"/>
+              </a:lnSpc>
+              <a:spcBef>
+                <a:spcPts val="0"/>
+              </a:spcBef>
+              <a:spcAft>
+                <a:spcPts val="0"/>
+              </a:spcAft>
+            </a:pPr>
+            <a:r>
+              <a:rPr sz="860" b="1" i="0">
+                <a:solidFill>
+                  <a:srgbClr val="26815C"/>
+                </a:solidFill>
+                <a:latin typeface="Manrope"/>
+                <a:cs typeface="Manrope"/>
+              </a:rPr>
+              <a:t>Fulfilment %</a:t>
+            </a:r>
+          </a:p>
+        </p:txBody>
+      </p:sp>
+      <p:sp>
+        <p:nvSpPr>
+          <p:cNvPr id="11" name="Rounded Rectangle 10"/>
+          <p:cNvSpPr/>
+          <p:nvPr/>
+        </p:nvSpPr>
+        <p:spPr>
+          <a:xfrm>
+            <a:off x="1924600" y="726000"/>
+            <a:ext cx="150000" cy="150000"/>
+          </a:xfrm>
+          <a:prstGeom prst="roundRect">
+            <a:avLst>
+              <a:gd name="adj" fmla="val 30000"/>
+            </a:avLst>
+          </a:prstGeom>
+          <a:solidFill>
+            <a:srgbClr val="6043A3"/>
+          </a:solidFill>
+          <a:ln>
+            <a:noFill/>
+          </a:ln>
+          <a:effectLst/>
+        </p:spPr>
+        <p:style>
+          <a:lnRef idx="1">
+            <a:schemeClr val="accent1"/>
+          </a:lnRef>
+          <a:fillRef idx="3">
+            <a:schemeClr val="accent1"/>
+          </a:fillRef>
+          <a:effectRef idx="2">
+            <a:schemeClr val="accent1"/>
+          </a:effectRef>
+          <a:fontRef idx="minor">
+            <a:schemeClr val="lt1"/>
+          </a:fontRef>
+        </p:style>
+        <p:txBody>
+          <a:bodyPr rtlCol="0" anchor="ctr"/>
+          <a:lstStyle/>
+          <a:p>
+            <a:pPr algn="ctr"/>
+          </a:p>
+        </p:txBody>
+      </p:sp>
+      <p:sp>
+        <p:nvSpPr>
+          <p:cNvPr id="12" name="TextBox 11"/>
+          <p:cNvSpPr txBox="1"/>
+          <p:nvPr/>
+        </p:nvSpPr>
+        <p:spPr>
+          <a:xfrm>
+            <a:off x="2109600" y="712000"/>
+            <a:ext cx="1900000" cy="190000"/>
+          </a:xfrm>
+          <a:prstGeom prst="rect">
+            <a:avLst/>
+          </a:prstGeom>
+          <a:noFill/>
+        </p:spPr>
+        <p:txBody>
+          <a:bodyPr wrap="square" anchor="ctr" lIns="0" rIns="0" tIns="0" bIns="0">
+            <a:spAutoFit/>
+          </a:bodyPr>
+          <a:lstStyle/>
+          <a:p>
+            <a:pPr algn="l">
+              <a:lnSpc>
+                <a:spcPct val="100000"/>
+              </a:lnSpc>
+              <a:spcBef>
+                <a:spcPts val="0"/>
+              </a:spcBef>
+              <a:spcAft>
+                <a:spcPts val="0"/>
+              </a:spcAft>
+            </a:pPr>
+            <a:r>
+              <a:rPr sz="860" b="1" i="0">
+                <a:solidFill>
+                  <a:srgbClr val="6043A3"/>
+                </a:solidFill>
+                <a:latin typeface="Manrope"/>
+                <a:cs typeface="Manrope"/>
+              </a:rPr>
+              <a:t>DAU</a:t>
+            </a:r>
+          </a:p>
+        </p:txBody>
+      </p:sp>
+      <p:sp>
+        <p:nvSpPr>
+          <p:cNvPr id="13" name="Rounded Rectangle 12"/>
+          <p:cNvSpPr/>
+          <p:nvPr/>
+        </p:nvSpPr>
+        <p:spPr>
+          <a:xfrm>
+            <a:off x="2430600" y="726000"/>
+            <a:ext cx="150000" cy="150000"/>
+          </a:xfrm>
+          <a:prstGeom prst="roundRect">
+            <a:avLst>
+              <a:gd name="adj" fmla="val 30000"/>
+            </a:avLst>
+          </a:prstGeom>
+          <a:solidFill>
+            <a:srgbClr val="C77D0A"/>
+          </a:solidFill>
+          <a:ln>
+            <a:noFill/>
+          </a:ln>
+          <a:effectLst/>
+        </p:spPr>
+        <p:style>
+          <a:lnRef idx="1">
+            <a:schemeClr val="accent1"/>
+          </a:lnRef>
+          <a:fillRef idx="3">
+            <a:schemeClr val="accent1"/>
+          </a:fillRef>
+          <a:effectRef idx="2">
+            <a:schemeClr val="accent1"/>
+          </a:effectRef>
+          <a:fontRef idx="minor">
+            <a:schemeClr val="lt1"/>
+          </a:fontRef>
+        </p:style>
+        <p:txBody>
+          <a:bodyPr rtlCol="0" anchor="ctr"/>
+          <a:lstStyle/>
+          <a:p>
+            <a:pPr algn="ctr"/>
+          </a:p>
+        </p:txBody>
+      </p:sp>
+      <p:sp>
+        <p:nvSpPr>
+          <p:cNvPr id="14" name="TextBox 13"/>
+          <p:cNvSpPr txBox="1"/>
+          <p:nvPr/>
+        </p:nvSpPr>
+        <p:spPr>
+          <a:xfrm>
+            <a:off x="2615600" y="712000"/>
+            <a:ext cx="1900000" cy="190000"/>
+          </a:xfrm>
+          <a:prstGeom prst="rect">
+            <a:avLst/>
+          </a:prstGeom>
+          <a:noFill/>
+        </p:spPr>
+        <p:txBody>
+          <a:bodyPr wrap="square" anchor="ctr" lIns="0" rIns="0" tIns="0" bIns="0">
+            <a:spAutoFit/>
+          </a:bodyPr>
+          <a:lstStyle/>
+          <a:p>
+            <a:pPr algn="l">
+              <a:lnSpc>
+                <a:spcPct val="100000"/>
+              </a:lnSpc>
+              <a:spcBef>
+                <a:spcPts val="0"/>
+              </a:spcBef>
+              <a:spcAft>
+                <a:spcPts val="0"/>
+              </a:spcAft>
+            </a:pPr>
+            <a:r>
+              <a:rPr sz="860" b="1" i="0">
+                <a:solidFill>
+                  <a:srgbClr val="C77D0A"/>
+                </a:solidFill>
+                <a:latin typeface="Manrope"/>
+                <a:cs typeface="Manrope"/>
+              </a:rPr>
+              <a:t>Reduce Ops Bandwidth</a:t>
+            </a:r>
+          </a:p>
+        </p:txBody>
+      </p:sp>
+      <p:sp>
+        <p:nvSpPr>
+          <p:cNvPr id="15" name="TextBox 14"/>
+          <p:cNvSpPr txBox="1"/>
+          <p:nvPr/>
+        </p:nvSpPr>
+        <p:spPr>
+          <a:xfrm>
+            <a:off x="5250000" y="712000"/>
+            <a:ext cx="3665400" cy="190000"/>
+          </a:xfrm>
+          <a:prstGeom prst="rect">
+            <a:avLst/>
+          </a:prstGeom>
+          <a:noFill/>
+        </p:spPr>
+        <p:txBody>
+          <a:bodyPr wrap="square" anchor="ctr" lIns="0" rIns="0" tIns="0" bIns="0">
+            <a:spAutoFit/>
+          </a:bodyPr>
+          <a:lstStyle/>
+          <a:p>
+            <a:pPr algn="r">
+              <a:lnSpc>
+                <a:spcPct val="100000"/>
+              </a:lnSpc>
+              <a:spcBef>
+                <a:spcPts val="0"/>
+              </a:spcBef>
+              <a:spcAft>
+                <a:spcPts val="0"/>
+              </a:spcAft>
+            </a:pPr>
+            <a:r>
+              <a:rPr sz="819" b="1" i="0">
+                <a:solidFill>
+                  <a:srgbClr val="3E4C63"/>
+                </a:solidFill>
+                <a:latin typeface="Manrope"/>
+                <a:cs typeface="Manrope"/>
+              </a:rPr>
+              <a:t>Network-lane conversion:  </a:t>
+            </a:r>
+            <a:r>
+              <a:rPr sz="819" b="0" i="0">
+                <a:solidFill>
+                  <a:srgbClr val="25303B"/>
+                </a:solidFill>
+                <a:latin typeface="Manrope"/>
+                <a:cs typeface="Manrope"/>
+              </a:rPr>
+              <a:t>Apr 13.7% → May 11.2% → Jun 17.1%  →  Q2 exit 20%</a:t>
+            </a:r>
+          </a:p>
+        </p:txBody>
+      </p:sp>
+      <p:sp>
+        <p:nvSpPr>
+          <p:cNvPr id="16" name="Rounded Rectangle 15"/>
+          <p:cNvSpPr/>
+          <p:nvPr/>
+        </p:nvSpPr>
+        <p:spPr>
+          <a:xfrm>
+            <a:off x="228600" y="966000"/>
+            <a:ext cx="2864933" cy="2854000"/>
+          </a:xfrm>
+          <a:prstGeom prst="roundRect">
+            <a:avLst>
+              <a:gd name="adj" fmla="val 9000"/>
+            </a:avLst>
+          </a:prstGeom>
+          <a:solidFill>
+            <a:srgbClr val="F7F8FA"/>
+          </a:solidFill>
+          <a:ln w="6350">
+            <a:solidFill>
+              <a:srgbClr val="D5DAE1"/>
+            </a:solidFill>
+          </a:ln>
+          <a:effectLst/>
+        </p:spPr>
+        <p:style>
+          <a:lnRef idx="1">
+            <a:schemeClr val="accent1"/>
+          </a:lnRef>
+          <a:fillRef idx="3">
+            <a:schemeClr val="accent1"/>
+          </a:fillRef>
+          <a:effectRef idx="2">
+            <a:schemeClr val="accent1"/>
+          </a:effectRef>
+          <a:fontRef idx="minor">
+            <a:schemeClr val="lt1"/>
+          </a:fontRef>
+        </p:style>
+        <p:txBody>
+          <a:bodyPr rtlCol="0" anchor="ctr"/>
+          <a:lstStyle/>
+          <a:p>
+            <a:pPr algn="ctr"/>
+          </a:p>
+        </p:txBody>
+      </p:sp>
+      <p:sp>
+        <p:nvSpPr>
+          <p:cNvPr id="17" name="Rounded Rectangle 16"/>
+          <p:cNvSpPr/>
+          <p:nvPr/>
+        </p:nvSpPr>
+        <p:spPr>
+          <a:xfrm>
+            <a:off x="228600" y="966000"/>
+            <a:ext cx="2864933" cy="250000"/>
+          </a:xfrm>
+          <a:prstGeom prst="roundRect">
+            <a:avLst>
+              <a:gd name="adj" fmla="val 9000"/>
+            </a:avLst>
+          </a:prstGeom>
+          <a:solidFill>
+            <a:srgbClr val="3E4C63"/>
+          </a:solidFill>
+          <a:ln>
+            <a:noFill/>
+          </a:ln>
+          <a:effectLst/>
+        </p:spPr>
+        <p:style>
+          <a:lnRef idx="1">
+            <a:schemeClr val="accent1"/>
+          </a:lnRef>
+          <a:fillRef idx="3">
+            <a:schemeClr val="accent1"/>
+          </a:fillRef>
+          <a:effectRef idx="2">
+            <a:schemeClr val="accent1"/>
+          </a:effectRef>
+          <a:fontRef idx="minor">
+            <a:schemeClr val="lt1"/>
+          </a:fontRef>
+        </p:style>
+        <p:txBody>
+          <a:bodyPr rtlCol="0" anchor="ctr"/>
+          <a:lstStyle/>
+          <a:p>
+            <a:pPr algn="ctr"/>
+          </a:p>
+        </p:txBody>
+      </p:sp>
+      <p:sp>
+        <p:nvSpPr>
+          <p:cNvPr id="18" name="TextBox 17"/>
+          <p:cNvSpPr txBox="1"/>
+          <p:nvPr/>
+        </p:nvSpPr>
+        <p:spPr>
+          <a:xfrm>
+            <a:off x="298600" y="966000"/>
+            <a:ext cx="2774933" cy="250000"/>
+          </a:xfrm>
+          <a:prstGeom prst="rect">
+            <a:avLst/>
+          </a:prstGeom>
+          <a:noFill/>
+        </p:spPr>
+        <p:txBody>
+          <a:bodyPr wrap="square" anchor="ctr" lIns="0" rIns="0" tIns="0" bIns="0">
+            <a:spAutoFit/>
+          </a:bodyPr>
+          <a:lstStyle/>
+          <a:p>
+            <a:pPr algn="l">
+              <a:lnSpc>
+                <a:spcPct val="100000"/>
+              </a:lnSpc>
+              <a:spcBef>
+                <a:spcPts val="0"/>
+              </a:spcBef>
+              <a:spcAft>
+                <a:spcPts val="0"/>
+              </a:spcAft>
+            </a:pPr>
+            <a:r>
+              <a:rPr sz="1000" b="1" i="0">
+                <a:solidFill>
+                  <a:srgbClr val="FFFFFF"/>
+                </a:solidFill>
+                <a:latin typeface="Manrope"/>
+                <a:cs typeface="Manrope"/>
+              </a:rPr>
+              <a:t>JULY   </a:t>
+            </a:r>
+            <a:r>
+              <a:rPr sz="850" b="1" i="0">
+                <a:solidFill>
+                  <a:srgbClr val="C5CCD6"/>
+                </a:solidFill>
+                <a:latin typeface="Manrope"/>
+                <a:cs typeface="Manrope"/>
+              </a:rPr>
+              <a:t>(12)</a:t>
+            </a:r>
+          </a:p>
+        </p:txBody>
+      </p:sp>
+      <p:sp>
+        <p:nvSpPr>
+          <p:cNvPr id="19" name="TextBox 18"/>
+          <p:cNvSpPr txBox="1"/>
+          <p:nvPr/>
+        </p:nvSpPr>
+        <p:spPr>
+          <a:xfrm>
+            <a:off x="292600" y="1272000"/>
+            <a:ext cx="2754933" cy="2548000"/>
+          </a:xfrm>
+          <a:prstGeom prst="rect">
+            <a:avLst/>
+          </a:prstGeom>
+          <a:noFill/>
+        </p:spPr>
+        <p:txBody>
+          <a:bodyPr wrap="square" anchor="t" lIns="0" rIns="0" tIns="0" bIns="0">
+            <a:spAutoFit/>
+          </a:bodyPr>
+          <a:lstStyle/>
+          <a:p>
+            <a:pPr algn="l" indent="-110000" marL="110000">
+              <a:lnSpc>
+                <a:spcPct val="102000"/>
+              </a:lnSpc>
+              <a:spcBef>
+                <a:spcPts val="0"/>
+              </a:spcBef>
+              <a:spcAft>
+                <a:spcPts val="320"/>
+              </a:spcAft>
+            </a:pPr>
+            <a:r>
+              <a:rPr sz="700" b="0" i="0">
+                <a:solidFill>
+                  <a:srgbClr val="1F3763"/>
+                </a:solidFill>
+                <a:latin typeface="Manrope"/>
+                <a:cs typeface="Manrope"/>
+              </a:rPr>
+              <a:t>● </a:t>
+            </a:r>
+            <a:r>
+              <a:rPr sz="720" b="1" i="0">
+                <a:solidFill>
+                  <a:srgbClr val="25303B"/>
+                </a:solidFill>
+                <a:latin typeface="Manrope"/>
+                <a:cs typeface="Manrope"/>
+              </a:rPr>
+              <a:t>CM-723  </a:t>
+            </a:r>
+            <a:r>
+              <a:rPr sz="720" b="0" i="0">
+                <a:solidFill>
+                  <a:srgbClr val="25303B"/>
+                </a:solidFill>
+                <a:latin typeface="Manrope"/>
+                <a:cs typeface="Manrope"/>
+              </a:rPr>
+              <a:t>Immutable trip-level payment record (Net Payable/Receivable)  </a:t>
+            </a:r>
+            <a:r>
+              <a:rPr sz="640" b="1" i="1">
+                <a:solidFill>
+                  <a:srgbClr val="1F3763"/>
+                </a:solidFill>
+                <a:latin typeface="Manrope"/>
+                <a:cs typeface="Manrope"/>
+              </a:rPr>
+              <a:t>In Dev</a:t>
+            </a:r>
+          </a:p>
+          <a:p>
+            <a:pPr algn="l" indent="-110000" marL="110000">
+              <a:lnSpc>
+                <a:spcPct val="102000"/>
+              </a:lnSpc>
+              <a:spcBef>
+                <a:spcPts val="0"/>
+              </a:spcBef>
+              <a:spcAft>
+                <a:spcPts val="320"/>
+              </a:spcAft>
+            </a:pPr>
+            <a:r>
+              <a:rPr sz="700" b="0" i="0">
+                <a:solidFill>
+                  <a:srgbClr val="1F3763"/>
+                </a:solidFill>
+                <a:latin typeface="Manrope"/>
+                <a:cs typeface="Manrope"/>
+              </a:rPr>
+              <a:t>● </a:t>
+            </a:r>
+            <a:r>
+              <a:rPr sz="720" b="1" i="0">
+                <a:solidFill>
+                  <a:srgbClr val="25303B"/>
+                </a:solidFill>
+                <a:latin typeface="Manrope"/>
+                <a:cs typeface="Manrope"/>
+              </a:rPr>
+              <a:t>CM-722  </a:t>
+            </a:r>
+            <a:r>
+              <a:rPr sz="720" b="0" i="0">
+                <a:solidFill>
+                  <a:srgbClr val="25303B"/>
+                </a:solidFill>
+                <a:latin typeface="Manrope"/>
+                <a:cs typeface="Manrope"/>
+              </a:rPr>
+              <a:t>Overpayment settlement via FO/LSP wallets  </a:t>
+            </a:r>
+            <a:r>
+              <a:rPr sz="640" b="1" i="1">
+                <a:solidFill>
+                  <a:srgbClr val="1F3763"/>
+                </a:solidFill>
+                <a:latin typeface="Manrope"/>
+                <a:cs typeface="Manrope"/>
+              </a:rPr>
+              <a:t>In Dev</a:t>
+            </a:r>
+          </a:p>
+          <a:p>
+            <a:pPr algn="l" indent="-110000" marL="110000">
+              <a:lnSpc>
+                <a:spcPct val="102000"/>
+              </a:lnSpc>
+              <a:spcBef>
+                <a:spcPts val="0"/>
+              </a:spcBef>
+              <a:spcAft>
+                <a:spcPts val="320"/>
+              </a:spcAft>
+            </a:pPr>
+            <a:r>
+              <a:rPr sz="700" b="0" i="0">
+                <a:solidFill>
+                  <a:srgbClr val="1F3763"/>
+                </a:solidFill>
+                <a:latin typeface="Manrope"/>
+                <a:cs typeface="Manrope"/>
+              </a:rPr>
+              <a:t>● </a:t>
+            </a:r>
+            <a:r>
+              <a:rPr sz="720" b="1" i="0">
+                <a:solidFill>
+                  <a:srgbClr val="25303B"/>
+                </a:solidFill>
+                <a:latin typeface="Manrope"/>
+                <a:cs typeface="Manrope"/>
+              </a:rPr>
+              <a:t>CM-734  </a:t>
+            </a:r>
+            <a:r>
+              <a:rPr sz="720" b="0" i="0">
+                <a:solidFill>
+                  <a:srgbClr val="25303B"/>
+                </a:solidFill>
+                <a:latin typeface="Manrope"/>
+                <a:cs typeface="Manrope"/>
+              </a:rPr>
+              <a:t>Capture TDS details in CRM (Supplier KYC)  </a:t>
+            </a:r>
+            <a:r>
+              <a:rPr sz="640" b="1" i="1">
+                <a:solidFill>
+                  <a:srgbClr val="1F3763"/>
+                </a:solidFill>
+                <a:latin typeface="Manrope"/>
+                <a:cs typeface="Manrope"/>
+              </a:rPr>
+              <a:t>In Dev</a:t>
+            </a:r>
+          </a:p>
+          <a:p>
+            <a:pPr algn="l" indent="-110000" marL="110000">
+              <a:lnSpc>
+                <a:spcPct val="102000"/>
+              </a:lnSpc>
+              <a:spcBef>
+                <a:spcPts val="0"/>
+              </a:spcBef>
+              <a:spcAft>
+                <a:spcPts val="320"/>
+              </a:spcAft>
+            </a:pPr>
+            <a:r>
+              <a:rPr sz="700" b="0" i="0">
+                <a:solidFill>
+                  <a:srgbClr val="1F3763"/>
+                </a:solidFill>
+                <a:latin typeface="Manrope"/>
+                <a:cs typeface="Manrope"/>
+              </a:rPr>
+              <a:t>● </a:t>
+            </a:r>
+            <a:r>
+              <a:rPr sz="720" b="1" i="0">
+                <a:solidFill>
+                  <a:srgbClr val="25303B"/>
+                </a:solidFill>
+                <a:latin typeface="Manrope"/>
+                <a:cs typeface="Manrope"/>
+              </a:rPr>
+              <a:t>CM-735  </a:t>
+            </a:r>
+            <a:r>
+              <a:rPr sz="720" b="0" i="0">
+                <a:solidFill>
+                  <a:srgbClr val="25303B"/>
+                </a:solidFill>
+                <a:latin typeface="Manrope"/>
+                <a:cs typeface="Manrope"/>
+              </a:rPr>
+              <a:t>Auto-calculate TDS for new &amp; active trips  </a:t>
+            </a:r>
+            <a:r>
+              <a:rPr sz="640" b="1" i="1">
+                <a:solidFill>
+                  <a:srgbClr val="1F3763"/>
+                </a:solidFill>
+                <a:latin typeface="Manrope"/>
+                <a:cs typeface="Manrope"/>
+              </a:rPr>
+              <a:t>In Dev</a:t>
+            </a:r>
+          </a:p>
+          <a:p>
+            <a:pPr algn="l" indent="-110000" marL="110000">
+              <a:lnSpc>
+                <a:spcPct val="102000"/>
+              </a:lnSpc>
+              <a:spcBef>
+                <a:spcPts val="0"/>
+              </a:spcBef>
+              <a:spcAft>
+                <a:spcPts val="320"/>
+              </a:spcAft>
+            </a:pPr>
+            <a:r>
+              <a:rPr sz="700" b="0" i="0">
+                <a:solidFill>
+                  <a:srgbClr val="1F3763"/>
+                </a:solidFill>
+                <a:latin typeface="Manrope"/>
+                <a:cs typeface="Manrope"/>
+              </a:rPr>
+              <a:t>● </a:t>
+            </a:r>
+            <a:r>
+              <a:rPr sz="720" b="1" i="0">
+                <a:solidFill>
+                  <a:srgbClr val="25303B"/>
+                </a:solidFill>
+                <a:latin typeface="Manrope"/>
+                <a:cs typeface="Manrope"/>
+              </a:rPr>
+              <a:t>CM-746  </a:t>
+            </a:r>
+            <a:r>
+              <a:rPr sz="720" b="0" i="0">
+                <a:solidFill>
+                  <a:srgbClr val="25303B"/>
+                </a:solidFill>
+                <a:latin typeface="Manrope"/>
+                <a:cs typeface="Manrope"/>
+              </a:rPr>
+              <a:t>Recalculate/reverse TDS on mid-month declaration change  </a:t>
+            </a:r>
+            <a:r>
+              <a:rPr sz="640" b="1" i="1">
+                <a:solidFill>
+                  <a:srgbClr val="6043A3"/>
+                </a:solidFill>
+                <a:latin typeface="Manrope"/>
+                <a:cs typeface="Manrope"/>
+              </a:rPr>
+              <a:t>Prioritised</a:t>
+            </a:r>
+          </a:p>
+          <a:p>
+            <a:pPr algn="l" indent="-110000" marL="110000">
+              <a:lnSpc>
+                <a:spcPct val="102000"/>
+              </a:lnSpc>
+              <a:spcBef>
+                <a:spcPts val="0"/>
+              </a:spcBef>
+              <a:spcAft>
+                <a:spcPts val="320"/>
+              </a:spcAft>
+            </a:pPr>
+            <a:r>
+              <a:rPr sz="700" b="0" i="0">
+                <a:solidFill>
+                  <a:srgbClr val="26815C"/>
+                </a:solidFill>
+                <a:latin typeface="Manrope"/>
+                <a:cs typeface="Manrope"/>
+              </a:rPr>
+              <a:t>● </a:t>
+            </a:r>
+            <a:r>
+              <a:rPr sz="720" b="1" i="0">
+                <a:solidFill>
+                  <a:srgbClr val="25303B"/>
+                </a:solidFill>
+                <a:latin typeface="Manrope"/>
+                <a:cs typeface="Manrope"/>
+              </a:rPr>
+              <a:t>CM-682  </a:t>
+            </a:r>
+            <a:r>
+              <a:rPr sz="720" b="0" i="0">
+                <a:solidFill>
+                  <a:srgbClr val="25303B"/>
+                </a:solidFill>
+                <a:latin typeface="Manrope"/>
+                <a:cs typeface="Manrope"/>
+              </a:rPr>
+              <a:t>Map agents to lanes for demand auto-assignment  </a:t>
+            </a:r>
+            <a:r>
+              <a:rPr sz="640" b="1" i="1">
+                <a:solidFill>
+                  <a:srgbClr val="6043A3"/>
+                </a:solidFill>
+                <a:latin typeface="Manrope"/>
+                <a:cs typeface="Manrope"/>
+              </a:rPr>
+              <a:t>Prioritised</a:t>
+            </a:r>
+          </a:p>
+          <a:p>
+            <a:pPr algn="l" indent="-110000" marL="110000">
+              <a:lnSpc>
+                <a:spcPct val="102000"/>
+              </a:lnSpc>
+              <a:spcBef>
+                <a:spcPts val="0"/>
+              </a:spcBef>
+              <a:spcAft>
+                <a:spcPts val="320"/>
+              </a:spcAft>
+            </a:pPr>
+            <a:r>
+              <a:rPr sz="700" b="0" i="0">
+                <a:solidFill>
+                  <a:srgbClr val="26815C"/>
+                </a:solidFill>
+                <a:latin typeface="Manrope"/>
+                <a:cs typeface="Manrope"/>
+              </a:rPr>
+              <a:t>● </a:t>
+            </a:r>
+            <a:r>
+              <a:rPr sz="720" b="1" i="0">
+                <a:solidFill>
+                  <a:srgbClr val="25303B"/>
+                </a:solidFill>
+                <a:latin typeface="Manrope"/>
+                <a:cs typeface="Manrope"/>
+              </a:rPr>
+              <a:t>CM-731  </a:t>
+            </a:r>
+            <a:r>
+              <a:rPr sz="720" b="0" i="0">
+                <a:solidFill>
+                  <a:srgbClr val="25303B"/>
+                </a:solidFill>
+                <a:latin typeface="Manrope"/>
+                <a:cs typeface="Manrope"/>
+              </a:rPr>
+              <a:t>Demand Bot: batch message context building  </a:t>
+            </a:r>
+            <a:r>
+              <a:rPr sz="640" b="1" i="1">
+                <a:solidFill>
+                  <a:srgbClr val="6043A3"/>
+                </a:solidFill>
+                <a:latin typeface="Manrope"/>
+                <a:cs typeface="Manrope"/>
+              </a:rPr>
+              <a:t>Prioritised</a:t>
+            </a:r>
+          </a:p>
+          <a:p>
+            <a:pPr algn="l" indent="-110000" marL="110000">
+              <a:lnSpc>
+                <a:spcPct val="102000"/>
+              </a:lnSpc>
+              <a:spcBef>
+                <a:spcPts val="0"/>
+              </a:spcBef>
+              <a:spcAft>
+                <a:spcPts val="320"/>
+              </a:spcAft>
+            </a:pPr>
+            <a:r>
+              <a:rPr sz="700" b="0" i="0">
+                <a:solidFill>
+                  <a:srgbClr val="26815C"/>
+                </a:solidFill>
+                <a:latin typeface="Manrope"/>
+                <a:cs typeface="Manrope"/>
+              </a:rPr>
+              <a:t>● </a:t>
+            </a:r>
+            <a:r>
+              <a:rPr sz="720" b="1" i="0">
+                <a:solidFill>
+                  <a:srgbClr val="25303B"/>
+                </a:solidFill>
+                <a:latin typeface="Manrope"/>
+                <a:cs typeface="Manrope"/>
+              </a:rPr>
+              <a:t>CM-739  </a:t>
+            </a:r>
+            <a:r>
+              <a:rPr sz="720" b="0" i="0">
+                <a:solidFill>
+                  <a:srgbClr val="25303B"/>
+                </a:solidFill>
+                <a:latin typeface="Manrope"/>
+                <a:cs typeface="Manrope"/>
+              </a:rPr>
+              <a:t>Near-match inventory logic + match quality on demand list  </a:t>
+            </a:r>
+            <a:r>
+              <a:rPr sz="640" b="1" i="1">
+                <a:solidFill>
+                  <a:srgbClr val="26815C"/>
+                </a:solidFill>
+                <a:latin typeface="Manrope"/>
+                <a:cs typeface="Manrope"/>
+              </a:rPr>
+              <a:t>Done</a:t>
+            </a:r>
+          </a:p>
+          <a:p>
+            <a:pPr algn="l" indent="-110000" marL="110000">
+              <a:lnSpc>
+                <a:spcPct val="102000"/>
+              </a:lnSpc>
+              <a:spcBef>
+                <a:spcPts val="0"/>
+              </a:spcBef>
+              <a:spcAft>
+                <a:spcPts val="320"/>
+              </a:spcAft>
+            </a:pPr>
+            <a:r>
+              <a:rPr sz="700" b="0" i="0">
+                <a:solidFill>
+                  <a:srgbClr val="6043A3"/>
+                </a:solidFill>
+                <a:latin typeface="Manrope"/>
+                <a:cs typeface="Manrope"/>
+              </a:rPr>
+              <a:t>● </a:t>
+            </a:r>
+            <a:r>
+              <a:rPr sz="720" b="1" i="0">
+                <a:solidFill>
+                  <a:srgbClr val="25303B"/>
+                </a:solidFill>
+                <a:latin typeface="Manrope"/>
+                <a:cs typeface="Manrope"/>
+              </a:rPr>
+              <a:t>CM-819  </a:t>
+            </a:r>
+            <a:r>
+              <a:rPr sz="720" b="0" i="0">
+                <a:solidFill>
+                  <a:srgbClr val="25303B"/>
+                </a:solidFill>
+                <a:latin typeface="Manrope"/>
+                <a:cs typeface="Manrope"/>
+              </a:rPr>
+              <a:t>FO App: reach PSA directly for placement (show PSA number)  </a:t>
+            </a:r>
+            <a:r>
+              <a:rPr sz="640" b="1" i="1">
+                <a:solidFill>
+                  <a:srgbClr val="6043A3"/>
+                </a:solidFill>
+                <a:latin typeface="Manrope"/>
+                <a:cs typeface="Manrope"/>
+              </a:rPr>
+              <a:t>Prioritised</a:t>
+            </a:r>
+          </a:p>
+          <a:p>
+            <a:pPr algn="l" indent="-110000" marL="110000">
+              <a:lnSpc>
+                <a:spcPct val="102000"/>
+              </a:lnSpc>
+              <a:spcBef>
+                <a:spcPts val="0"/>
+              </a:spcBef>
+              <a:spcAft>
+                <a:spcPts val="320"/>
+              </a:spcAft>
+            </a:pPr>
+            <a:r>
+              <a:rPr sz="700" b="0" i="0">
+                <a:solidFill>
+                  <a:srgbClr val="C77D0A"/>
+                </a:solidFill>
+                <a:latin typeface="Manrope"/>
+                <a:cs typeface="Manrope"/>
+              </a:rPr>
+              <a:t>● </a:t>
+            </a:r>
+            <a:r>
+              <a:rPr sz="720" b="1" i="0">
+                <a:solidFill>
+                  <a:srgbClr val="25303B"/>
+                </a:solidFill>
+                <a:latin typeface="Manrope"/>
+                <a:cs typeface="Manrope"/>
+              </a:rPr>
+              <a:t>CM-785  </a:t>
+            </a:r>
+            <a:r>
+              <a:rPr sz="720" b="0" i="0">
+                <a:solidFill>
+                  <a:srgbClr val="25303B"/>
+                </a:solidFill>
+                <a:latin typeface="Manrope"/>
+                <a:cs typeface="Manrope"/>
+              </a:rPr>
+              <a:t>Automate advance payments for Gold/Silver FOs  </a:t>
+            </a:r>
+            <a:r>
+              <a:rPr sz="640" b="1" i="1">
+                <a:solidFill>
+                  <a:srgbClr val="6043A3"/>
+                </a:solidFill>
+                <a:latin typeface="Manrope"/>
+                <a:cs typeface="Manrope"/>
+              </a:rPr>
+              <a:t>Prioritised</a:t>
+            </a:r>
+          </a:p>
+          <a:p>
+            <a:pPr algn="l" indent="-110000" marL="110000">
+              <a:lnSpc>
+                <a:spcPct val="102000"/>
+              </a:lnSpc>
+              <a:spcBef>
+                <a:spcPts val="0"/>
+              </a:spcBef>
+              <a:spcAft>
+                <a:spcPts val="320"/>
+              </a:spcAft>
+            </a:pPr>
+            <a:r>
+              <a:rPr sz="700" b="0" i="0">
+                <a:solidFill>
+                  <a:srgbClr val="C77D0A"/>
+                </a:solidFill>
+                <a:latin typeface="Manrope"/>
+                <a:cs typeface="Manrope"/>
+              </a:rPr>
+              <a:t>● </a:t>
+            </a:r>
+            <a:r>
+              <a:rPr sz="720" b="1" i="0">
+                <a:solidFill>
+                  <a:srgbClr val="25303B"/>
+                </a:solidFill>
+                <a:latin typeface="Manrope"/>
+                <a:cs typeface="Manrope"/>
+              </a:rPr>
+              <a:t>CM-660  </a:t>
+            </a:r>
+            <a:r>
+              <a:rPr sz="720" b="0" i="0">
+                <a:solidFill>
+                  <a:srgbClr val="25303B"/>
+                </a:solidFill>
+                <a:latin typeface="Manrope"/>
+                <a:cs typeface="Manrope"/>
+              </a:rPr>
+              <a:t>Automate SIM consent collection (pre-transit)  </a:t>
+            </a:r>
+            <a:r>
+              <a:rPr sz="640" b="1" i="1">
+                <a:solidFill>
+                  <a:srgbClr val="C77D0A"/>
+                </a:solidFill>
+                <a:latin typeface="Manrope"/>
+                <a:cs typeface="Manrope"/>
+              </a:rPr>
+              <a:t>On-hold</a:t>
+            </a:r>
+          </a:p>
+          <a:p>
+            <a:pPr algn="l" indent="-110000" marL="110000">
+              <a:lnSpc>
+                <a:spcPct val="102000"/>
+              </a:lnSpc>
+              <a:spcBef>
+                <a:spcPts val="0"/>
+              </a:spcBef>
+              <a:spcAft>
+                <a:spcPts val="320"/>
+              </a:spcAft>
+            </a:pPr>
+            <a:r>
+              <a:rPr sz="700" b="0" i="0">
+                <a:solidFill>
+                  <a:srgbClr val="C77D0A"/>
+                </a:solidFill>
+                <a:latin typeface="Manrope"/>
+                <a:cs typeface="Manrope"/>
+              </a:rPr>
+              <a:t>● </a:t>
+            </a:r>
+            <a:r>
+              <a:rPr sz="720" b="1" i="0">
+                <a:solidFill>
+                  <a:srgbClr val="25303B"/>
+                </a:solidFill>
+                <a:latin typeface="Manrope"/>
+                <a:cs typeface="Manrope"/>
+              </a:rPr>
+              <a:t>CM-665  </a:t>
+            </a:r>
+            <a:r>
+              <a:rPr sz="720" b="0" i="0">
+                <a:solidFill>
+                  <a:srgbClr val="25303B"/>
+                </a:solidFill>
+                <a:latin typeface="Manrope"/>
+                <a:cs typeface="Manrope"/>
+              </a:rPr>
+              <a:t>Automated transit-delay detection &amp; escalation  </a:t>
+            </a:r>
+            <a:r>
+              <a:rPr sz="640" b="1" i="1">
+                <a:solidFill>
+                  <a:srgbClr val="6043A3"/>
+                </a:solidFill>
+                <a:latin typeface="Manrope"/>
+                <a:cs typeface="Manrope"/>
+              </a:rPr>
+              <a:t>Prioritised</a:t>
+            </a:r>
+          </a:p>
+        </p:txBody>
+      </p:sp>
+      <p:sp>
+        <p:nvSpPr>
+          <p:cNvPr id="20" name="Rounded Rectangle 19"/>
+          <p:cNvSpPr/>
+          <p:nvPr/>
+        </p:nvSpPr>
+        <p:spPr>
+          <a:xfrm>
+            <a:off x="3139533" y="966000"/>
+            <a:ext cx="2864933" cy="2854000"/>
+          </a:xfrm>
+          <a:prstGeom prst="roundRect">
+            <a:avLst>
+              <a:gd name="adj" fmla="val 9000"/>
+            </a:avLst>
+          </a:prstGeom>
+          <a:solidFill>
+            <a:srgbClr val="F7F8FA"/>
+          </a:solidFill>
+          <a:ln w="6350">
+            <a:solidFill>
+              <a:srgbClr val="D5DAE1"/>
+            </a:solidFill>
+          </a:ln>
+          <a:effectLst/>
+        </p:spPr>
+        <p:style>
+          <a:lnRef idx="1">
+            <a:schemeClr val="accent1"/>
+          </a:lnRef>
+          <a:fillRef idx="3">
+            <a:schemeClr val="accent1"/>
+          </a:fillRef>
+          <a:effectRef idx="2">
+            <a:schemeClr val="accent1"/>
+          </a:effectRef>
+          <a:fontRef idx="minor">
+            <a:schemeClr val="lt1"/>
+          </a:fontRef>
+        </p:style>
+        <p:txBody>
+          <a:bodyPr rtlCol="0" anchor="ctr"/>
+          <a:lstStyle/>
+          <a:p>
+            <a:pPr algn="ctr"/>
+          </a:p>
+        </p:txBody>
+      </p:sp>
+      <p:sp>
+        <p:nvSpPr>
+          <p:cNvPr id="21" name="Rounded Rectangle 20"/>
+          <p:cNvSpPr/>
+          <p:nvPr/>
+        </p:nvSpPr>
+        <p:spPr>
+          <a:xfrm>
+            <a:off x="3139533" y="966000"/>
+            <a:ext cx="2864933" cy="250000"/>
+          </a:xfrm>
+          <a:prstGeom prst="roundRect">
+            <a:avLst>
+              <a:gd name="adj" fmla="val 9000"/>
+            </a:avLst>
+          </a:prstGeom>
+          <a:solidFill>
+            <a:srgbClr val="3E4C63"/>
+          </a:solidFill>
+          <a:ln>
+            <a:noFill/>
+          </a:ln>
+          <a:effectLst/>
+        </p:spPr>
+        <p:style>
+          <a:lnRef idx="1">
+            <a:schemeClr val="accent1"/>
+          </a:lnRef>
+          <a:fillRef idx="3">
+            <a:schemeClr val="accent1"/>
+          </a:fillRef>
+          <a:effectRef idx="2">
+            <a:schemeClr val="accent1"/>
+          </a:effectRef>
+          <a:fontRef idx="minor">
+            <a:schemeClr val="lt1"/>
+          </a:fontRef>
+        </p:style>
+        <p:txBody>
+          <a:bodyPr rtlCol="0" anchor="ctr"/>
+          <a:lstStyle/>
+          <a:p>
+            <a:pPr algn="ctr"/>
+          </a:p>
+        </p:txBody>
+      </p:sp>
+      <p:sp>
+        <p:nvSpPr>
+          <p:cNvPr id="22" name="TextBox 21"/>
+          <p:cNvSpPr txBox="1"/>
+          <p:nvPr/>
+        </p:nvSpPr>
+        <p:spPr>
+          <a:xfrm>
+            <a:off x="3209533" y="966000"/>
+            <a:ext cx="2774933" cy="250000"/>
+          </a:xfrm>
+          <a:prstGeom prst="rect">
+            <a:avLst/>
+          </a:prstGeom>
+          <a:noFill/>
+        </p:spPr>
+        <p:txBody>
+          <a:bodyPr wrap="square" anchor="ctr" lIns="0" rIns="0" tIns="0" bIns="0">
+            <a:spAutoFit/>
+          </a:bodyPr>
+          <a:lstStyle/>
+          <a:p>
+            <a:pPr algn="l">
+              <a:lnSpc>
+                <a:spcPct val="100000"/>
+              </a:lnSpc>
+              <a:spcBef>
+                <a:spcPts val="0"/>
+              </a:spcBef>
+              <a:spcAft>
+                <a:spcPts val="0"/>
+              </a:spcAft>
+            </a:pPr>
+            <a:r>
+              <a:rPr sz="1000" b="1" i="0">
+                <a:solidFill>
+                  <a:srgbClr val="FFFFFF"/>
+                </a:solidFill>
+                <a:latin typeface="Manrope"/>
+                <a:cs typeface="Manrope"/>
+              </a:rPr>
+              <a:t>AUGUST   </a:t>
+            </a:r>
+            <a:r>
+              <a:rPr sz="850" b="1" i="0">
+                <a:solidFill>
+                  <a:srgbClr val="C5CCD6"/>
+                </a:solidFill>
+                <a:latin typeface="Manrope"/>
+                <a:cs typeface="Manrope"/>
+              </a:rPr>
+              <a:t>(11)</a:t>
+            </a:r>
+          </a:p>
+        </p:txBody>
+      </p:sp>
+      <p:sp>
+        <p:nvSpPr>
+          <p:cNvPr id="23" name="TextBox 22"/>
+          <p:cNvSpPr txBox="1"/>
+          <p:nvPr/>
+        </p:nvSpPr>
+        <p:spPr>
+          <a:xfrm>
+            <a:off x="3203533" y="1272000"/>
+            <a:ext cx="2754933" cy="2548000"/>
+          </a:xfrm>
+          <a:prstGeom prst="rect">
+            <a:avLst/>
+          </a:prstGeom>
+          <a:noFill/>
+        </p:spPr>
+        <p:txBody>
+          <a:bodyPr wrap="square" anchor="t" lIns="0" rIns="0" tIns="0" bIns="0">
+            <a:spAutoFit/>
+          </a:bodyPr>
+          <a:lstStyle/>
+          <a:p>
+            <a:pPr algn="l" indent="-110000" marL="110000">
+              <a:lnSpc>
+                <a:spcPct val="102000"/>
+              </a:lnSpc>
+              <a:spcBef>
+                <a:spcPts val="0"/>
+              </a:spcBef>
+              <a:spcAft>
+                <a:spcPts val="320"/>
+              </a:spcAft>
+            </a:pPr>
+            <a:r>
+              <a:rPr sz="700" b="0" i="0">
+                <a:solidFill>
+                  <a:srgbClr val="1F3763"/>
+                </a:solidFill>
+                <a:latin typeface="Manrope"/>
+                <a:cs typeface="Manrope"/>
+              </a:rPr>
+              <a:t>● </a:t>
+            </a:r>
+            <a:r>
+              <a:rPr sz="720" b="0" i="0">
+                <a:solidFill>
+                  <a:srgbClr val="25303B"/>
+                </a:solidFill>
+                <a:latin typeface="Manrope"/>
+                <a:cs typeface="Manrope"/>
+              </a:rPr>
+              <a:t>Ledger Phase-1 production rollout (continues from July)  </a:t>
+            </a:r>
+            <a:r>
+              <a:rPr sz="640" b="1" i="1">
+                <a:solidFill>
+                  <a:srgbClr val="1F3763"/>
+                </a:solidFill>
+                <a:latin typeface="Manrope"/>
+                <a:cs typeface="Manrope"/>
+              </a:rPr>
+              <a:t>In Dev</a:t>
+            </a:r>
+          </a:p>
+          <a:p>
+            <a:pPr algn="l" indent="-110000" marL="110000">
+              <a:lnSpc>
+                <a:spcPct val="102000"/>
+              </a:lnSpc>
+              <a:spcBef>
+                <a:spcPts val="0"/>
+              </a:spcBef>
+              <a:spcAft>
+                <a:spcPts val="320"/>
+              </a:spcAft>
+            </a:pPr>
+            <a:r>
+              <a:rPr sz="700" b="0" i="0">
+                <a:solidFill>
+                  <a:srgbClr val="1F3763"/>
+                </a:solidFill>
+                <a:latin typeface="Manrope"/>
+                <a:cs typeface="Manrope"/>
+              </a:rPr>
+              <a:t>● </a:t>
+            </a:r>
+            <a:r>
+              <a:rPr sz="720" b="1" i="0">
+                <a:solidFill>
+                  <a:srgbClr val="25303B"/>
+                </a:solidFill>
+                <a:latin typeface="Manrope"/>
+                <a:cs typeface="Manrope"/>
+              </a:rPr>
+              <a:t>CM-784  </a:t>
+            </a:r>
+            <a:r>
+              <a:rPr sz="720" b="0" i="0">
+                <a:solidFill>
+                  <a:srgbClr val="25303B"/>
+                </a:solidFill>
+                <a:latin typeface="Manrope"/>
+                <a:cs typeface="Manrope"/>
+              </a:rPr>
+              <a:t>Trip Statement — 3-yr financial ledger tab in FO App  </a:t>
+            </a:r>
+            <a:r>
+              <a:rPr sz="640" b="1" i="1">
+                <a:solidFill>
+                  <a:srgbClr val="6043A3"/>
+                </a:solidFill>
+                <a:latin typeface="Manrope"/>
+                <a:cs typeface="Manrope"/>
+              </a:rPr>
+              <a:t>Prioritised</a:t>
+            </a:r>
+          </a:p>
+          <a:p>
+            <a:pPr algn="l" indent="-110000" marL="110000">
+              <a:lnSpc>
+                <a:spcPct val="102000"/>
+              </a:lnSpc>
+              <a:spcBef>
+                <a:spcPts val="0"/>
+              </a:spcBef>
+              <a:spcAft>
+                <a:spcPts val="320"/>
+              </a:spcAft>
+            </a:pPr>
+            <a:r>
+              <a:rPr sz="700" b="0" i="0">
+                <a:solidFill>
+                  <a:srgbClr val="1F3763"/>
+                </a:solidFill>
+                <a:latin typeface="Manrope"/>
+                <a:cs typeface="Manrope"/>
+              </a:rPr>
+              <a:t>● </a:t>
+            </a:r>
+            <a:r>
+              <a:rPr sz="720" b="1" i="0">
+                <a:solidFill>
+                  <a:srgbClr val="25303B"/>
+                </a:solidFill>
+                <a:latin typeface="Manrope"/>
+                <a:cs typeface="Manrope"/>
+              </a:rPr>
+              <a:t>CM-736  </a:t>
+            </a:r>
+            <a:r>
+              <a:rPr sz="720" b="0" i="0">
+                <a:solidFill>
+                  <a:srgbClr val="25303B"/>
+                </a:solidFill>
+                <a:latin typeface="Manrope"/>
+                <a:cs typeface="Manrope"/>
+              </a:rPr>
+              <a:t>FO App: show TDS rate at trip level  </a:t>
+            </a:r>
+            <a:r>
+              <a:rPr sz="640" b="1" i="1">
+                <a:solidFill>
+                  <a:srgbClr val="6043A3"/>
+                </a:solidFill>
+                <a:latin typeface="Manrope"/>
+                <a:cs typeface="Manrope"/>
+              </a:rPr>
+              <a:t>Prioritised</a:t>
+            </a:r>
+          </a:p>
+          <a:p>
+            <a:pPr algn="l" indent="-110000" marL="110000">
+              <a:lnSpc>
+                <a:spcPct val="102000"/>
+              </a:lnSpc>
+              <a:spcBef>
+                <a:spcPts val="0"/>
+              </a:spcBef>
+              <a:spcAft>
+                <a:spcPts val="320"/>
+              </a:spcAft>
+            </a:pPr>
+            <a:r>
+              <a:rPr sz="700" b="0" i="0">
+                <a:solidFill>
+                  <a:srgbClr val="1F3763"/>
+                </a:solidFill>
+                <a:latin typeface="Manrope"/>
+                <a:cs typeface="Manrope"/>
+              </a:rPr>
+              <a:t>● </a:t>
+            </a:r>
+            <a:r>
+              <a:rPr sz="720" b="1" i="0">
+                <a:solidFill>
+                  <a:srgbClr val="25303B"/>
+                </a:solidFill>
+                <a:latin typeface="Manrope"/>
+                <a:cs typeface="Manrope"/>
+              </a:rPr>
+              <a:t>CM-791  </a:t>
+            </a:r>
+            <a:r>
+              <a:rPr sz="720" b="0" i="0">
+                <a:solidFill>
+                  <a:srgbClr val="25303B"/>
+                </a:solidFill>
+                <a:latin typeface="Manrope"/>
+                <a:cs typeface="Manrope"/>
+              </a:rPr>
+              <a:t>TDS transparency + self-serve TDS declaration in FO App  </a:t>
+            </a:r>
+            <a:r>
+              <a:rPr sz="640" b="1" i="1">
+                <a:solidFill>
+                  <a:srgbClr val="6043A3"/>
+                </a:solidFill>
+                <a:latin typeface="Manrope"/>
+                <a:cs typeface="Manrope"/>
+              </a:rPr>
+              <a:t>Prioritised</a:t>
+            </a:r>
+          </a:p>
+          <a:p>
+            <a:pPr algn="l" indent="-110000" marL="110000">
+              <a:lnSpc>
+                <a:spcPct val="102000"/>
+              </a:lnSpc>
+              <a:spcBef>
+                <a:spcPts val="0"/>
+              </a:spcBef>
+              <a:spcAft>
+                <a:spcPts val="320"/>
+              </a:spcAft>
+            </a:pPr>
+            <a:r>
+              <a:rPr sz="700" b="0" i="0">
+                <a:solidFill>
+                  <a:srgbClr val="26815C"/>
+                </a:solidFill>
+                <a:latin typeface="Manrope"/>
+                <a:cs typeface="Manrope"/>
+              </a:rPr>
+              <a:t>● </a:t>
+            </a:r>
+            <a:r>
+              <a:rPr sz="720" b="1" i="0">
+                <a:solidFill>
+                  <a:srgbClr val="25303B"/>
+                </a:solidFill>
+                <a:latin typeface="Manrope"/>
+                <a:cs typeface="Manrope"/>
+              </a:rPr>
+              <a:t>CM-821  </a:t>
+            </a:r>
+            <a:r>
+              <a:rPr sz="720" b="0" i="0">
+                <a:solidFill>
+                  <a:srgbClr val="25303B"/>
+                </a:solidFill>
+                <a:latin typeface="Manrope"/>
+                <a:cs typeface="Manrope"/>
+              </a:rPr>
+              <a:t>Auto CRM alerts: bids received / inventory matched / approval assigned  </a:t>
+            </a:r>
+            <a:r>
+              <a:rPr sz="640" b="1" i="1">
+                <a:solidFill>
+                  <a:srgbClr val="6043A3"/>
+                </a:solidFill>
+                <a:latin typeface="Manrope"/>
+                <a:cs typeface="Manrope"/>
+              </a:rPr>
+              <a:t>Prioritised</a:t>
+            </a:r>
+          </a:p>
+          <a:p>
+            <a:pPr algn="l" indent="-110000" marL="110000">
+              <a:lnSpc>
+                <a:spcPct val="102000"/>
+              </a:lnSpc>
+              <a:spcBef>
+                <a:spcPts val="0"/>
+              </a:spcBef>
+              <a:spcAft>
+                <a:spcPts val="320"/>
+              </a:spcAft>
+            </a:pPr>
+            <a:r>
+              <a:rPr sz="700" b="0" i="0">
+                <a:solidFill>
+                  <a:srgbClr val="26815C"/>
+                </a:solidFill>
+                <a:latin typeface="Manrope"/>
+                <a:cs typeface="Manrope"/>
+              </a:rPr>
+              <a:t>● </a:t>
+            </a:r>
+            <a:r>
+              <a:rPr sz="720" b="1" i="0">
+                <a:solidFill>
+                  <a:srgbClr val="25303B"/>
+                </a:solidFill>
+                <a:latin typeface="Manrope"/>
+                <a:cs typeface="Manrope"/>
+              </a:rPr>
+              <a:t>CM-377  </a:t>
+            </a:r>
+            <a:r>
+              <a:rPr sz="720" b="0" i="0">
+                <a:solidFill>
+                  <a:srgbClr val="25303B"/>
+                </a:solidFill>
+                <a:latin typeface="Manrope"/>
+                <a:cs typeface="Manrope"/>
+              </a:rPr>
+              <a:t>Sort demand by Demand Actionability Score to prioritise loads  </a:t>
+            </a:r>
+            <a:r>
+              <a:rPr sz="640" b="1" i="1">
+                <a:solidFill>
+                  <a:srgbClr val="6B7480"/>
+                </a:solidFill>
+                <a:latin typeface="Manrope"/>
+                <a:cs typeface="Manrope"/>
+              </a:rPr>
+              <a:t>Planned</a:t>
+            </a:r>
+          </a:p>
+          <a:p>
+            <a:pPr algn="l" indent="-110000" marL="110000">
+              <a:lnSpc>
+                <a:spcPct val="102000"/>
+              </a:lnSpc>
+              <a:spcBef>
+                <a:spcPts val="0"/>
+              </a:spcBef>
+              <a:spcAft>
+                <a:spcPts val="320"/>
+              </a:spcAft>
+            </a:pPr>
+            <a:r>
+              <a:rPr sz="700" b="0" i="0">
+                <a:solidFill>
+                  <a:srgbClr val="26815C"/>
+                </a:solidFill>
+                <a:latin typeface="Manrope"/>
+                <a:cs typeface="Manrope"/>
+              </a:rPr>
+              <a:t>● </a:t>
+            </a:r>
+            <a:r>
+              <a:rPr sz="720" b="1" i="0">
+                <a:solidFill>
+                  <a:srgbClr val="25303B"/>
+                </a:solidFill>
+                <a:latin typeface="Manrope"/>
+                <a:cs typeface="Manrope"/>
+              </a:rPr>
+              <a:t>CM-823  </a:t>
+            </a:r>
+            <a:r>
+              <a:rPr sz="720" b="0" i="0">
+                <a:solidFill>
+                  <a:srgbClr val="25303B"/>
+                </a:solidFill>
+                <a:latin typeface="Manrope"/>
+                <a:cs typeface="Manrope"/>
+              </a:rPr>
+              <a:t>Build vehicle heat-map for location movement  </a:t>
+            </a:r>
+            <a:r>
+              <a:rPr sz="640" b="1" i="1">
+                <a:solidFill>
+                  <a:srgbClr val="6B7480"/>
+                </a:solidFill>
+                <a:latin typeface="Manrope"/>
+                <a:cs typeface="Manrope"/>
+              </a:rPr>
+              <a:t>Planned</a:t>
+            </a:r>
+          </a:p>
+          <a:p>
+            <a:pPr algn="l" indent="-110000" marL="110000">
+              <a:lnSpc>
+                <a:spcPct val="102000"/>
+              </a:lnSpc>
+              <a:spcBef>
+                <a:spcPts val="0"/>
+              </a:spcBef>
+              <a:spcAft>
+                <a:spcPts val="320"/>
+              </a:spcAft>
+            </a:pPr>
+            <a:r>
+              <a:rPr sz="700" b="0" i="0">
+                <a:solidFill>
+                  <a:srgbClr val="26815C"/>
+                </a:solidFill>
+                <a:latin typeface="Manrope"/>
+                <a:cs typeface="Manrope"/>
+              </a:rPr>
+              <a:t>● </a:t>
+            </a:r>
+            <a:r>
+              <a:rPr sz="720" b="0" i="0">
+                <a:solidFill>
+                  <a:srgbClr val="25303B"/>
+                </a:solidFill>
+                <a:latin typeface="Manrope"/>
+                <a:cs typeface="Manrope"/>
+              </a:rPr>
+              <a:t>Auto-add vehicle to tracking master on trip completion (raise trackable count)  </a:t>
+            </a:r>
+            <a:r>
+              <a:rPr sz="640" b="1" i="1">
+                <a:solidFill>
+                  <a:srgbClr val="6B7480"/>
+                </a:solidFill>
+                <a:latin typeface="Manrope"/>
+                <a:cs typeface="Manrope"/>
+              </a:rPr>
+              <a:t>Planned</a:t>
+            </a:r>
+          </a:p>
+          <a:p>
+            <a:pPr algn="l" indent="-110000" marL="110000">
+              <a:lnSpc>
+                <a:spcPct val="102000"/>
+              </a:lnSpc>
+              <a:spcBef>
+                <a:spcPts val="0"/>
+              </a:spcBef>
+              <a:spcAft>
+                <a:spcPts val="320"/>
+              </a:spcAft>
+            </a:pPr>
+            <a:r>
+              <a:rPr sz="700" b="0" i="0">
+                <a:solidFill>
+                  <a:srgbClr val="26815C"/>
+                </a:solidFill>
+                <a:latin typeface="Manrope"/>
+                <a:cs typeface="Manrope"/>
+              </a:rPr>
+              <a:t>● </a:t>
+            </a:r>
+            <a:r>
+              <a:rPr sz="720" b="1" i="0">
+                <a:solidFill>
+                  <a:srgbClr val="25303B"/>
+                </a:solidFill>
+                <a:latin typeface="Manrope"/>
+                <a:cs typeface="Manrope"/>
+              </a:rPr>
+              <a:t>CM-824  </a:t>
+            </a:r>
+            <a:r>
+              <a:rPr sz="720" b="0" i="0">
+                <a:solidFill>
+                  <a:srgbClr val="25303B"/>
+                </a:solidFill>
+                <a:latin typeface="Manrope"/>
+                <a:cs typeface="Manrope"/>
+              </a:rPr>
+              <a:t>In-CRM calling with callback on unanswered calls  </a:t>
+            </a:r>
+            <a:r>
+              <a:rPr sz="640" b="1" i="1">
+                <a:solidFill>
+                  <a:srgbClr val="6B7480"/>
+                </a:solidFill>
+                <a:latin typeface="Manrope"/>
+                <a:cs typeface="Manrope"/>
+              </a:rPr>
+              <a:t>Planned</a:t>
+            </a:r>
+          </a:p>
+          <a:p>
+            <a:pPr algn="l" indent="-110000" marL="110000">
+              <a:lnSpc>
+                <a:spcPct val="102000"/>
+              </a:lnSpc>
+              <a:spcBef>
+                <a:spcPts val="0"/>
+              </a:spcBef>
+              <a:spcAft>
+                <a:spcPts val="320"/>
+              </a:spcAft>
+            </a:pPr>
+            <a:r>
+              <a:rPr sz="700" b="0" i="0">
+                <a:solidFill>
+                  <a:srgbClr val="6043A3"/>
+                </a:solidFill>
+                <a:latin typeface="Manrope"/>
+                <a:cs typeface="Manrope"/>
+              </a:rPr>
+              <a:t>● </a:t>
+            </a:r>
+            <a:r>
+              <a:rPr sz="720" b="1" i="0">
+                <a:solidFill>
+                  <a:srgbClr val="25303B"/>
+                </a:solidFill>
+                <a:latin typeface="Manrope"/>
+                <a:cs typeface="Manrope"/>
+              </a:rPr>
+              <a:t>CM-826  </a:t>
+            </a:r>
+            <a:r>
+              <a:rPr sz="720" b="0" i="0">
+                <a:solidFill>
+                  <a:srgbClr val="25303B"/>
+                </a:solidFill>
+                <a:latin typeface="Manrope"/>
+                <a:cs typeface="Manrope"/>
+              </a:rPr>
+              <a:t>Ticketing for FOs not on the app (WhatsApp / IVR / agent)  </a:t>
+            </a:r>
+            <a:r>
+              <a:rPr sz="640" b="1" i="1">
+                <a:solidFill>
+                  <a:srgbClr val="6B7480"/>
+                </a:solidFill>
+                <a:latin typeface="Manrope"/>
+                <a:cs typeface="Manrope"/>
+              </a:rPr>
+              <a:t>Planned</a:t>
+            </a:r>
+          </a:p>
+          <a:p>
+            <a:pPr algn="l" indent="-110000" marL="110000">
+              <a:lnSpc>
+                <a:spcPct val="102000"/>
+              </a:lnSpc>
+              <a:spcBef>
+                <a:spcPts val="0"/>
+              </a:spcBef>
+              <a:spcAft>
+                <a:spcPts val="320"/>
+              </a:spcAft>
+            </a:pPr>
+            <a:r>
+              <a:rPr sz="700" b="0" i="0">
+                <a:solidFill>
+                  <a:srgbClr val="C77D0A"/>
+                </a:solidFill>
+                <a:latin typeface="Manrope"/>
+                <a:cs typeface="Manrope"/>
+              </a:rPr>
+              <a:t>● </a:t>
+            </a:r>
+            <a:r>
+              <a:rPr sz="720" b="1" i="0">
+                <a:solidFill>
+                  <a:srgbClr val="25303B"/>
+                </a:solidFill>
+                <a:latin typeface="Manrope"/>
+                <a:cs typeface="Manrope"/>
+              </a:rPr>
+              <a:t>CM-825  </a:t>
+            </a:r>
+            <a:r>
+              <a:rPr sz="720" b="0" i="0">
+                <a:solidFill>
+                  <a:srgbClr val="25303B"/>
+                </a:solidFill>
+                <a:latin typeface="Manrope"/>
+                <a:cs typeface="Manrope"/>
+              </a:rPr>
+              <a:t>Auto-share loading location to driver (call + WhatsApp)  </a:t>
+            </a:r>
+            <a:r>
+              <a:rPr sz="640" b="1" i="1">
+                <a:solidFill>
+                  <a:srgbClr val="6B7480"/>
+                </a:solidFill>
+                <a:latin typeface="Manrope"/>
+                <a:cs typeface="Manrope"/>
+              </a:rPr>
+              <a:t>Planned</a:t>
+            </a:r>
+          </a:p>
+        </p:txBody>
+      </p:sp>
+      <p:sp>
+        <p:nvSpPr>
+          <p:cNvPr id="24" name="Rounded Rectangle 23"/>
+          <p:cNvSpPr/>
+          <p:nvPr/>
+        </p:nvSpPr>
+        <p:spPr>
+          <a:xfrm>
+            <a:off x="6050466" y="966000"/>
+            <a:ext cx="2864933" cy="2854000"/>
+          </a:xfrm>
+          <a:prstGeom prst="roundRect">
+            <a:avLst>
+              <a:gd name="adj" fmla="val 9000"/>
+            </a:avLst>
+          </a:prstGeom>
+          <a:solidFill>
+            <a:srgbClr val="F7F8FA"/>
+          </a:solidFill>
+          <a:ln w="6350">
+            <a:solidFill>
+              <a:srgbClr val="D5DAE1"/>
+            </a:solidFill>
+          </a:ln>
+          <a:effectLst/>
+        </p:spPr>
+        <p:style>
+          <a:lnRef idx="1">
+            <a:schemeClr val="accent1"/>
+          </a:lnRef>
+          <a:fillRef idx="3">
+            <a:schemeClr val="accent1"/>
+          </a:fillRef>
+          <a:effectRef idx="2">
+            <a:schemeClr val="accent1"/>
+          </a:effectRef>
+          <a:fontRef idx="minor">
+            <a:schemeClr val="lt1"/>
+          </a:fontRef>
+        </p:style>
+        <p:txBody>
+          <a:bodyPr rtlCol="0" anchor="ctr"/>
+          <a:lstStyle/>
+          <a:p>
+            <a:pPr algn="ctr"/>
+          </a:p>
+        </p:txBody>
+      </p:sp>
+      <p:sp>
+        <p:nvSpPr>
+          <p:cNvPr id="25" name="Rounded Rectangle 24"/>
+          <p:cNvSpPr/>
+          <p:nvPr/>
+        </p:nvSpPr>
+        <p:spPr>
+          <a:xfrm>
+            <a:off x="6050466" y="966000"/>
+            <a:ext cx="2864933" cy="250000"/>
+          </a:xfrm>
+          <a:prstGeom prst="roundRect">
+            <a:avLst>
+              <a:gd name="adj" fmla="val 9000"/>
+            </a:avLst>
+          </a:prstGeom>
+          <a:solidFill>
+            <a:srgbClr val="3E4C63"/>
+          </a:solidFill>
+          <a:ln>
+            <a:noFill/>
+          </a:ln>
+          <a:effectLst/>
+        </p:spPr>
+        <p:style>
+          <a:lnRef idx="1">
+            <a:schemeClr val="accent1"/>
+          </a:lnRef>
+          <a:fillRef idx="3">
+            <a:schemeClr val="accent1"/>
+          </a:fillRef>
+          <a:effectRef idx="2">
+            <a:schemeClr val="accent1"/>
+          </a:effectRef>
+          <a:fontRef idx="minor">
+            <a:schemeClr val="lt1"/>
+          </a:fontRef>
+        </p:style>
+        <p:txBody>
+          <a:bodyPr rtlCol="0" anchor="ctr"/>
+          <a:lstStyle/>
+          <a:p>
+            <a:pPr algn="ctr"/>
+          </a:p>
+        </p:txBody>
+      </p:sp>
+      <p:sp>
+        <p:nvSpPr>
+          <p:cNvPr id="26" name="TextBox 25"/>
+          <p:cNvSpPr txBox="1"/>
+          <p:nvPr/>
+        </p:nvSpPr>
+        <p:spPr>
+          <a:xfrm>
+            <a:off x="6120466" y="966000"/>
+            <a:ext cx="2774933" cy="250000"/>
+          </a:xfrm>
+          <a:prstGeom prst="rect">
+            <a:avLst/>
+          </a:prstGeom>
+          <a:noFill/>
+        </p:spPr>
+        <p:txBody>
+          <a:bodyPr wrap="square" anchor="ctr" lIns="0" rIns="0" tIns="0" bIns="0">
+            <a:spAutoFit/>
+          </a:bodyPr>
+          <a:lstStyle/>
+          <a:p>
+            <a:pPr algn="l">
+              <a:lnSpc>
+                <a:spcPct val="100000"/>
+              </a:lnSpc>
+              <a:spcBef>
+                <a:spcPts val="0"/>
+              </a:spcBef>
+              <a:spcAft>
+                <a:spcPts val="0"/>
+              </a:spcAft>
+            </a:pPr>
+            <a:r>
+              <a:rPr sz="1000" b="1" i="0">
+                <a:solidFill>
+                  <a:srgbClr val="FFFFFF"/>
+                </a:solidFill>
+                <a:latin typeface="Manrope"/>
+                <a:cs typeface="Manrope"/>
+              </a:rPr>
+              <a:t>SEPTEMBER   </a:t>
+            </a:r>
+            <a:r>
+              <a:rPr sz="850" b="1" i="0">
+                <a:solidFill>
+                  <a:srgbClr val="C5CCD6"/>
+                </a:solidFill>
+                <a:latin typeface="Manrope"/>
+                <a:cs typeface="Manrope"/>
+              </a:rPr>
+              <a:t>(6)</a:t>
+            </a:r>
+          </a:p>
+        </p:txBody>
+      </p:sp>
+      <p:sp>
+        <p:nvSpPr>
+          <p:cNvPr id="27" name="TextBox 26"/>
+          <p:cNvSpPr txBox="1"/>
+          <p:nvPr/>
+        </p:nvSpPr>
+        <p:spPr>
+          <a:xfrm>
+            <a:off x="6114466" y="1272000"/>
+            <a:ext cx="2754933" cy="2548000"/>
+          </a:xfrm>
+          <a:prstGeom prst="rect">
+            <a:avLst/>
+          </a:prstGeom>
+          <a:noFill/>
+        </p:spPr>
+        <p:txBody>
+          <a:bodyPr wrap="square" anchor="t" lIns="0" rIns="0" tIns="0" bIns="0">
+            <a:spAutoFit/>
+          </a:bodyPr>
+          <a:lstStyle/>
+          <a:p>
+            <a:pPr algn="l" indent="-110000" marL="110000">
+              <a:lnSpc>
+                <a:spcPct val="102000"/>
+              </a:lnSpc>
+              <a:spcBef>
+                <a:spcPts val="0"/>
+              </a:spcBef>
+              <a:spcAft>
+                <a:spcPts val="320"/>
+              </a:spcAft>
+            </a:pPr>
+            <a:r>
+              <a:rPr sz="700" b="0" i="0">
+                <a:solidFill>
+                  <a:srgbClr val="1F3763"/>
+                </a:solidFill>
+                <a:latin typeface="Manrope"/>
+                <a:cs typeface="Manrope"/>
+              </a:rPr>
+              <a:t>● </a:t>
+            </a:r>
+            <a:r>
+              <a:rPr sz="720" b="1" i="0">
+                <a:solidFill>
+                  <a:srgbClr val="25303B"/>
+                </a:solidFill>
+                <a:latin typeface="Manrope"/>
+                <a:cs typeface="Manrope"/>
+              </a:rPr>
+              <a:t>CM-828  </a:t>
+            </a:r>
+            <a:r>
+              <a:rPr sz="720" b="0" i="0">
+                <a:solidFill>
+                  <a:srgbClr val="25303B"/>
+                </a:solidFill>
+                <a:latin typeface="Manrope"/>
+                <a:cs typeface="Manrope"/>
+              </a:rPr>
+              <a:t>Configurable LSP exposure limit + auto-disable on breach  </a:t>
+            </a:r>
+            <a:r>
+              <a:rPr sz="640" b="1" i="1">
+                <a:solidFill>
+                  <a:srgbClr val="6B7480"/>
+                </a:solidFill>
+                <a:latin typeface="Manrope"/>
+                <a:cs typeface="Manrope"/>
+              </a:rPr>
+              <a:t>Planned</a:t>
+            </a:r>
+          </a:p>
+          <a:p>
+            <a:pPr algn="l" indent="-110000" marL="110000">
+              <a:lnSpc>
+                <a:spcPct val="102000"/>
+              </a:lnSpc>
+              <a:spcBef>
+                <a:spcPts val="0"/>
+              </a:spcBef>
+              <a:spcAft>
+                <a:spcPts val="320"/>
+              </a:spcAft>
+            </a:pPr>
+            <a:r>
+              <a:rPr sz="700" b="0" i="0">
+                <a:solidFill>
+                  <a:srgbClr val="26815C"/>
+                </a:solidFill>
+                <a:latin typeface="Manrope"/>
+                <a:cs typeface="Manrope"/>
+              </a:rPr>
+              <a:t>● </a:t>
+            </a:r>
+            <a:r>
+              <a:rPr sz="720" b="0" i="0">
+                <a:solidFill>
+                  <a:srgbClr val="25303B"/>
+                </a:solidFill>
+                <a:latin typeface="Manrope"/>
+                <a:cs typeface="Manrope"/>
+              </a:rPr>
+              <a:t>Agentic-AI calling for fulfilment agents  </a:t>
+            </a:r>
+            <a:r>
+              <a:rPr sz="640" b="1" i="1">
+                <a:solidFill>
+                  <a:srgbClr val="6B7480"/>
+                </a:solidFill>
+                <a:latin typeface="Manrope"/>
+                <a:cs typeface="Manrope"/>
+              </a:rPr>
+              <a:t>Planned</a:t>
+            </a:r>
+          </a:p>
+          <a:p>
+            <a:pPr algn="l" indent="-110000" marL="110000">
+              <a:lnSpc>
+                <a:spcPct val="102000"/>
+              </a:lnSpc>
+              <a:spcBef>
+                <a:spcPts val="0"/>
+              </a:spcBef>
+              <a:spcAft>
+                <a:spcPts val="320"/>
+              </a:spcAft>
+            </a:pPr>
+            <a:r>
+              <a:rPr sz="700" b="0" i="0">
+                <a:solidFill>
+                  <a:srgbClr val="26815C"/>
+                </a:solidFill>
+                <a:latin typeface="Manrope"/>
+                <a:cs typeface="Manrope"/>
+              </a:rPr>
+              <a:t>● </a:t>
+            </a:r>
+            <a:r>
+              <a:rPr sz="720" b="1" i="0">
+                <a:solidFill>
+                  <a:srgbClr val="25303B"/>
+                </a:solidFill>
+                <a:latin typeface="Manrope"/>
+                <a:cs typeface="Manrope"/>
+              </a:rPr>
+              <a:t>CM-829  </a:t>
+            </a:r>
+            <a:r>
+              <a:rPr sz="720" b="0" i="0">
+                <a:solidFill>
+                  <a:srgbClr val="25303B"/>
+                </a:solidFill>
+                <a:latin typeface="Manrope"/>
+                <a:cs typeface="Manrope"/>
+              </a:rPr>
+              <a:t>Live target dashboard — LSP / PSA-CSM / City-wise  </a:t>
+            </a:r>
+            <a:r>
+              <a:rPr sz="640" b="1" i="1">
+                <a:solidFill>
+                  <a:srgbClr val="6B7480"/>
+                </a:solidFill>
+                <a:latin typeface="Manrope"/>
+                <a:cs typeface="Manrope"/>
+              </a:rPr>
+              <a:t>Planned</a:t>
+            </a:r>
+          </a:p>
+          <a:p>
+            <a:pPr algn="l" indent="-110000" marL="110000">
+              <a:lnSpc>
+                <a:spcPct val="102000"/>
+              </a:lnSpc>
+              <a:spcBef>
+                <a:spcPts val="0"/>
+              </a:spcBef>
+              <a:spcAft>
+                <a:spcPts val="320"/>
+              </a:spcAft>
+            </a:pPr>
+            <a:r>
+              <a:rPr sz="700" b="0" i="0">
+                <a:solidFill>
+                  <a:srgbClr val="6043A3"/>
+                </a:solidFill>
+                <a:latin typeface="Manrope"/>
+                <a:cs typeface="Manrope"/>
+              </a:rPr>
+              <a:t>● </a:t>
+            </a:r>
+            <a:r>
+              <a:rPr sz="720" b="1" i="0">
+                <a:solidFill>
+                  <a:srgbClr val="25303B"/>
+                </a:solidFill>
+                <a:latin typeface="Manrope"/>
+                <a:cs typeface="Manrope"/>
+              </a:rPr>
+              <a:t>CM-820  </a:t>
+            </a:r>
+            <a:r>
+              <a:rPr sz="720" b="0" i="0">
+                <a:solidFill>
+                  <a:srgbClr val="25303B"/>
+                </a:solidFill>
+                <a:latin typeface="Manrope"/>
+                <a:cs typeface="Manrope"/>
+              </a:rPr>
+              <a:t>FO App: capture trip charges directly with approval flow  </a:t>
+            </a:r>
+            <a:r>
+              <a:rPr sz="640" b="1" i="1">
+                <a:solidFill>
+                  <a:srgbClr val="6043A3"/>
+                </a:solidFill>
+                <a:latin typeface="Manrope"/>
+                <a:cs typeface="Manrope"/>
+              </a:rPr>
+              <a:t>Prioritised</a:t>
+            </a:r>
+          </a:p>
+          <a:p>
+            <a:pPr algn="l" indent="-110000" marL="110000">
+              <a:lnSpc>
+                <a:spcPct val="102000"/>
+              </a:lnSpc>
+              <a:spcBef>
+                <a:spcPts val="0"/>
+              </a:spcBef>
+              <a:spcAft>
+                <a:spcPts val="320"/>
+              </a:spcAft>
+            </a:pPr>
+            <a:r>
+              <a:rPr sz="700" b="0" i="0">
+                <a:solidFill>
+                  <a:srgbClr val="C77D0A"/>
+                </a:solidFill>
+                <a:latin typeface="Manrope"/>
+                <a:cs typeface="Manrope"/>
+              </a:rPr>
+              <a:t>● </a:t>
+            </a:r>
+            <a:r>
+              <a:rPr sz="720" b="1" i="0">
+                <a:solidFill>
+                  <a:srgbClr val="25303B"/>
+                </a:solidFill>
+                <a:latin typeface="Manrope"/>
+                <a:cs typeface="Manrope"/>
+              </a:rPr>
+              <a:t>CM-827  </a:t>
+            </a:r>
+            <a:r>
+              <a:rPr sz="720" b="0" i="0">
+                <a:solidFill>
+                  <a:srgbClr val="25303B"/>
+                </a:solidFill>
+                <a:latin typeface="Manrope"/>
+                <a:cs typeface="Manrope"/>
+              </a:rPr>
+              <a:t>Automate compliance document generation  </a:t>
+            </a:r>
+            <a:r>
+              <a:rPr sz="640" b="1" i="1">
+                <a:solidFill>
+                  <a:srgbClr val="6B7480"/>
+                </a:solidFill>
+                <a:latin typeface="Manrope"/>
+                <a:cs typeface="Manrope"/>
+              </a:rPr>
+              <a:t>Planned</a:t>
+            </a:r>
+          </a:p>
+          <a:p>
+            <a:pPr algn="l" indent="-110000" marL="110000">
+              <a:lnSpc>
+                <a:spcPct val="102000"/>
+              </a:lnSpc>
+              <a:spcBef>
+                <a:spcPts val="0"/>
+              </a:spcBef>
+              <a:spcAft>
+                <a:spcPts val="320"/>
+              </a:spcAft>
+            </a:pPr>
+            <a:r>
+              <a:rPr sz="700" b="0" i="0">
+                <a:solidFill>
+                  <a:srgbClr val="C77D0A"/>
+                </a:solidFill>
+                <a:latin typeface="Manrope"/>
+                <a:cs typeface="Manrope"/>
+              </a:rPr>
+              <a:t>● </a:t>
+            </a:r>
+            <a:r>
+              <a:rPr sz="720" b="1" i="0">
+                <a:solidFill>
+                  <a:srgbClr val="25303B"/>
+                </a:solidFill>
+                <a:latin typeface="Manrope"/>
+                <a:cs typeface="Manrope"/>
+              </a:rPr>
+              <a:t>CM-822  </a:t>
+            </a:r>
+            <a:r>
+              <a:rPr sz="720" b="0" i="0">
+                <a:solidFill>
+                  <a:srgbClr val="25303B"/>
+                </a:solidFill>
+                <a:latin typeface="Manrope"/>
+                <a:cs typeface="Manrope"/>
+              </a:rPr>
+              <a:t>Automate POD audit via OCR  </a:t>
+            </a:r>
+            <a:r>
+              <a:rPr sz="640" b="1" i="1">
+                <a:solidFill>
+                  <a:srgbClr val="6043A3"/>
+                </a:solidFill>
+                <a:latin typeface="Manrope"/>
+                <a:cs typeface="Manrope"/>
+              </a:rPr>
+              <a:t>Prioritised</a:t>
+            </a:r>
+          </a:p>
+        </p:txBody>
+      </p:sp>
+      <p:sp>
+        <p:nvSpPr>
+          <p:cNvPr id="28" name="Rounded Rectangle 27"/>
+          <p:cNvSpPr/>
+          <p:nvPr/>
+        </p:nvSpPr>
+        <p:spPr>
+          <a:xfrm>
+            <a:off x="228600" y="3860000"/>
+            <a:ext cx="8686800" cy="530000"/>
+          </a:xfrm>
+          <a:prstGeom prst="roundRect">
+            <a:avLst>
+              <a:gd name="adj" fmla="val 9000"/>
+            </a:avLst>
+          </a:prstGeom>
+          <a:solidFill>
+            <a:srgbClr val="F4F6F9"/>
+          </a:solidFill>
+          <a:ln>
+            <a:noFill/>
+          </a:ln>
+          <a:effectLst/>
+        </p:spPr>
+        <p:style>
+          <a:lnRef idx="1">
+            <a:schemeClr val="accent1"/>
+          </a:lnRef>
+          <a:fillRef idx="3">
+            <a:schemeClr val="accent1"/>
+          </a:fillRef>
+          <a:effectRef idx="2">
+            <a:schemeClr val="accent1"/>
+          </a:effectRef>
+          <a:fontRef idx="minor">
+            <a:schemeClr val="lt1"/>
+          </a:fontRef>
+        </p:style>
+        <p:txBody>
+          <a:bodyPr rtlCol="0" anchor="ctr"/>
+          <a:lstStyle/>
+          <a:p>
+            <a:pPr algn="ctr"/>
+          </a:p>
+        </p:txBody>
+      </p:sp>
+      <p:sp>
+        <p:nvSpPr>
+          <p:cNvPr id="29" name="TextBox 28"/>
+          <p:cNvSpPr txBox="1"/>
+          <p:nvPr/>
+        </p:nvSpPr>
+        <p:spPr>
+          <a:xfrm>
+            <a:off x="318600" y="3894000"/>
+            <a:ext cx="8506800" cy="470000"/>
+          </a:xfrm>
+          <a:prstGeom prst="rect">
+            <a:avLst/>
+          </a:prstGeom>
+          <a:noFill/>
+        </p:spPr>
+        <p:txBody>
+          <a:bodyPr wrap="square" anchor="ctr" lIns="0" rIns="0" tIns="0" bIns="0">
+            <a:spAutoFit/>
+          </a:bodyPr>
+          <a:lstStyle/>
+          <a:p>
+            <a:pPr algn="l">
+              <a:lnSpc>
+                <a:spcPct val="105000"/>
+              </a:lnSpc>
+              <a:spcBef>
+                <a:spcPts val="0"/>
+              </a:spcBef>
+              <a:spcAft>
+                <a:spcPts val="300"/>
+              </a:spcAft>
+            </a:pPr>
+            <a:r>
+              <a:rPr sz="860" b="1" i="0">
+                <a:solidFill>
+                  <a:srgbClr val="1F3763"/>
+                </a:solidFill>
+                <a:latin typeface="Manrope"/>
+                <a:cs typeface="Manrope"/>
+              </a:rPr>
+              <a:t>Notes for leadership   </a:t>
+            </a:r>
+            <a:r>
+              <a:rPr sz="819" b="0" i="0">
+                <a:solidFill>
+                  <a:srgbClr val="25303B"/>
+                </a:solidFill>
+                <a:latin typeface="Manrope"/>
+                <a:cs typeface="Manrope"/>
+              </a:rPr>
+              <a:t>Q2 exit targets: DAU → 500 · network-lane conversion → 20% · MS+FinOps bandwidth −30%  (25% / 50% are FY27 annual targets).</a:t>
+            </a:r>
+          </a:p>
+          <a:p>
+            <a:pPr algn="l">
+              <a:lnSpc>
+                <a:spcPct val="105000"/>
+              </a:lnSpc>
+              <a:spcBef>
+                <a:spcPts val="0"/>
+              </a:spcBef>
+              <a:spcAft>
+                <a:spcPts val="0"/>
+              </a:spcAft>
+            </a:pPr>
+            <a:r>
+              <a:rPr sz="819" b="0" i="0">
+                <a:solidFill>
+                  <a:srgbClr val="25303B"/>
+                </a:solidFill>
+                <a:latin typeface="Manrope"/>
+                <a:cs typeface="Manrope"/>
+              </a:rPr>
+              <a:t>Network-lane conversion (Q1 FY27 actuals): Apr 13.7% → May 11.2% → Jun 17.1% — entering Q2 at ~17%, the plan above targets a 20% exit.</a:t>
+            </a:r>
+          </a:p>
+        </p:txBody>
+      </p:sp>
+    </p:spTree>
+  </p:cSld>
+  <p:clrMapOvr>
+    <a:masterClrMapping/>
+  </p:clrMapOvr>
+</p:sld>
+</file>
+
 <file path=ppt/theme/theme1.xml><?xml version="1.0" encoding="utf-8"?>
 <a:theme xmlns:a="http://schemas.openxmlformats.org/drawingml/2006/main" xmlns:r="http://schemas.openxmlformats.org/officeDocument/2006/relationships">
   <a:themeElements>

</xml_diff>

<commit_message>
Restructure roadmap slide to Month - Goal - task summary
Roll individual CM tickets up into one summary per goal (Ledger / Fulfilment%
/ DAU / Reduce Ops Bandwidth) within each month, with story counts and
colour-coded accents instead of listing every ticket.

Co-Authored-By: Claude Opus 4.8 <noreply@anthropic.com>
Claude-Session: https://claude.ai/code/session_01HTHNkMyy3hCJ7Wqf5x3kDZ
</commit_message>
<xml_diff>
--- a/board_review_q2_2026/TML_Review_CM_AprMayJun_2026_BoardReview.pptx
+++ b/board_review_q2_2026/TML_Review_CM_AprMayJun_2026_BoardReview.pptx
@@ -21695,8 +21695,8 @@
         </p:nvSpPr>
         <p:spPr>
           <a:xfrm>
-            <a:off x="228600" y="966000"/>
-            <a:ext cx="2864933" cy="2854000"/>
+            <a:off x="228600" y="980000"/>
+            <a:ext cx="2864933" cy="3320000"/>
           </a:xfrm>
           <a:prstGeom prst="roundRect">
             <a:avLst>
@@ -21743,7 +21743,7 @@
         </p:nvSpPr>
         <p:spPr>
           <a:xfrm>
-            <a:off x="228600" y="966000"/>
+            <a:off x="228600" y="980000"/>
             <a:ext cx="2864933" cy="250000"/>
           </a:xfrm>
           <a:prstGeom prst="roundRect">
@@ -21789,8 +21789,8 @@
         </p:nvSpPr>
         <p:spPr>
           <a:xfrm>
-            <a:off x="298600" y="966000"/>
-            <a:ext cx="2774933" cy="250000"/>
+            <a:off x="308600" y="980000"/>
+            <a:ext cx="2764933" cy="250000"/>
           </a:xfrm>
           <a:prstGeom prst="rect">
             <a:avLst/>
@@ -21815,38 +21815,84 @@
               </a:spcAft>
             </a:pPr>
             <a:r>
-              <a:rPr sz="1000" b="1" i="0">
+              <a:rPr sz="1100" b="1" i="0">
                 <a:solidFill>
                   <a:srgbClr val="FFFFFF"/>
                 </a:solidFill>
                 <a:latin typeface="Manrope"/>
                 <a:cs typeface="Manrope"/>
               </a:rPr>
-              <a:t>JULY   </a:t>
+              <a:t>JULY    </a:t>
             </a:r>
             <a:r>
-              <a:rPr sz="850" b="1" i="0">
+              <a:rPr sz="800" b="1" i="0">
                 <a:solidFill>
                   <a:srgbClr val="C5CCD6"/>
                 </a:solidFill>
                 <a:latin typeface="Manrope"/>
                 <a:cs typeface="Manrope"/>
               </a:rPr>
-              <a:t>(12)</a:t>
+              <a:t>12 stories</a:t>
             </a:r>
           </a:p>
         </p:txBody>
       </p:sp>
       <p:sp>
         <p:nvSpPr>
-          <p:cNvPr id="19" name="TextBox 18"/>
+          <p:cNvPr id="19" name="Rounded Rectangle 18"/>
+          <p:cNvSpPr/>
+          <p:nvPr/>
+        </p:nvSpPr>
+        <p:spPr>
+          <a:xfrm>
+            <a:off x="284600" y="1272000"/>
+            <a:ext cx="44000" cy="660500"/>
+          </a:xfrm>
+          <a:prstGeom prst="roundRect">
+            <a:avLst>
+              <a:gd name="adj" fmla="val 40000"/>
+            </a:avLst>
+          </a:prstGeom>
+          <a:solidFill>
+            <a:srgbClr val="1F3763"/>
+          </a:solidFill>
+          <a:ln>
+            <a:noFill/>
+          </a:ln>
+          <a:effectLst/>
+        </p:spPr>
+        <p:style>
+          <a:lnRef idx="1">
+            <a:schemeClr val="accent1"/>
+          </a:lnRef>
+          <a:fillRef idx="3">
+            <a:schemeClr val="accent1"/>
+          </a:fillRef>
+          <a:effectRef idx="2">
+            <a:schemeClr val="accent1"/>
+          </a:effectRef>
+          <a:fontRef idx="minor">
+            <a:schemeClr val="lt1"/>
+          </a:fontRef>
+        </p:style>
+        <p:txBody>
+          <a:bodyPr rtlCol="0" anchor="ctr"/>
+          <a:lstStyle/>
+          <a:p>
+            <a:pPr algn="ctr"/>
+          </a:p>
+        </p:txBody>
+      </p:sp>
+      <p:sp>
+        <p:nvSpPr>
+          <p:cNvPr id="20" name="TextBox 19"/>
           <p:cNvSpPr txBox="1"/>
           <p:nvPr/>
         </p:nvSpPr>
         <p:spPr>
           <a:xfrm>
-            <a:off x="292600" y="1272000"/>
-            <a:ext cx="2754933" cy="2548000"/>
+            <a:off x="368600" y="1264000"/>
+            <a:ext cx="2664933" cy="694500"/>
           </a:xfrm>
           <a:prstGeom prst="rect">
             <a:avLst/>
@@ -21854,658 +21900,561 @@
           <a:noFill/>
         </p:spPr>
         <p:txBody>
-          <a:bodyPr wrap="square" anchor="t" lIns="0" rIns="0" tIns="0" bIns="0">
+          <a:bodyPr wrap="square" anchor="ctr" lIns="0" rIns="0" tIns="0" bIns="0">
             <a:spAutoFit/>
           </a:bodyPr>
           <a:lstStyle/>
           <a:p>
-            <a:pPr algn="l" indent="-110000" marL="110000">
-              <a:lnSpc>
-                <a:spcPct val="102000"/>
-              </a:lnSpc>
-              <a:spcBef>
-                <a:spcPts val="0"/>
-              </a:spcBef>
-              <a:spcAft>
-                <a:spcPts val="320"/>
+            <a:pPr algn="l">
+              <a:lnSpc>
+                <a:spcPct val="100000"/>
+              </a:lnSpc>
+              <a:spcBef>
+                <a:spcPts val="0"/>
+              </a:spcBef>
+              <a:spcAft>
+                <a:spcPts val="300"/>
               </a:spcAft>
             </a:pPr>
             <a:r>
-              <a:rPr sz="700" b="0" i="0">
+              <a:rPr sz="900" b="1" i="0">
                 <a:solidFill>
                   <a:srgbClr val="1F3763"/>
                 </a:solidFill>
                 <a:latin typeface="Manrope"/>
                 <a:cs typeface="Manrope"/>
               </a:rPr>
-              <a:t>● </a:t>
+              <a:t>Ledger   </a:t>
             </a:r>
             <a:r>
-              <a:rPr sz="720" b="1" i="0">
-                <a:solidFill>
-                  <a:srgbClr val="25303B"/>
+              <a:rPr sz="700" b="1" i="0">
+                <a:solidFill>
+                  <a:srgbClr val="6B7480"/>
                 </a:solidFill>
                 <a:latin typeface="Manrope"/>
                 <a:cs typeface="Manrope"/>
               </a:rPr>
-              <a:t>CM-723  </a:t>
+              <a:t>· 5 stories</a:t>
             </a:r>
+          </a:p>
+          <a:p>
+            <a:pPr algn="l">
+              <a:lnSpc>
+                <a:spcPct val="108000"/>
+              </a:lnSpc>
+              <a:spcBef>
+                <a:spcPts val="0"/>
+              </a:spcBef>
+              <a:spcAft>
+                <a:spcPts val="0"/>
+              </a:spcAft>
+            </a:pPr>
             <a:r>
-              <a:rPr sz="720" b="0" i="0">
+              <a:rPr sz="760" b="0" i="0">
                 <a:solidFill>
                   <a:srgbClr val="25303B"/>
                 </a:solidFill>
                 <a:latin typeface="Manrope"/>
                 <a:cs typeface="Manrope"/>
               </a:rPr>
-              <a:t>Immutable trip-level payment record (Net Payable/Receivable)  </a:t>
+              <a:t>Stand up the trip-level payment ledger — immutable Net Payable/Receivable record, wallet-based overpayment settlement, and automated TDS (capture, calculate &amp; reverse).</a:t>
             </a:r>
+          </a:p>
+        </p:txBody>
+      </p:sp>
+      <p:cxnSp>
+        <p:nvCxnSpPr>
+          <p:cNvPr id="21" name="Connector 20"/>
+          <p:cNvCxnSpPr/>
+          <p:nvPr/>
+        </p:nvCxnSpPr>
+        <p:spPr>
+          <a:xfrm>
+            <a:off x="298600" y="1982500"/>
+            <a:ext cx="2724933" cy="0"/>
+          </a:xfrm>
+          <a:prstGeom prst="line">
+            <a:avLst/>
+          </a:prstGeom>
+          <a:ln w="6350">
+            <a:solidFill>
+              <a:srgbClr val="E4E8ED"/>
+            </a:solidFill>
+          </a:ln>
+          <a:effectLst/>
+        </p:spPr>
+        <p:style>
+          <a:lnRef idx="2">
+            <a:schemeClr val="accent1"/>
+          </a:lnRef>
+          <a:fillRef idx="0">
+            <a:schemeClr val="accent1"/>
+          </a:fillRef>
+          <a:effectRef idx="1">
+            <a:schemeClr val="accent1"/>
+          </a:effectRef>
+          <a:fontRef idx="minor">
+            <a:schemeClr val="tx1"/>
+          </a:fontRef>
+        </p:style>
+      </p:cxnSp>
+      <p:sp>
+        <p:nvSpPr>
+          <p:cNvPr id="22" name="Rounded Rectangle 21"/>
+          <p:cNvSpPr/>
+          <p:nvPr/>
+        </p:nvSpPr>
+        <p:spPr>
+          <a:xfrm>
+            <a:off x="284600" y="2024500"/>
+            <a:ext cx="44000" cy="660500"/>
+          </a:xfrm>
+          <a:prstGeom prst="roundRect">
+            <a:avLst>
+              <a:gd name="adj" fmla="val 40000"/>
+            </a:avLst>
+          </a:prstGeom>
+          <a:solidFill>
+            <a:srgbClr val="26815C"/>
+          </a:solidFill>
+          <a:ln>
+            <a:noFill/>
+          </a:ln>
+          <a:effectLst/>
+        </p:spPr>
+        <p:style>
+          <a:lnRef idx="1">
+            <a:schemeClr val="accent1"/>
+          </a:lnRef>
+          <a:fillRef idx="3">
+            <a:schemeClr val="accent1"/>
+          </a:fillRef>
+          <a:effectRef idx="2">
+            <a:schemeClr val="accent1"/>
+          </a:effectRef>
+          <a:fontRef idx="minor">
+            <a:schemeClr val="lt1"/>
+          </a:fontRef>
+        </p:style>
+        <p:txBody>
+          <a:bodyPr rtlCol="0" anchor="ctr"/>
+          <a:lstStyle/>
+          <a:p>
+            <a:pPr algn="ctr"/>
+          </a:p>
+        </p:txBody>
+      </p:sp>
+      <p:sp>
+        <p:nvSpPr>
+          <p:cNvPr id="23" name="TextBox 22"/>
+          <p:cNvSpPr txBox="1"/>
+          <p:nvPr/>
+        </p:nvSpPr>
+        <p:spPr>
+          <a:xfrm>
+            <a:off x="368600" y="2016500"/>
+            <a:ext cx="2664933" cy="694500"/>
+          </a:xfrm>
+          <a:prstGeom prst="rect">
+            <a:avLst/>
+          </a:prstGeom>
+          <a:noFill/>
+        </p:spPr>
+        <p:txBody>
+          <a:bodyPr wrap="square" anchor="ctr" lIns="0" rIns="0" tIns="0" bIns="0">
+            <a:spAutoFit/>
+          </a:bodyPr>
+          <a:lstStyle/>
+          <a:p>
+            <a:pPr algn="l">
+              <a:lnSpc>
+                <a:spcPct val="100000"/>
+              </a:lnSpc>
+              <a:spcBef>
+                <a:spcPts val="0"/>
+              </a:spcBef>
+              <a:spcAft>
+                <a:spcPts val="300"/>
+              </a:spcAft>
+            </a:pPr>
             <a:r>
-              <a:rPr sz="640" b="1" i="1">
-                <a:solidFill>
-                  <a:srgbClr val="1F3763"/>
+              <a:rPr sz="900" b="1" i="0">
+                <a:solidFill>
+                  <a:srgbClr val="26815C"/>
                 </a:solidFill>
                 <a:latin typeface="Manrope"/>
                 <a:cs typeface="Manrope"/>
               </a:rPr>
-              <a:t>In Dev</a:t>
+              <a:t>Fulfilment %   </a:t>
+            </a:r>
+            <a:r>
+              <a:rPr sz="700" b="1" i="0">
+                <a:solidFill>
+                  <a:srgbClr val="6B7480"/>
+                </a:solidFill>
+                <a:latin typeface="Manrope"/>
+                <a:cs typeface="Manrope"/>
+              </a:rPr>
+              <a:t>· 3 stories</a:t>
             </a:r>
           </a:p>
           <a:p>
-            <a:pPr algn="l" indent="-110000" marL="110000">
-              <a:lnSpc>
-                <a:spcPct val="102000"/>
-              </a:lnSpc>
-              <a:spcBef>
-                <a:spcPts val="0"/>
-              </a:spcBef>
-              <a:spcAft>
-                <a:spcPts val="320"/>
+            <a:pPr algn="l">
+              <a:lnSpc>
+                <a:spcPct val="108000"/>
+              </a:lnSpc>
+              <a:spcBef>
+                <a:spcPts val="0"/>
+              </a:spcBef>
+              <a:spcAft>
+                <a:spcPts val="0"/>
               </a:spcAft>
             </a:pPr>
             <a:r>
-              <a:rPr sz="700" b="0" i="0">
-                <a:solidFill>
-                  <a:srgbClr val="1F3763"/>
+              <a:rPr sz="760" b="0" i="0">
+                <a:solidFill>
+                  <a:srgbClr val="25303B"/>
                 </a:solidFill>
                 <a:latin typeface="Manrope"/>
                 <a:cs typeface="Manrope"/>
               </a:rPr>
-              <a:t>● </a:t>
+              <a:t>Act on demand faster — lane-based agent auto-assignment, Demand-Bot context building, and near-match inventory with match-quality on the demand list.</a:t>
             </a:r>
+          </a:p>
+        </p:txBody>
+      </p:sp>
+      <p:cxnSp>
+        <p:nvCxnSpPr>
+          <p:cNvPr id="24" name="Connector 23"/>
+          <p:cNvCxnSpPr/>
+          <p:nvPr/>
+        </p:nvCxnSpPr>
+        <p:spPr>
+          <a:xfrm>
+            <a:off x="298600" y="2735000"/>
+            <a:ext cx="2724933" cy="0"/>
+          </a:xfrm>
+          <a:prstGeom prst="line">
+            <a:avLst/>
+          </a:prstGeom>
+          <a:ln w="6350">
+            <a:solidFill>
+              <a:srgbClr val="E4E8ED"/>
+            </a:solidFill>
+          </a:ln>
+          <a:effectLst/>
+        </p:spPr>
+        <p:style>
+          <a:lnRef idx="2">
+            <a:schemeClr val="accent1"/>
+          </a:lnRef>
+          <a:fillRef idx="0">
+            <a:schemeClr val="accent1"/>
+          </a:fillRef>
+          <a:effectRef idx="1">
+            <a:schemeClr val="accent1"/>
+          </a:effectRef>
+          <a:fontRef idx="minor">
+            <a:schemeClr val="tx1"/>
+          </a:fontRef>
+        </p:style>
+      </p:cxnSp>
+      <p:sp>
+        <p:nvSpPr>
+          <p:cNvPr id="25" name="Rounded Rectangle 24"/>
+          <p:cNvSpPr/>
+          <p:nvPr/>
+        </p:nvSpPr>
+        <p:spPr>
+          <a:xfrm>
+            <a:off x="284600" y="2777000"/>
+            <a:ext cx="44000" cy="660500"/>
+          </a:xfrm>
+          <a:prstGeom prst="roundRect">
+            <a:avLst>
+              <a:gd name="adj" fmla="val 40000"/>
+            </a:avLst>
+          </a:prstGeom>
+          <a:solidFill>
+            <a:srgbClr val="6043A3"/>
+          </a:solidFill>
+          <a:ln>
+            <a:noFill/>
+          </a:ln>
+          <a:effectLst/>
+        </p:spPr>
+        <p:style>
+          <a:lnRef idx="1">
+            <a:schemeClr val="accent1"/>
+          </a:lnRef>
+          <a:fillRef idx="3">
+            <a:schemeClr val="accent1"/>
+          </a:fillRef>
+          <a:effectRef idx="2">
+            <a:schemeClr val="accent1"/>
+          </a:effectRef>
+          <a:fontRef idx="minor">
+            <a:schemeClr val="lt1"/>
+          </a:fontRef>
+        </p:style>
+        <p:txBody>
+          <a:bodyPr rtlCol="0" anchor="ctr"/>
+          <a:lstStyle/>
+          <a:p>
+            <a:pPr algn="ctr"/>
+          </a:p>
+        </p:txBody>
+      </p:sp>
+      <p:sp>
+        <p:nvSpPr>
+          <p:cNvPr id="26" name="TextBox 25"/>
+          <p:cNvSpPr txBox="1"/>
+          <p:nvPr/>
+        </p:nvSpPr>
+        <p:spPr>
+          <a:xfrm>
+            <a:off x="368600" y="2769000"/>
+            <a:ext cx="2664933" cy="694500"/>
+          </a:xfrm>
+          <a:prstGeom prst="rect">
+            <a:avLst/>
+          </a:prstGeom>
+          <a:noFill/>
+        </p:spPr>
+        <p:txBody>
+          <a:bodyPr wrap="square" anchor="ctr" lIns="0" rIns="0" tIns="0" bIns="0">
+            <a:spAutoFit/>
+          </a:bodyPr>
+          <a:lstStyle/>
+          <a:p>
+            <a:pPr algn="l">
+              <a:lnSpc>
+                <a:spcPct val="100000"/>
+              </a:lnSpc>
+              <a:spcBef>
+                <a:spcPts val="0"/>
+              </a:spcBef>
+              <a:spcAft>
+                <a:spcPts val="300"/>
+              </a:spcAft>
+            </a:pPr>
             <a:r>
-              <a:rPr sz="720" b="1" i="0">
-                <a:solidFill>
-                  <a:srgbClr val="25303B"/>
+              <a:rPr sz="900" b="1" i="0">
+                <a:solidFill>
+                  <a:srgbClr val="6043A3"/>
                 </a:solidFill>
                 <a:latin typeface="Manrope"/>
                 <a:cs typeface="Manrope"/>
               </a:rPr>
-              <a:t>CM-722  </a:t>
+              <a:t>DAU   </a:t>
             </a:r>
             <a:r>
-              <a:rPr sz="720" b="0" i="0">
-                <a:solidFill>
-                  <a:srgbClr val="25303B"/>
+              <a:rPr sz="700" b="1" i="0">
+                <a:solidFill>
+                  <a:srgbClr val="6B7480"/>
                 </a:solidFill>
                 <a:latin typeface="Manrope"/>
                 <a:cs typeface="Manrope"/>
               </a:rPr>
-              <a:t>Overpayment settlement via FO/LSP wallets  </a:t>
+              <a:t>· 1 story</a:t>
             </a:r>
+          </a:p>
+          <a:p>
+            <a:pPr algn="l">
+              <a:lnSpc>
+                <a:spcPct val="108000"/>
+              </a:lnSpc>
+              <a:spcBef>
+                <a:spcPts val="0"/>
+              </a:spcBef>
+              <a:spcAft>
+                <a:spcPts val="0"/>
+              </a:spcAft>
+            </a:pPr>
             <a:r>
-              <a:rPr sz="640" b="1" i="1">
-                <a:solidFill>
-                  <a:srgbClr val="1F3763"/>
+              <a:rPr sz="760" b="0" i="0">
+                <a:solidFill>
+                  <a:srgbClr val="25303B"/>
                 </a:solidFill>
                 <a:latin typeface="Manrope"/>
                 <a:cs typeface="Manrope"/>
               </a:rPr>
-              <a:t>In Dev</a:t>
+              <a:t>Let FOs reach the PSA directly for placement from the app (PSA number in-app).</a:t>
+            </a:r>
+          </a:p>
+        </p:txBody>
+      </p:sp>
+      <p:cxnSp>
+        <p:nvCxnSpPr>
+          <p:cNvPr id="27" name="Connector 26"/>
+          <p:cNvCxnSpPr/>
+          <p:nvPr/>
+        </p:nvCxnSpPr>
+        <p:spPr>
+          <a:xfrm>
+            <a:off x="298600" y="3487500"/>
+            <a:ext cx="2724933" cy="0"/>
+          </a:xfrm>
+          <a:prstGeom prst="line">
+            <a:avLst/>
+          </a:prstGeom>
+          <a:ln w="6350">
+            <a:solidFill>
+              <a:srgbClr val="E4E8ED"/>
+            </a:solidFill>
+          </a:ln>
+          <a:effectLst/>
+        </p:spPr>
+        <p:style>
+          <a:lnRef idx="2">
+            <a:schemeClr val="accent1"/>
+          </a:lnRef>
+          <a:fillRef idx="0">
+            <a:schemeClr val="accent1"/>
+          </a:fillRef>
+          <a:effectRef idx="1">
+            <a:schemeClr val="accent1"/>
+          </a:effectRef>
+          <a:fontRef idx="minor">
+            <a:schemeClr val="tx1"/>
+          </a:fontRef>
+        </p:style>
+      </p:cxnSp>
+      <p:sp>
+        <p:nvSpPr>
+          <p:cNvPr id="28" name="Rounded Rectangle 27"/>
+          <p:cNvSpPr/>
+          <p:nvPr/>
+        </p:nvSpPr>
+        <p:spPr>
+          <a:xfrm>
+            <a:off x="284600" y="3529500"/>
+            <a:ext cx="44000" cy="660500"/>
+          </a:xfrm>
+          <a:prstGeom prst="roundRect">
+            <a:avLst>
+              <a:gd name="adj" fmla="val 40000"/>
+            </a:avLst>
+          </a:prstGeom>
+          <a:solidFill>
+            <a:srgbClr val="C77D0A"/>
+          </a:solidFill>
+          <a:ln>
+            <a:noFill/>
+          </a:ln>
+          <a:effectLst/>
+        </p:spPr>
+        <p:style>
+          <a:lnRef idx="1">
+            <a:schemeClr val="accent1"/>
+          </a:lnRef>
+          <a:fillRef idx="3">
+            <a:schemeClr val="accent1"/>
+          </a:fillRef>
+          <a:effectRef idx="2">
+            <a:schemeClr val="accent1"/>
+          </a:effectRef>
+          <a:fontRef idx="minor">
+            <a:schemeClr val="lt1"/>
+          </a:fontRef>
+        </p:style>
+        <p:txBody>
+          <a:bodyPr rtlCol="0" anchor="ctr"/>
+          <a:lstStyle/>
+          <a:p>
+            <a:pPr algn="ctr"/>
+          </a:p>
+        </p:txBody>
+      </p:sp>
+      <p:sp>
+        <p:nvSpPr>
+          <p:cNvPr id="29" name="TextBox 28"/>
+          <p:cNvSpPr txBox="1"/>
+          <p:nvPr/>
+        </p:nvSpPr>
+        <p:spPr>
+          <a:xfrm>
+            <a:off x="368600" y="3521500"/>
+            <a:ext cx="2664933" cy="694500"/>
+          </a:xfrm>
+          <a:prstGeom prst="rect">
+            <a:avLst/>
+          </a:prstGeom>
+          <a:noFill/>
+        </p:spPr>
+        <p:txBody>
+          <a:bodyPr wrap="square" anchor="ctr" lIns="0" rIns="0" tIns="0" bIns="0">
+            <a:spAutoFit/>
+          </a:bodyPr>
+          <a:lstStyle/>
+          <a:p>
+            <a:pPr algn="l">
+              <a:lnSpc>
+                <a:spcPct val="100000"/>
+              </a:lnSpc>
+              <a:spcBef>
+                <a:spcPts val="0"/>
+              </a:spcBef>
+              <a:spcAft>
+                <a:spcPts val="300"/>
+              </a:spcAft>
+            </a:pPr>
+            <a:r>
+              <a:rPr sz="900" b="1" i="0">
+                <a:solidFill>
+                  <a:srgbClr val="C77D0A"/>
+                </a:solidFill>
+                <a:latin typeface="Manrope"/>
+                <a:cs typeface="Manrope"/>
+              </a:rPr>
+              <a:t>Reduce Ops Bandwidth   </a:t>
+            </a:r>
+            <a:r>
+              <a:rPr sz="700" b="1" i="0">
+                <a:solidFill>
+                  <a:srgbClr val="6B7480"/>
+                </a:solidFill>
+                <a:latin typeface="Manrope"/>
+                <a:cs typeface="Manrope"/>
+              </a:rPr>
+              <a:t>· 3 stories</a:t>
             </a:r>
           </a:p>
           <a:p>
-            <a:pPr algn="l" indent="-110000" marL="110000">
-              <a:lnSpc>
-                <a:spcPct val="102000"/>
-              </a:lnSpc>
-              <a:spcBef>
-                <a:spcPts val="0"/>
-              </a:spcBef>
-              <a:spcAft>
-                <a:spcPts val="320"/>
+            <a:pPr algn="l">
+              <a:lnSpc>
+                <a:spcPct val="108000"/>
+              </a:lnSpc>
+              <a:spcBef>
+                <a:spcPts val="0"/>
+              </a:spcBef>
+              <a:spcAft>
+                <a:spcPts val="0"/>
               </a:spcAft>
             </a:pPr>
             <a:r>
-              <a:rPr sz="700" b="0" i="0">
-                <a:solidFill>
-                  <a:srgbClr val="1F3763"/>
+              <a:rPr sz="760" b="0" i="0">
+                <a:solidFill>
+                  <a:srgbClr val="25303B"/>
                 </a:solidFill>
                 <a:latin typeface="Manrope"/>
                 <a:cs typeface="Manrope"/>
               </a:rPr>
-              <a:t>● </a:t>
-            </a:r>
-            <a:r>
-              <a:rPr sz="720" b="1" i="0">
-                <a:solidFill>
-                  <a:srgbClr val="25303B"/>
-                </a:solidFill>
-                <a:latin typeface="Manrope"/>
-                <a:cs typeface="Manrope"/>
-              </a:rPr>
-              <a:t>CM-734  </a:t>
-            </a:r>
-            <a:r>
-              <a:rPr sz="720" b="0" i="0">
-                <a:solidFill>
-                  <a:srgbClr val="25303B"/>
-                </a:solidFill>
-                <a:latin typeface="Manrope"/>
-                <a:cs typeface="Manrope"/>
-              </a:rPr>
-              <a:t>Capture TDS details in CRM (Supplier KYC)  </a:t>
-            </a:r>
-            <a:r>
-              <a:rPr sz="640" b="1" i="1">
-                <a:solidFill>
-                  <a:srgbClr val="1F3763"/>
-                </a:solidFill>
-                <a:latin typeface="Manrope"/>
-                <a:cs typeface="Manrope"/>
-              </a:rPr>
-              <a:t>In Dev</a:t>
-            </a:r>
-          </a:p>
-          <a:p>
-            <a:pPr algn="l" indent="-110000" marL="110000">
-              <a:lnSpc>
-                <a:spcPct val="102000"/>
-              </a:lnSpc>
-              <a:spcBef>
-                <a:spcPts val="0"/>
-              </a:spcBef>
-              <a:spcAft>
-                <a:spcPts val="320"/>
-              </a:spcAft>
-            </a:pPr>
-            <a:r>
-              <a:rPr sz="700" b="0" i="0">
-                <a:solidFill>
-                  <a:srgbClr val="1F3763"/>
-                </a:solidFill>
-                <a:latin typeface="Manrope"/>
-                <a:cs typeface="Manrope"/>
-              </a:rPr>
-              <a:t>● </a:t>
-            </a:r>
-            <a:r>
-              <a:rPr sz="720" b="1" i="0">
-                <a:solidFill>
-                  <a:srgbClr val="25303B"/>
-                </a:solidFill>
-                <a:latin typeface="Manrope"/>
-                <a:cs typeface="Manrope"/>
-              </a:rPr>
-              <a:t>CM-735  </a:t>
-            </a:r>
-            <a:r>
-              <a:rPr sz="720" b="0" i="0">
-                <a:solidFill>
-                  <a:srgbClr val="25303B"/>
-                </a:solidFill>
-                <a:latin typeface="Manrope"/>
-                <a:cs typeface="Manrope"/>
-              </a:rPr>
-              <a:t>Auto-calculate TDS for new &amp; active trips  </a:t>
-            </a:r>
-            <a:r>
-              <a:rPr sz="640" b="1" i="1">
-                <a:solidFill>
-                  <a:srgbClr val="1F3763"/>
-                </a:solidFill>
-                <a:latin typeface="Manrope"/>
-                <a:cs typeface="Manrope"/>
-              </a:rPr>
-              <a:t>In Dev</a:t>
-            </a:r>
-          </a:p>
-          <a:p>
-            <a:pPr algn="l" indent="-110000" marL="110000">
-              <a:lnSpc>
-                <a:spcPct val="102000"/>
-              </a:lnSpc>
-              <a:spcBef>
-                <a:spcPts val="0"/>
-              </a:spcBef>
-              <a:spcAft>
-                <a:spcPts val="320"/>
-              </a:spcAft>
-            </a:pPr>
-            <a:r>
-              <a:rPr sz="700" b="0" i="0">
-                <a:solidFill>
-                  <a:srgbClr val="1F3763"/>
-                </a:solidFill>
-                <a:latin typeface="Manrope"/>
-                <a:cs typeface="Manrope"/>
-              </a:rPr>
-              <a:t>● </a:t>
-            </a:r>
-            <a:r>
-              <a:rPr sz="720" b="1" i="0">
-                <a:solidFill>
-                  <a:srgbClr val="25303B"/>
-                </a:solidFill>
-                <a:latin typeface="Manrope"/>
-                <a:cs typeface="Manrope"/>
-              </a:rPr>
-              <a:t>CM-746  </a:t>
-            </a:r>
-            <a:r>
-              <a:rPr sz="720" b="0" i="0">
-                <a:solidFill>
-                  <a:srgbClr val="25303B"/>
-                </a:solidFill>
-                <a:latin typeface="Manrope"/>
-                <a:cs typeface="Manrope"/>
-              </a:rPr>
-              <a:t>Recalculate/reverse TDS on mid-month declaration change  </a:t>
-            </a:r>
-            <a:r>
-              <a:rPr sz="640" b="1" i="1">
-                <a:solidFill>
-                  <a:srgbClr val="6043A3"/>
-                </a:solidFill>
-                <a:latin typeface="Manrope"/>
-                <a:cs typeface="Manrope"/>
-              </a:rPr>
-              <a:t>Prioritised</a:t>
-            </a:r>
-          </a:p>
-          <a:p>
-            <a:pPr algn="l" indent="-110000" marL="110000">
-              <a:lnSpc>
-                <a:spcPct val="102000"/>
-              </a:lnSpc>
-              <a:spcBef>
-                <a:spcPts val="0"/>
-              </a:spcBef>
-              <a:spcAft>
-                <a:spcPts val="320"/>
-              </a:spcAft>
-            </a:pPr>
-            <a:r>
-              <a:rPr sz="700" b="0" i="0">
-                <a:solidFill>
-                  <a:srgbClr val="26815C"/>
-                </a:solidFill>
-                <a:latin typeface="Manrope"/>
-                <a:cs typeface="Manrope"/>
-              </a:rPr>
-              <a:t>● </a:t>
-            </a:r>
-            <a:r>
-              <a:rPr sz="720" b="1" i="0">
-                <a:solidFill>
-                  <a:srgbClr val="25303B"/>
-                </a:solidFill>
-                <a:latin typeface="Manrope"/>
-                <a:cs typeface="Manrope"/>
-              </a:rPr>
-              <a:t>CM-682  </a:t>
-            </a:r>
-            <a:r>
-              <a:rPr sz="720" b="0" i="0">
-                <a:solidFill>
-                  <a:srgbClr val="25303B"/>
-                </a:solidFill>
-                <a:latin typeface="Manrope"/>
-                <a:cs typeface="Manrope"/>
-              </a:rPr>
-              <a:t>Map agents to lanes for demand auto-assignment  </a:t>
-            </a:r>
-            <a:r>
-              <a:rPr sz="640" b="1" i="1">
-                <a:solidFill>
-                  <a:srgbClr val="6043A3"/>
-                </a:solidFill>
-                <a:latin typeface="Manrope"/>
-                <a:cs typeface="Manrope"/>
-              </a:rPr>
-              <a:t>Prioritised</a:t>
-            </a:r>
-          </a:p>
-          <a:p>
-            <a:pPr algn="l" indent="-110000" marL="110000">
-              <a:lnSpc>
-                <a:spcPct val="102000"/>
-              </a:lnSpc>
-              <a:spcBef>
-                <a:spcPts val="0"/>
-              </a:spcBef>
-              <a:spcAft>
-                <a:spcPts val="320"/>
-              </a:spcAft>
-            </a:pPr>
-            <a:r>
-              <a:rPr sz="700" b="0" i="0">
-                <a:solidFill>
-                  <a:srgbClr val="26815C"/>
-                </a:solidFill>
-                <a:latin typeface="Manrope"/>
-                <a:cs typeface="Manrope"/>
-              </a:rPr>
-              <a:t>● </a:t>
-            </a:r>
-            <a:r>
-              <a:rPr sz="720" b="1" i="0">
-                <a:solidFill>
-                  <a:srgbClr val="25303B"/>
-                </a:solidFill>
-                <a:latin typeface="Manrope"/>
-                <a:cs typeface="Manrope"/>
-              </a:rPr>
-              <a:t>CM-731  </a:t>
-            </a:r>
-            <a:r>
-              <a:rPr sz="720" b="0" i="0">
-                <a:solidFill>
-                  <a:srgbClr val="25303B"/>
-                </a:solidFill>
-                <a:latin typeface="Manrope"/>
-                <a:cs typeface="Manrope"/>
-              </a:rPr>
-              <a:t>Demand Bot: batch message context building  </a:t>
-            </a:r>
-            <a:r>
-              <a:rPr sz="640" b="1" i="1">
-                <a:solidFill>
-                  <a:srgbClr val="6043A3"/>
-                </a:solidFill>
-                <a:latin typeface="Manrope"/>
-                <a:cs typeface="Manrope"/>
-              </a:rPr>
-              <a:t>Prioritised</a:t>
-            </a:r>
-          </a:p>
-          <a:p>
-            <a:pPr algn="l" indent="-110000" marL="110000">
-              <a:lnSpc>
-                <a:spcPct val="102000"/>
-              </a:lnSpc>
-              <a:spcBef>
-                <a:spcPts val="0"/>
-              </a:spcBef>
-              <a:spcAft>
-                <a:spcPts val="320"/>
-              </a:spcAft>
-            </a:pPr>
-            <a:r>
-              <a:rPr sz="700" b="0" i="0">
-                <a:solidFill>
-                  <a:srgbClr val="26815C"/>
-                </a:solidFill>
-                <a:latin typeface="Manrope"/>
-                <a:cs typeface="Manrope"/>
-              </a:rPr>
-              <a:t>● </a:t>
-            </a:r>
-            <a:r>
-              <a:rPr sz="720" b="1" i="0">
-                <a:solidFill>
-                  <a:srgbClr val="25303B"/>
-                </a:solidFill>
-                <a:latin typeface="Manrope"/>
-                <a:cs typeface="Manrope"/>
-              </a:rPr>
-              <a:t>CM-739  </a:t>
-            </a:r>
-            <a:r>
-              <a:rPr sz="720" b="0" i="0">
-                <a:solidFill>
-                  <a:srgbClr val="25303B"/>
-                </a:solidFill>
-                <a:latin typeface="Manrope"/>
-                <a:cs typeface="Manrope"/>
-              </a:rPr>
-              <a:t>Near-match inventory logic + match quality on demand list  </a:t>
-            </a:r>
-            <a:r>
-              <a:rPr sz="640" b="1" i="1">
-                <a:solidFill>
-                  <a:srgbClr val="26815C"/>
-                </a:solidFill>
-                <a:latin typeface="Manrope"/>
-                <a:cs typeface="Manrope"/>
-              </a:rPr>
-              <a:t>Done</a:t>
-            </a:r>
-          </a:p>
-          <a:p>
-            <a:pPr algn="l" indent="-110000" marL="110000">
-              <a:lnSpc>
-                <a:spcPct val="102000"/>
-              </a:lnSpc>
-              <a:spcBef>
-                <a:spcPts val="0"/>
-              </a:spcBef>
-              <a:spcAft>
-                <a:spcPts val="320"/>
-              </a:spcAft>
-            </a:pPr>
-            <a:r>
-              <a:rPr sz="700" b="0" i="0">
-                <a:solidFill>
-                  <a:srgbClr val="6043A3"/>
-                </a:solidFill>
-                <a:latin typeface="Manrope"/>
-                <a:cs typeface="Manrope"/>
-              </a:rPr>
-              <a:t>● </a:t>
-            </a:r>
-            <a:r>
-              <a:rPr sz="720" b="1" i="0">
-                <a:solidFill>
-                  <a:srgbClr val="25303B"/>
-                </a:solidFill>
-                <a:latin typeface="Manrope"/>
-                <a:cs typeface="Manrope"/>
-              </a:rPr>
-              <a:t>CM-819  </a:t>
-            </a:r>
-            <a:r>
-              <a:rPr sz="720" b="0" i="0">
-                <a:solidFill>
-                  <a:srgbClr val="25303B"/>
-                </a:solidFill>
-                <a:latin typeface="Manrope"/>
-                <a:cs typeface="Manrope"/>
-              </a:rPr>
-              <a:t>FO App: reach PSA directly for placement (show PSA number)  </a:t>
-            </a:r>
-            <a:r>
-              <a:rPr sz="640" b="1" i="1">
-                <a:solidFill>
-                  <a:srgbClr val="6043A3"/>
-                </a:solidFill>
-                <a:latin typeface="Manrope"/>
-                <a:cs typeface="Manrope"/>
-              </a:rPr>
-              <a:t>Prioritised</a:t>
-            </a:r>
-          </a:p>
-          <a:p>
-            <a:pPr algn="l" indent="-110000" marL="110000">
-              <a:lnSpc>
-                <a:spcPct val="102000"/>
-              </a:lnSpc>
-              <a:spcBef>
-                <a:spcPts val="0"/>
-              </a:spcBef>
-              <a:spcAft>
-                <a:spcPts val="320"/>
-              </a:spcAft>
-            </a:pPr>
-            <a:r>
-              <a:rPr sz="700" b="0" i="0">
-                <a:solidFill>
-                  <a:srgbClr val="C77D0A"/>
-                </a:solidFill>
-                <a:latin typeface="Manrope"/>
-                <a:cs typeface="Manrope"/>
-              </a:rPr>
-              <a:t>● </a:t>
-            </a:r>
-            <a:r>
-              <a:rPr sz="720" b="1" i="0">
-                <a:solidFill>
-                  <a:srgbClr val="25303B"/>
-                </a:solidFill>
-                <a:latin typeface="Manrope"/>
-                <a:cs typeface="Manrope"/>
-              </a:rPr>
-              <a:t>CM-785  </a:t>
-            </a:r>
-            <a:r>
-              <a:rPr sz="720" b="0" i="0">
-                <a:solidFill>
-                  <a:srgbClr val="25303B"/>
-                </a:solidFill>
-                <a:latin typeface="Manrope"/>
-                <a:cs typeface="Manrope"/>
-              </a:rPr>
-              <a:t>Automate advance payments for Gold/Silver FOs  </a:t>
-            </a:r>
-            <a:r>
-              <a:rPr sz="640" b="1" i="1">
-                <a:solidFill>
-                  <a:srgbClr val="6043A3"/>
-                </a:solidFill>
-                <a:latin typeface="Manrope"/>
-                <a:cs typeface="Manrope"/>
-              </a:rPr>
-              <a:t>Prioritised</a:t>
-            </a:r>
-          </a:p>
-          <a:p>
-            <a:pPr algn="l" indent="-110000" marL="110000">
-              <a:lnSpc>
-                <a:spcPct val="102000"/>
-              </a:lnSpc>
-              <a:spcBef>
-                <a:spcPts val="0"/>
-              </a:spcBef>
-              <a:spcAft>
-                <a:spcPts val="320"/>
-              </a:spcAft>
-            </a:pPr>
-            <a:r>
-              <a:rPr sz="700" b="0" i="0">
-                <a:solidFill>
-                  <a:srgbClr val="C77D0A"/>
-                </a:solidFill>
-                <a:latin typeface="Manrope"/>
-                <a:cs typeface="Manrope"/>
-              </a:rPr>
-              <a:t>● </a:t>
-            </a:r>
-            <a:r>
-              <a:rPr sz="720" b="1" i="0">
-                <a:solidFill>
-                  <a:srgbClr val="25303B"/>
-                </a:solidFill>
-                <a:latin typeface="Manrope"/>
-                <a:cs typeface="Manrope"/>
-              </a:rPr>
-              <a:t>CM-660  </a:t>
-            </a:r>
-            <a:r>
-              <a:rPr sz="720" b="0" i="0">
-                <a:solidFill>
-                  <a:srgbClr val="25303B"/>
-                </a:solidFill>
-                <a:latin typeface="Manrope"/>
-                <a:cs typeface="Manrope"/>
-              </a:rPr>
-              <a:t>Automate SIM consent collection (pre-transit)  </a:t>
-            </a:r>
-            <a:r>
-              <a:rPr sz="640" b="1" i="1">
-                <a:solidFill>
-                  <a:srgbClr val="C77D0A"/>
-                </a:solidFill>
-                <a:latin typeface="Manrope"/>
-                <a:cs typeface="Manrope"/>
-              </a:rPr>
-              <a:t>On-hold</a:t>
-            </a:r>
-          </a:p>
-          <a:p>
-            <a:pPr algn="l" indent="-110000" marL="110000">
-              <a:lnSpc>
-                <a:spcPct val="102000"/>
-              </a:lnSpc>
-              <a:spcBef>
-                <a:spcPts val="0"/>
-              </a:spcBef>
-              <a:spcAft>
-                <a:spcPts val="320"/>
-              </a:spcAft>
-            </a:pPr>
-            <a:r>
-              <a:rPr sz="700" b="0" i="0">
-                <a:solidFill>
-                  <a:srgbClr val="C77D0A"/>
-                </a:solidFill>
-                <a:latin typeface="Manrope"/>
-                <a:cs typeface="Manrope"/>
-              </a:rPr>
-              <a:t>● </a:t>
-            </a:r>
-            <a:r>
-              <a:rPr sz="720" b="1" i="0">
-                <a:solidFill>
-                  <a:srgbClr val="25303B"/>
-                </a:solidFill>
-                <a:latin typeface="Manrope"/>
-                <a:cs typeface="Manrope"/>
-              </a:rPr>
-              <a:t>CM-665  </a:t>
-            </a:r>
-            <a:r>
-              <a:rPr sz="720" b="0" i="0">
-                <a:solidFill>
-                  <a:srgbClr val="25303B"/>
-                </a:solidFill>
-                <a:latin typeface="Manrope"/>
-                <a:cs typeface="Manrope"/>
-              </a:rPr>
-              <a:t>Automated transit-delay detection &amp; escalation  </a:t>
-            </a:r>
-            <a:r>
-              <a:rPr sz="640" b="1" i="1">
-                <a:solidFill>
-                  <a:srgbClr val="6043A3"/>
-                </a:solidFill>
-                <a:latin typeface="Manrope"/>
-                <a:cs typeface="Manrope"/>
-              </a:rPr>
-              <a:t>Prioritised</a:t>
+              <a:t>Automate ops — advance payments for Gold/Silver FOs, pre-transit SIM-consent collection, and transit-delay detection &amp; escalation.</a:t>
             </a:r>
           </a:p>
         </p:txBody>
       </p:sp>
       <p:sp>
         <p:nvSpPr>
-          <p:cNvPr id="20" name="Rounded Rectangle 19"/>
+          <p:cNvPr id="30" name="Rounded Rectangle 29"/>
           <p:cNvSpPr/>
           <p:nvPr/>
         </p:nvSpPr>
         <p:spPr>
           <a:xfrm>
-            <a:off x="3139533" y="966000"/>
-            <a:ext cx="2864933" cy="2854000"/>
+            <a:off x="3139533" y="980000"/>
+            <a:ext cx="2864933" cy="3320000"/>
           </a:xfrm>
           <a:prstGeom prst="roundRect">
             <a:avLst>
@@ -22546,13 +22495,13 @@
       </p:sp>
       <p:sp>
         <p:nvSpPr>
-          <p:cNvPr id="21" name="Rounded Rectangle 20"/>
+          <p:cNvPr id="31" name="Rounded Rectangle 30"/>
           <p:cNvSpPr/>
           <p:nvPr/>
         </p:nvSpPr>
         <p:spPr>
           <a:xfrm>
-            <a:off x="3139533" y="966000"/>
+            <a:off x="3139533" y="980000"/>
             <a:ext cx="2864933" cy="250000"/>
           </a:xfrm>
           <a:prstGeom prst="roundRect">
@@ -22592,14 +22541,14 @@
       </p:sp>
       <p:sp>
         <p:nvSpPr>
-          <p:cNvPr id="22" name="TextBox 21"/>
+          <p:cNvPr id="32" name="TextBox 31"/>
           <p:cNvSpPr txBox="1"/>
           <p:nvPr/>
         </p:nvSpPr>
         <p:spPr>
           <a:xfrm>
-            <a:off x="3209533" y="966000"/>
-            <a:ext cx="2774933" cy="250000"/>
+            <a:off x="3219533" y="980000"/>
+            <a:ext cx="2764933" cy="250000"/>
           </a:xfrm>
           <a:prstGeom prst="rect">
             <a:avLst/>
@@ -22624,38 +22573,84 @@
               </a:spcAft>
             </a:pPr>
             <a:r>
-              <a:rPr sz="1000" b="1" i="0">
+              <a:rPr sz="1100" b="1" i="0">
                 <a:solidFill>
                   <a:srgbClr val="FFFFFF"/>
                 </a:solidFill>
                 <a:latin typeface="Manrope"/>
                 <a:cs typeface="Manrope"/>
               </a:rPr>
-              <a:t>AUGUST   </a:t>
+              <a:t>AUGUST    </a:t>
             </a:r>
             <a:r>
-              <a:rPr sz="850" b="1" i="0">
+              <a:rPr sz="800" b="1" i="0">
                 <a:solidFill>
                   <a:srgbClr val="C5CCD6"/>
                 </a:solidFill>
                 <a:latin typeface="Manrope"/>
                 <a:cs typeface="Manrope"/>
               </a:rPr>
-              <a:t>(11)</a:t>
+              <a:t>11 stories</a:t>
             </a:r>
           </a:p>
         </p:txBody>
       </p:sp>
       <p:sp>
         <p:nvSpPr>
-          <p:cNvPr id="23" name="TextBox 22"/>
+          <p:cNvPr id="33" name="Rounded Rectangle 32"/>
+          <p:cNvSpPr/>
+          <p:nvPr/>
+        </p:nvSpPr>
+        <p:spPr>
+          <a:xfrm>
+            <a:off x="3195533" y="1272000"/>
+            <a:ext cx="44000" cy="660500"/>
+          </a:xfrm>
+          <a:prstGeom prst="roundRect">
+            <a:avLst>
+              <a:gd name="adj" fmla="val 40000"/>
+            </a:avLst>
+          </a:prstGeom>
+          <a:solidFill>
+            <a:srgbClr val="1F3763"/>
+          </a:solidFill>
+          <a:ln>
+            <a:noFill/>
+          </a:ln>
+          <a:effectLst/>
+        </p:spPr>
+        <p:style>
+          <a:lnRef idx="1">
+            <a:schemeClr val="accent1"/>
+          </a:lnRef>
+          <a:fillRef idx="3">
+            <a:schemeClr val="accent1"/>
+          </a:fillRef>
+          <a:effectRef idx="2">
+            <a:schemeClr val="accent1"/>
+          </a:effectRef>
+          <a:fontRef idx="minor">
+            <a:schemeClr val="lt1"/>
+          </a:fontRef>
+        </p:style>
+        <p:txBody>
+          <a:bodyPr rtlCol="0" anchor="ctr"/>
+          <a:lstStyle/>
+          <a:p>
+            <a:pPr algn="ctr"/>
+          </a:p>
+        </p:txBody>
+      </p:sp>
+      <p:sp>
+        <p:nvSpPr>
+          <p:cNvPr id="34" name="TextBox 33"/>
           <p:cNvSpPr txBox="1"/>
           <p:nvPr/>
         </p:nvSpPr>
         <p:spPr>
           <a:xfrm>
-            <a:off x="3203533" y="1272000"/>
-            <a:ext cx="2754933" cy="2548000"/>
+            <a:off x="3279533" y="1264000"/>
+            <a:ext cx="2664933" cy="694500"/>
           </a:xfrm>
           <a:prstGeom prst="rect">
             <a:avLst/>
@@ -22663,585 +22658,561 @@
           <a:noFill/>
         </p:spPr>
         <p:txBody>
-          <a:bodyPr wrap="square" anchor="t" lIns="0" rIns="0" tIns="0" bIns="0">
+          <a:bodyPr wrap="square" anchor="ctr" lIns="0" rIns="0" tIns="0" bIns="0">
             <a:spAutoFit/>
           </a:bodyPr>
           <a:lstStyle/>
           <a:p>
-            <a:pPr algn="l" indent="-110000" marL="110000">
-              <a:lnSpc>
-                <a:spcPct val="102000"/>
-              </a:lnSpc>
-              <a:spcBef>
-                <a:spcPts val="0"/>
-              </a:spcBef>
-              <a:spcAft>
-                <a:spcPts val="320"/>
+            <a:pPr algn="l">
+              <a:lnSpc>
+                <a:spcPct val="100000"/>
+              </a:lnSpc>
+              <a:spcBef>
+                <a:spcPts val="0"/>
+              </a:spcBef>
+              <a:spcAft>
+                <a:spcPts val="300"/>
               </a:spcAft>
             </a:pPr>
             <a:r>
-              <a:rPr sz="700" b="0" i="0">
+              <a:rPr sz="900" b="1" i="0">
                 <a:solidFill>
                   <a:srgbClr val="1F3763"/>
                 </a:solidFill>
                 <a:latin typeface="Manrope"/>
                 <a:cs typeface="Manrope"/>
               </a:rPr>
-              <a:t>● </a:t>
+              <a:t>Ledger   </a:t>
             </a:r>
             <a:r>
-              <a:rPr sz="720" b="0" i="0">
-                <a:solidFill>
-                  <a:srgbClr val="25303B"/>
+              <a:rPr sz="700" b="1" i="0">
+                <a:solidFill>
+                  <a:srgbClr val="6B7480"/>
                 </a:solidFill>
                 <a:latin typeface="Manrope"/>
                 <a:cs typeface="Manrope"/>
               </a:rPr>
-              <a:t>Ledger Phase-1 production rollout (continues from July)  </a:t>
+              <a:t>· 4 stories</a:t>
             </a:r>
+          </a:p>
+          <a:p>
+            <a:pPr algn="l">
+              <a:lnSpc>
+                <a:spcPct val="108000"/>
+              </a:lnSpc>
+              <a:spcBef>
+                <a:spcPts val="0"/>
+              </a:spcBef>
+              <a:spcAft>
+                <a:spcPts val="0"/>
+              </a:spcAft>
+            </a:pPr>
             <a:r>
-              <a:rPr sz="640" b="1" i="1">
-                <a:solidFill>
-                  <a:srgbClr val="1F3763"/>
+              <a:rPr sz="760" b="0" i="0">
+                <a:solidFill>
+                  <a:srgbClr val="25303B"/>
                 </a:solidFill>
                 <a:latin typeface="Manrope"/>
                 <a:cs typeface="Manrope"/>
               </a:rPr>
-              <a:t>In Dev</a:t>
+              <a:t>Take Ledger Phase-1 to production and bring finance into the FO App — 3-yr trip statement, trip-level TDS rate, and self-serve TDS declaration.</a:t>
+            </a:r>
+          </a:p>
+        </p:txBody>
+      </p:sp>
+      <p:cxnSp>
+        <p:nvCxnSpPr>
+          <p:cNvPr id="35" name="Connector 34"/>
+          <p:cNvCxnSpPr/>
+          <p:nvPr/>
+        </p:nvCxnSpPr>
+        <p:spPr>
+          <a:xfrm>
+            <a:off x="3209533" y="1982500"/>
+            <a:ext cx="2724933" cy="0"/>
+          </a:xfrm>
+          <a:prstGeom prst="line">
+            <a:avLst/>
+          </a:prstGeom>
+          <a:ln w="6350">
+            <a:solidFill>
+              <a:srgbClr val="E4E8ED"/>
+            </a:solidFill>
+          </a:ln>
+          <a:effectLst/>
+        </p:spPr>
+        <p:style>
+          <a:lnRef idx="2">
+            <a:schemeClr val="accent1"/>
+          </a:lnRef>
+          <a:fillRef idx="0">
+            <a:schemeClr val="accent1"/>
+          </a:fillRef>
+          <a:effectRef idx="1">
+            <a:schemeClr val="accent1"/>
+          </a:effectRef>
+          <a:fontRef idx="minor">
+            <a:schemeClr val="tx1"/>
+          </a:fontRef>
+        </p:style>
+      </p:cxnSp>
+      <p:sp>
+        <p:nvSpPr>
+          <p:cNvPr id="36" name="Rounded Rectangle 35"/>
+          <p:cNvSpPr/>
+          <p:nvPr/>
+        </p:nvSpPr>
+        <p:spPr>
+          <a:xfrm>
+            <a:off x="3195533" y="2024500"/>
+            <a:ext cx="44000" cy="660500"/>
+          </a:xfrm>
+          <a:prstGeom prst="roundRect">
+            <a:avLst>
+              <a:gd name="adj" fmla="val 40000"/>
+            </a:avLst>
+          </a:prstGeom>
+          <a:solidFill>
+            <a:srgbClr val="26815C"/>
+          </a:solidFill>
+          <a:ln>
+            <a:noFill/>
+          </a:ln>
+          <a:effectLst/>
+        </p:spPr>
+        <p:style>
+          <a:lnRef idx="1">
+            <a:schemeClr val="accent1"/>
+          </a:lnRef>
+          <a:fillRef idx="3">
+            <a:schemeClr val="accent1"/>
+          </a:fillRef>
+          <a:effectRef idx="2">
+            <a:schemeClr val="accent1"/>
+          </a:effectRef>
+          <a:fontRef idx="minor">
+            <a:schemeClr val="lt1"/>
+          </a:fontRef>
+        </p:style>
+        <p:txBody>
+          <a:bodyPr rtlCol="0" anchor="ctr"/>
+          <a:lstStyle/>
+          <a:p>
+            <a:pPr algn="ctr"/>
+          </a:p>
+        </p:txBody>
+      </p:sp>
+      <p:sp>
+        <p:nvSpPr>
+          <p:cNvPr id="37" name="TextBox 36"/>
+          <p:cNvSpPr txBox="1"/>
+          <p:nvPr/>
+        </p:nvSpPr>
+        <p:spPr>
+          <a:xfrm>
+            <a:off x="3279533" y="2016500"/>
+            <a:ext cx="2664933" cy="694500"/>
+          </a:xfrm>
+          <a:prstGeom prst="rect">
+            <a:avLst/>
+          </a:prstGeom>
+          <a:noFill/>
+        </p:spPr>
+        <p:txBody>
+          <a:bodyPr wrap="square" anchor="ctr" lIns="0" rIns="0" tIns="0" bIns="0">
+            <a:spAutoFit/>
+          </a:bodyPr>
+          <a:lstStyle/>
+          <a:p>
+            <a:pPr algn="l">
+              <a:lnSpc>
+                <a:spcPct val="100000"/>
+              </a:lnSpc>
+              <a:spcBef>
+                <a:spcPts val="0"/>
+              </a:spcBef>
+              <a:spcAft>
+                <a:spcPts val="300"/>
+              </a:spcAft>
+            </a:pPr>
+            <a:r>
+              <a:rPr sz="900" b="1" i="0">
+                <a:solidFill>
+                  <a:srgbClr val="26815C"/>
+                </a:solidFill>
+                <a:latin typeface="Manrope"/>
+                <a:cs typeface="Manrope"/>
+              </a:rPr>
+              <a:t>Fulfilment %   </a:t>
+            </a:r>
+            <a:r>
+              <a:rPr sz="700" b="1" i="0">
+                <a:solidFill>
+                  <a:srgbClr val="6B7480"/>
+                </a:solidFill>
+                <a:latin typeface="Manrope"/>
+                <a:cs typeface="Manrope"/>
+              </a:rPr>
+              <a:t>· 5 stories</a:t>
             </a:r>
           </a:p>
           <a:p>
-            <a:pPr algn="l" indent="-110000" marL="110000">
-              <a:lnSpc>
-                <a:spcPct val="102000"/>
-              </a:lnSpc>
-              <a:spcBef>
-                <a:spcPts val="0"/>
-              </a:spcBef>
-              <a:spcAft>
-                <a:spcPts val="320"/>
+            <a:pPr algn="l">
+              <a:lnSpc>
+                <a:spcPct val="108000"/>
+              </a:lnSpc>
+              <a:spcBef>
+                <a:spcPts val="0"/>
+              </a:spcBef>
+              <a:spcAft>
+                <a:spcPts val="0"/>
               </a:spcAft>
             </a:pPr>
             <a:r>
-              <a:rPr sz="700" b="0" i="0">
-                <a:solidFill>
-                  <a:srgbClr val="1F3763"/>
+              <a:rPr sz="760" b="0" i="0">
+                <a:solidFill>
+                  <a:srgbClr val="25303B"/>
                 </a:solidFill>
                 <a:latin typeface="Manrope"/>
                 <a:cs typeface="Manrope"/>
               </a:rPr>
-              <a:t>● </a:t>
+              <a:t>Prioritise placeable demand — auto CRM alerts, Demand-Actionability-Score sorting, vehicle heat-map, auto tracking-master updates, and in-CRM calling with callbacks.</a:t>
             </a:r>
+          </a:p>
+        </p:txBody>
+      </p:sp>
+      <p:cxnSp>
+        <p:nvCxnSpPr>
+          <p:cNvPr id="38" name="Connector 37"/>
+          <p:cNvCxnSpPr/>
+          <p:nvPr/>
+        </p:nvCxnSpPr>
+        <p:spPr>
+          <a:xfrm>
+            <a:off x="3209533" y="2735000"/>
+            <a:ext cx="2724933" cy="0"/>
+          </a:xfrm>
+          <a:prstGeom prst="line">
+            <a:avLst/>
+          </a:prstGeom>
+          <a:ln w="6350">
+            <a:solidFill>
+              <a:srgbClr val="E4E8ED"/>
+            </a:solidFill>
+          </a:ln>
+          <a:effectLst/>
+        </p:spPr>
+        <p:style>
+          <a:lnRef idx="2">
+            <a:schemeClr val="accent1"/>
+          </a:lnRef>
+          <a:fillRef idx="0">
+            <a:schemeClr val="accent1"/>
+          </a:fillRef>
+          <a:effectRef idx="1">
+            <a:schemeClr val="accent1"/>
+          </a:effectRef>
+          <a:fontRef idx="minor">
+            <a:schemeClr val="tx1"/>
+          </a:fontRef>
+        </p:style>
+      </p:cxnSp>
+      <p:sp>
+        <p:nvSpPr>
+          <p:cNvPr id="39" name="Rounded Rectangle 38"/>
+          <p:cNvSpPr/>
+          <p:nvPr/>
+        </p:nvSpPr>
+        <p:spPr>
+          <a:xfrm>
+            <a:off x="3195533" y="2777000"/>
+            <a:ext cx="44000" cy="660500"/>
+          </a:xfrm>
+          <a:prstGeom prst="roundRect">
+            <a:avLst>
+              <a:gd name="adj" fmla="val 40000"/>
+            </a:avLst>
+          </a:prstGeom>
+          <a:solidFill>
+            <a:srgbClr val="6043A3"/>
+          </a:solidFill>
+          <a:ln>
+            <a:noFill/>
+          </a:ln>
+          <a:effectLst/>
+        </p:spPr>
+        <p:style>
+          <a:lnRef idx="1">
+            <a:schemeClr val="accent1"/>
+          </a:lnRef>
+          <a:fillRef idx="3">
+            <a:schemeClr val="accent1"/>
+          </a:fillRef>
+          <a:effectRef idx="2">
+            <a:schemeClr val="accent1"/>
+          </a:effectRef>
+          <a:fontRef idx="minor">
+            <a:schemeClr val="lt1"/>
+          </a:fontRef>
+        </p:style>
+        <p:txBody>
+          <a:bodyPr rtlCol="0" anchor="ctr"/>
+          <a:lstStyle/>
+          <a:p>
+            <a:pPr algn="ctr"/>
+          </a:p>
+        </p:txBody>
+      </p:sp>
+      <p:sp>
+        <p:nvSpPr>
+          <p:cNvPr id="40" name="TextBox 39"/>
+          <p:cNvSpPr txBox="1"/>
+          <p:nvPr/>
+        </p:nvSpPr>
+        <p:spPr>
+          <a:xfrm>
+            <a:off x="3279533" y="2769000"/>
+            <a:ext cx="2664933" cy="694500"/>
+          </a:xfrm>
+          <a:prstGeom prst="rect">
+            <a:avLst/>
+          </a:prstGeom>
+          <a:noFill/>
+        </p:spPr>
+        <p:txBody>
+          <a:bodyPr wrap="square" anchor="ctr" lIns="0" rIns="0" tIns="0" bIns="0">
+            <a:spAutoFit/>
+          </a:bodyPr>
+          <a:lstStyle/>
+          <a:p>
+            <a:pPr algn="l">
+              <a:lnSpc>
+                <a:spcPct val="100000"/>
+              </a:lnSpc>
+              <a:spcBef>
+                <a:spcPts val="0"/>
+              </a:spcBef>
+              <a:spcAft>
+                <a:spcPts val="300"/>
+              </a:spcAft>
+            </a:pPr>
             <a:r>
-              <a:rPr sz="720" b="1" i="0">
-                <a:solidFill>
-                  <a:srgbClr val="25303B"/>
+              <a:rPr sz="900" b="1" i="0">
+                <a:solidFill>
+                  <a:srgbClr val="6043A3"/>
                 </a:solidFill>
                 <a:latin typeface="Manrope"/>
                 <a:cs typeface="Manrope"/>
               </a:rPr>
-              <a:t>CM-784  </a:t>
+              <a:t>DAU   </a:t>
             </a:r>
             <a:r>
-              <a:rPr sz="720" b="0" i="0">
-                <a:solidFill>
-                  <a:srgbClr val="25303B"/>
+              <a:rPr sz="700" b="1" i="0">
+                <a:solidFill>
+                  <a:srgbClr val="6B7480"/>
                 </a:solidFill>
                 <a:latin typeface="Manrope"/>
                 <a:cs typeface="Manrope"/>
               </a:rPr>
-              <a:t>Trip Statement — 3-yr financial ledger tab in FO App  </a:t>
+              <a:t>· 1 story</a:t>
             </a:r>
+          </a:p>
+          <a:p>
+            <a:pPr algn="l">
+              <a:lnSpc>
+                <a:spcPct val="108000"/>
+              </a:lnSpc>
+              <a:spcBef>
+                <a:spcPts val="0"/>
+              </a:spcBef>
+              <a:spcAft>
+                <a:spcPts val="0"/>
+              </a:spcAft>
+            </a:pPr>
             <a:r>
-              <a:rPr sz="640" b="1" i="1">
-                <a:solidFill>
-                  <a:srgbClr val="6043A3"/>
+              <a:rPr sz="760" b="0" i="0">
+                <a:solidFill>
+                  <a:srgbClr val="25303B"/>
                 </a:solidFill>
                 <a:latin typeface="Manrope"/>
                 <a:cs typeface="Manrope"/>
               </a:rPr>
-              <a:t>Prioritised</a:t>
+              <a:t>Extend ticketing to FOs not on the app via WhatsApp / IVR / agent.</a:t>
+            </a:r>
+          </a:p>
+        </p:txBody>
+      </p:sp>
+      <p:cxnSp>
+        <p:nvCxnSpPr>
+          <p:cNvPr id="41" name="Connector 40"/>
+          <p:cNvCxnSpPr/>
+          <p:nvPr/>
+        </p:nvCxnSpPr>
+        <p:spPr>
+          <a:xfrm>
+            <a:off x="3209533" y="3487500"/>
+            <a:ext cx="2724933" cy="0"/>
+          </a:xfrm>
+          <a:prstGeom prst="line">
+            <a:avLst/>
+          </a:prstGeom>
+          <a:ln w="6350">
+            <a:solidFill>
+              <a:srgbClr val="E4E8ED"/>
+            </a:solidFill>
+          </a:ln>
+          <a:effectLst/>
+        </p:spPr>
+        <p:style>
+          <a:lnRef idx="2">
+            <a:schemeClr val="accent1"/>
+          </a:lnRef>
+          <a:fillRef idx="0">
+            <a:schemeClr val="accent1"/>
+          </a:fillRef>
+          <a:effectRef idx="1">
+            <a:schemeClr val="accent1"/>
+          </a:effectRef>
+          <a:fontRef idx="minor">
+            <a:schemeClr val="tx1"/>
+          </a:fontRef>
+        </p:style>
+      </p:cxnSp>
+      <p:sp>
+        <p:nvSpPr>
+          <p:cNvPr id="42" name="Rounded Rectangle 41"/>
+          <p:cNvSpPr/>
+          <p:nvPr/>
+        </p:nvSpPr>
+        <p:spPr>
+          <a:xfrm>
+            <a:off x="3195533" y="3529500"/>
+            <a:ext cx="44000" cy="660500"/>
+          </a:xfrm>
+          <a:prstGeom prst="roundRect">
+            <a:avLst>
+              <a:gd name="adj" fmla="val 40000"/>
+            </a:avLst>
+          </a:prstGeom>
+          <a:solidFill>
+            <a:srgbClr val="C77D0A"/>
+          </a:solidFill>
+          <a:ln>
+            <a:noFill/>
+          </a:ln>
+          <a:effectLst/>
+        </p:spPr>
+        <p:style>
+          <a:lnRef idx="1">
+            <a:schemeClr val="accent1"/>
+          </a:lnRef>
+          <a:fillRef idx="3">
+            <a:schemeClr val="accent1"/>
+          </a:fillRef>
+          <a:effectRef idx="2">
+            <a:schemeClr val="accent1"/>
+          </a:effectRef>
+          <a:fontRef idx="minor">
+            <a:schemeClr val="lt1"/>
+          </a:fontRef>
+        </p:style>
+        <p:txBody>
+          <a:bodyPr rtlCol="0" anchor="ctr"/>
+          <a:lstStyle/>
+          <a:p>
+            <a:pPr algn="ctr"/>
+          </a:p>
+        </p:txBody>
+      </p:sp>
+      <p:sp>
+        <p:nvSpPr>
+          <p:cNvPr id="43" name="TextBox 42"/>
+          <p:cNvSpPr txBox="1"/>
+          <p:nvPr/>
+        </p:nvSpPr>
+        <p:spPr>
+          <a:xfrm>
+            <a:off x="3279533" y="3521500"/>
+            <a:ext cx="2664933" cy="694500"/>
+          </a:xfrm>
+          <a:prstGeom prst="rect">
+            <a:avLst/>
+          </a:prstGeom>
+          <a:noFill/>
+        </p:spPr>
+        <p:txBody>
+          <a:bodyPr wrap="square" anchor="ctr" lIns="0" rIns="0" tIns="0" bIns="0">
+            <a:spAutoFit/>
+          </a:bodyPr>
+          <a:lstStyle/>
+          <a:p>
+            <a:pPr algn="l">
+              <a:lnSpc>
+                <a:spcPct val="100000"/>
+              </a:lnSpc>
+              <a:spcBef>
+                <a:spcPts val="0"/>
+              </a:spcBef>
+              <a:spcAft>
+                <a:spcPts val="300"/>
+              </a:spcAft>
+            </a:pPr>
+            <a:r>
+              <a:rPr sz="900" b="1" i="0">
+                <a:solidFill>
+                  <a:srgbClr val="C77D0A"/>
+                </a:solidFill>
+                <a:latin typeface="Manrope"/>
+                <a:cs typeface="Manrope"/>
+              </a:rPr>
+              <a:t>Reduce Ops Bandwidth   </a:t>
+            </a:r>
+            <a:r>
+              <a:rPr sz="700" b="1" i="0">
+                <a:solidFill>
+                  <a:srgbClr val="6B7480"/>
+                </a:solidFill>
+                <a:latin typeface="Manrope"/>
+                <a:cs typeface="Manrope"/>
+              </a:rPr>
+              <a:t>· 1 story</a:t>
             </a:r>
           </a:p>
           <a:p>
-            <a:pPr algn="l" indent="-110000" marL="110000">
-              <a:lnSpc>
-                <a:spcPct val="102000"/>
-              </a:lnSpc>
-              <a:spcBef>
-                <a:spcPts val="0"/>
-              </a:spcBef>
-              <a:spcAft>
-                <a:spcPts val="320"/>
+            <a:pPr algn="l">
+              <a:lnSpc>
+                <a:spcPct val="108000"/>
+              </a:lnSpc>
+              <a:spcBef>
+                <a:spcPts val="0"/>
+              </a:spcBef>
+              <a:spcAft>
+                <a:spcPts val="0"/>
               </a:spcAft>
             </a:pPr>
             <a:r>
-              <a:rPr sz="700" b="0" i="0">
-                <a:solidFill>
-                  <a:srgbClr val="1F3763"/>
+              <a:rPr sz="760" b="0" i="0">
+                <a:solidFill>
+                  <a:srgbClr val="25303B"/>
                 </a:solidFill>
                 <a:latin typeface="Manrope"/>
                 <a:cs typeface="Manrope"/>
               </a:rPr>
-              <a:t>● </a:t>
-            </a:r>
-            <a:r>
-              <a:rPr sz="720" b="1" i="0">
-                <a:solidFill>
-                  <a:srgbClr val="25303B"/>
-                </a:solidFill>
-                <a:latin typeface="Manrope"/>
-                <a:cs typeface="Manrope"/>
-              </a:rPr>
-              <a:t>CM-736  </a:t>
-            </a:r>
-            <a:r>
-              <a:rPr sz="720" b="0" i="0">
-                <a:solidFill>
-                  <a:srgbClr val="25303B"/>
-                </a:solidFill>
-                <a:latin typeface="Manrope"/>
-                <a:cs typeface="Manrope"/>
-              </a:rPr>
-              <a:t>FO App: show TDS rate at trip level  </a:t>
-            </a:r>
-            <a:r>
-              <a:rPr sz="640" b="1" i="1">
-                <a:solidFill>
-                  <a:srgbClr val="6043A3"/>
-                </a:solidFill>
-                <a:latin typeface="Manrope"/>
-                <a:cs typeface="Manrope"/>
-              </a:rPr>
-              <a:t>Prioritised</a:t>
-            </a:r>
-          </a:p>
-          <a:p>
-            <a:pPr algn="l" indent="-110000" marL="110000">
-              <a:lnSpc>
-                <a:spcPct val="102000"/>
-              </a:lnSpc>
-              <a:spcBef>
-                <a:spcPts val="0"/>
-              </a:spcBef>
-              <a:spcAft>
-                <a:spcPts val="320"/>
-              </a:spcAft>
-            </a:pPr>
-            <a:r>
-              <a:rPr sz="700" b="0" i="0">
-                <a:solidFill>
-                  <a:srgbClr val="1F3763"/>
-                </a:solidFill>
-                <a:latin typeface="Manrope"/>
-                <a:cs typeface="Manrope"/>
-              </a:rPr>
-              <a:t>● </a:t>
-            </a:r>
-            <a:r>
-              <a:rPr sz="720" b="1" i="0">
-                <a:solidFill>
-                  <a:srgbClr val="25303B"/>
-                </a:solidFill>
-                <a:latin typeface="Manrope"/>
-                <a:cs typeface="Manrope"/>
-              </a:rPr>
-              <a:t>CM-791  </a:t>
-            </a:r>
-            <a:r>
-              <a:rPr sz="720" b="0" i="0">
-                <a:solidFill>
-                  <a:srgbClr val="25303B"/>
-                </a:solidFill>
-                <a:latin typeface="Manrope"/>
-                <a:cs typeface="Manrope"/>
-              </a:rPr>
-              <a:t>TDS transparency + self-serve TDS declaration in FO App  </a:t>
-            </a:r>
-            <a:r>
-              <a:rPr sz="640" b="1" i="1">
-                <a:solidFill>
-                  <a:srgbClr val="6043A3"/>
-                </a:solidFill>
-                <a:latin typeface="Manrope"/>
-                <a:cs typeface="Manrope"/>
-              </a:rPr>
-              <a:t>Prioritised</a:t>
-            </a:r>
-          </a:p>
-          <a:p>
-            <a:pPr algn="l" indent="-110000" marL="110000">
-              <a:lnSpc>
-                <a:spcPct val="102000"/>
-              </a:lnSpc>
-              <a:spcBef>
-                <a:spcPts val="0"/>
-              </a:spcBef>
-              <a:spcAft>
-                <a:spcPts val="320"/>
-              </a:spcAft>
-            </a:pPr>
-            <a:r>
-              <a:rPr sz="700" b="0" i="0">
-                <a:solidFill>
-                  <a:srgbClr val="26815C"/>
-                </a:solidFill>
-                <a:latin typeface="Manrope"/>
-                <a:cs typeface="Manrope"/>
-              </a:rPr>
-              <a:t>● </a:t>
-            </a:r>
-            <a:r>
-              <a:rPr sz="720" b="1" i="0">
-                <a:solidFill>
-                  <a:srgbClr val="25303B"/>
-                </a:solidFill>
-                <a:latin typeface="Manrope"/>
-                <a:cs typeface="Manrope"/>
-              </a:rPr>
-              <a:t>CM-821  </a:t>
-            </a:r>
-            <a:r>
-              <a:rPr sz="720" b="0" i="0">
-                <a:solidFill>
-                  <a:srgbClr val="25303B"/>
-                </a:solidFill>
-                <a:latin typeface="Manrope"/>
-                <a:cs typeface="Manrope"/>
-              </a:rPr>
-              <a:t>Auto CRM alerts: bids received / inventory matched / approval assigned  </a:t>
-            </a:r>
-            <a:r>
-              <a:rPr sz="640" b="1" i="1">
-                <a:solidFill>
-                  <a:srgbClr val="6043A3"/>
-                </a:solidFill>
-                <a:latin typeface="Manrope"/>
-                <a:cs typeface="Manrope"/>
-              </a:rPr>
-              <a:t>Prioritised</a:t>
-            </a:r>
-          </a:p>
-          <a:p>
-            <a:pPr algn="l" indent="-110000" marL="110000">
-              <a:lnSpc>
-                <a:spcPct val="102000"/>
-              </a:lnSpc>
-              <a:spcBef>
-                <a:spcPts val="0"/>
-              </a:spcBef>
-              <a:spcAft>
-                <a:spcPts val="320"/>
-              </a:spcAft>
-            </a:pPr>
-            <a:r>
-              <a:rPr sz="700" b="0" i="0">
-                <a:solidFill>
-                  <a:srgbClr val="26815C"/>
-                </a:solidFill>
-                <a:latin typeface="Manrope"/>
-                <a:cs typeface="Manrope"/>
-              </a:rPr>
-              <a:t>● </a:t>
-            </a:r>
-            <a:r>
-              <a:rPr sz="720" b="1" i="0">
-                <a:solidFill>
-                  <a:srgbClr val="25303B"/>
-                </a:solidFill>
-                <a:latin typeface="Manrope"/>
-                <a:cs typeface="Manrope"/>
-              </a:rPr>
-              <a:t>CM-377  </a:t>
-            </a:r>
-            <a:r>
-              <a:rPr sz="720" b="0" i="0">
-                <a:solidFill>
-                  <a:srgbClr val="25303B"/>
-                </a:solidFill>
-                <a:latin typeface="Manrope"/>
-                <a:cs typeface="Manrope"/>
-              </a:rPr>
-              <a:t>Sort demand by Demand Actionability Score to prioritise loads  </a:t>
-            </a:r>
-            <a:r>
-              <a:rPr sz="640" b="1" i="1">
-                <a:solidFill>
-                  <a:srgbClr val="6B7480"/>
-                </a:solidFill>
-                <a:latin typeface="Manrope"/>
-                <a:cs typeface="Manrope"/>
-              </a:rPr>
-              <a:t>Planned</a:t>
-            </a:r>
-          </a:p>
-          <a:p>
-            <a:pPr algn="l" indent="-110000" marL="110000">
-              <a:lnSpc>
-                <a:spcPct val="102000"/>
-              </a:lnSpc>
-              <a:spcBef>
-                <a:spcPts val="0"/>
-              </a:spcBef>
-              <a:spcAft>
-                <a:spcPts val="320"/>
-              </a:spcAft>
-            </a:pPr>
-            <a:r>
-              <a:rPr sz="700" b="0" i="0">
-                <a:solidFill>
-                  <a:srgbClr val="26815C"/>
-                </a:solidFill>
-                <a:latin typeface="Manrope"/>
-                <a:cs typeface="Manrope"/>
-              </a:rPr>
-              <a:t>● </a:t>
-            </a:r>
-            <a:r>
-              <a:rPr sz="720" b="1" i="0">
-                <a:solidFill>
-                  <a:srgbClr val="25303B"/>
-                </a:solidFill>
-                <a:latin typeface="Manrope"/>
-                <a:cs typeface="Manrope"/>
-              </a:rPr>
-              <a:t>CM-823  </a:t>
-            </a:r>
-            <a:r>
-              <a:rPr sz="720" b="0" i="0">
-                <a:solidFill>
-                  <a:srgbClr val="25303B"/>
-                </a:solidFill>
-                <a:latin typeface="Manrope"/>
-                <a:cs typeface="Manrope"/>
-              </a:rPr>
-              <a:t>Build vehicle heat-map for location movement  </a:t>
-            </a:r>
-            <a:r>
-              <a:rPr sz="640" b="1" i="1">
-                <a:solidFill>
-                  <a:srgbClr val="6B7480"/>
-                </a:solidFill>
-                <a:latin typeface="Manrope"/>
-                <a:cs typeface="Manrope"/>
-              </a:rPr>
-              <a:t>Planned</a:t>
-            </a:r>
-          </a:p>
-          <a:p>
-            <a:pPr algn="l" indent="-110000" marL="110000">
-              <a:lnSpc>
-                <a:spcPct val="102000"/>
-              </a:lnSpc>
-              <a:spcBef>
-                <a:spcPts val="0"/>
-              </a:spcBef>
-              <a:spcAft>
-                <a:spcPts val="320"/>
-              </a:spcAft>
-            </a:pPr>
-            <a:r>
-              <a:rPr sz="700" b="0" i="0">
-                <a:solidFill>
-                  <a:srgbClr val="26815C"/>
-                </a:solidFill>
-                <a:latin typeface="Manrope"/>
-                <a:cs typeface="Manrope"/>
-              </a:rPr>
-              <a:t>● </a:t>
-            </a:r>
-            <a:r>
-              <a:rPr sz="720" b="0" i="0">
-                <a:solidFill>
-                  <a:srgbClr val="25303B"/>
-                </a:solidFill>
-                <a:latin typeface="Manrope"/>
-                <a:cs typeface="Manrope"/>
-              </a:rPr>
-              <a:t>Auto-add vehicle to tracking master on trip completion (raise trackable count)  </a:t>
-            </a:r>
-            <a:r>
-              <a:rPr sz="640" b="1" i="1">
-                <a:solidFill>
-                  <a:srgbClr val="6B7480"/>
-                </a:solidFill>
-                <a:latin typeface="Manrope"/>
-                <a:cs typeface="Manrope"/>
-              </a:rPr>
-              <a:t>Planned</a:t>
-            </a:r>
-          </a:p>
-          <a:p>
-            <a:pPr algn="l" indent="-110000" marL="110000">
-              <a:lnSpc>
-                <a:spcPct val="102000"/>
-              </a:lnSpc>
-              <a:spcBef>
-                <a:spcPts val="0"/>
-              </a:spcBef>
-              <a:spcAft>
-                <a:spcPts val="320"/>
-              </a:spcAft>
-            </a:pPr>
-            <a:r>
-              <a:rPr sz="700" b="0" i="0">
-                <a:solidFill>
-                  <a:srgbClr val="26815C"/>
-                </a:solidFill>
-                <a:latin typeface="Manrope"/>
-                <a:cs typeface="Manrope"/>
-              </a:rPr>
-              <a:t>● </a:t>
-            </a:r>
-            <a:r>
-              <a:rPr sz="720" b="1" i="0">
-                <a:solidFill>
-                  <a:srgbClr val="25303B"/>
-                </a:solidFill>
-                <a:latin typeface="Manrope"/>
-                <a:cs typeface="Manrope"/>
-              </a:rPr>
-              <a:t>CM-824  </a:t>
-            </a:r>
-            <a:r>
-              <a:rPr sz="720" b="0" i="0">
-                <a:solidFill>
-                  <a:srgbClr val="25303B"/>
-                </a:solidFill>
-                <a:latin typeface="Manrope"/>
-                <a:cs typeface="Manrope"/>
-              </a:rPr>
-              <a:t>In-CRM calling with callback on unanswered calls  </a:t>
-            </a:r>
-            <a:r>
-              <a:rPr sz="640" b="1" i="1">
-                <a:solidFill>
-                  <a:srgbClr val="6B7480"/>
-                </a:solidFill>
-                <a:latin typeface="Manrope"/>
-                <a:cs typeface="Manrope"/>
-              </a:rPr>
-              <a:t>Planned</a:t>
-            </a:r>
-          </a:p>
-          <a:p>
-            <a:pPr algn="l" indent="-110000" marL="110000">
-              <a:lnSpc>
-                <a:spcPct val="102000"/>
-              </a:lnSpc>
-              <a:spcBef>
-                <a:spcPts val="0"/>
-              </a:spcBef>
-              <a:spcAft>
-                <a:spcPts val="320"/>
-              </a:spcAft>
-            </a:pPr>
-            <a:r>
-              <a:rPr sz="700" b="0" i="0">
-                <a:solidFill>
-                  <a:srgbClr val="6043A3"/>
-                </a:solidFill>
-                <a:latin typeface="Manrope"/>
-                <a:cs typeface="Manrope"/>
-              </a:rPr>
-              <a:t>● </a:t>
-            </a:r>
-            <a:r>
-              <a:rPr sz="720" b="1" i="0">
-                <a:solidFill>
-                  <a:srgbClr val="25303B"/>
-                </a:solidFill>
-                <a:latin typeface="Manrope"/>
-                <a:cs typeface="Manrope"/>
-              </a:rPr>
-              <a:t>CM-826  </a:t>
-            </a:r>
-            <a:r>
-              <a:rPr sz="720" b="0" i="0">
-                <a:solidFill>
-                  <a:srgbClr val="25303B"/>
-                </a:solidFill>
-                <a:latin typeface="Manrope"/>
-                <a:cs typeface="Manrope"/>
-              </a:rPr>
-              <a:t>Ticketing for FOs not on the app (WhatsApp / IVR / agent)  </a:t>
-            </a:r>
-            <a:r>
-              <a:rPr sz="640" b="1" i="1">
-                <a:solidFill>
-                  <a:srgbClr val="6B7480"/>
-                </a:solidFill>
-                <a:latin typeface="Manrope"/>
-                <a:cs typeface="Manrope"/>
-              </a:rPr>
-              <a:t>Planned</a:t>
-            </a:r>
-          </a:p>
-          <a:p>
-            <a:pPr algn="l" indent="-110000" marL="110000">
-              <a:lnSpc>
-                <a:spcPct val="102000"/>
-              </a:lnSpc>
-              <a:spcBef>
-                <a:spcPts val="0"/>
-              </a:spcBef>
-              <a:spcAft>
-                <a:spcPts val="320"/>
-              </a:spcAft>
-            </a:pPr>
-            <a:r>
-              <a:rPr sz="700" b="0" i="0">
-                <a:solidFill>
-                  <a:srgbClr val="C77D0A"/>
-                </a:solidFill>
-                <a:latin typeface="Manrope"/>
-                <a:cs typeface="Manrope"/>
-              </a:rPr>
-              <a:t>● </a:t>
-            </a:r>
-            <a:r>
-              <a:rPr sz="720" b="1" i="0">
-                <a:solidFill>
-                  <a:srgbClr val="25303B"/>
-                </a:solidFill>
-                <a:latin typeface="Manrope"/>
-                <a:cs typeface="Manrope"/>
-              </a:rPr>
-              <a:t>CM-825  </a:t>
-            </a:r>
-            <a:r>
-              <a:rPr sz="720" b="0" i="0">
-                <a:solidFill>
-                  <a:srgbClr val="25303B"/>
-                </a:solidFill>
-                <a:latin typeface="Manrope"/>
-                <a:cs typeface="Manrope"/>
-              </a:rPr>
-              <a:t>Auto-share loading location to driver (call + WhatsApp)  </a:t>
-            </a:r>
-            <a:r>
-              <a:rPr sz="640" b="1" i="1">
-                <a:solidFill>
-                  <a:srgbClr val="6B7480"/>
-                </a:solidFill>
-                <a:latin typeface="Manrope"/>
-                <a:cs typeface="Manrope"/>
-              </a:rPr>
-              <a:t>Planned</a:t>
+              <a:t>Auto-share the loading location to drivers over call + WhatsApp.</a:t>
             </a:r>
           </a:p>
         </p:txBody>
       </p:sp>
       <p:sp>
         <p:nvSpPr>
-          <p:cNvPr id="24" name="Rounded Rectangle 23"/>
+          <p:cNvPr id="44" name="Rounded Rectangle 43"/>
           <p:cNvSpPr/>
           <p:nvPr/>
         </p:nvSpPr>
         <p:spPr>
           <a:xfrm>
-            <a:off x="6050466" y="966000"/>
-            <a:ext cx="2864933" cy="2854000"/>
+            <a:off x="6050466" y="980000"/>
+            <a:ext cx="2864933" cy="3320000"/>
           </a:xfrm>
           <a:prstGeom prst="roundRect">
             <a:avLst>
@@ -23282,13 +23253,13 @@
       </p:sp>
       <p:sp>
         <p:nvSpPr>
-          <p:cNvPr id="25" name="Rounded Rectangle 24"/>
+          <p:cNvPr id="45" name="Rounded Rectangle 44"/>
           <p:cNvSpPr/>
           <p:nvPr/>
         </p:nvSpPr>
         <p:spPr>
           <a:xfrm>
-            <a:off x="6050466" y="966000"/>
+            <a:off x="6050466" y="980000"/>
             <a:ext cx="2864933" cy="250000"/>
           </a:xfrm>
           <a:prstGeom prst="roundRect">
@@ -23328,14 +23299,14 @@
       </p:sp>
       <p:sp>
         <p:nvSpPr>
-          <p:cNvPr id="26" name="TextBox 25"/>
+          <p:cNvPr id="46" name="TextBox 45"/>
           <p:cNvSpPr txBox="1"/>
           <p:nvPr/>
         </p:nvSpPr>
         <p:spPr>
           <a:xfrm>
-            <a:off x="6120466" y="966000"/>
-            <a:ext cx="2774933" cy="250000"/>
+            <a:off x="6130466" y="980000"/>
+            <a:ext cx="2764933" cy="250000"/>
           </a:xfrm>
           <a:prstGeom prst="rect">
             <a:avLst/>
@@ -23360,38 +23331,84 @@
               </a:spcAft>
             </a:pPr>
             <a:r>
-              <a:rPr sz="1000" b="1" i="0">
+              <a:rPr sz="1100" b="1" i="0">
                 <a:solidFill>
                   <a:srgbClr val="FFFFFF"/>
                 </a:solidFill>
                 <a:latin typeface="Manrope"/>
                 <a:cs typeface="Manrope"/>
               </a:rPr>
-              <a:t>SEPTEMBER   </a:t>
+              <a:t>SEPTEMBER    </a:t>
             </a:r>
             <a:r>
-              <a:rPr sz="850" b="1" i="0">
+              <a:rPr sz="800" b="1" i="0">
                 <a:solidFill>
                   <a:srgbClr val="C5CCD6"/>
                 </a:solidFill>
                 <a:latin typeface="Manrope"/>
                 <a:cs typeface="Manrope"/>
               </a:rPr>
-              <a:t>(6)</a:t>
+              <a:t>6 stories</a:t>
             </a:r>
           </a:p>
         </p:txBody>
       </p:sp>
       <p:sp>
         <p:nvSpPr>
-          <p:cNvPr id="27" name="TextBox 26"/>
+          <p:cNvPr id="47" name="Rounded Rectangle 46"/>
+          <p:cNvSpPr/>
+          <p:nvPr/>
+        </p:nvSpPr>
+        <p:spPr>
+          <a:xfrm>
+            <a:off x="6106466" y="1272000"/>
+            <a:ext cx="44000" cy="660500"/>
+          </a:xfrm>
+          <a:prstGeom prst="roundRect">
+            <a:avLst>
+              <a:gd name="adj" fmla="val 40000"/>
+            </a:avLst>
+          </a:prstGeom>
+          <a:solidFill>
+            <a:srgbClr val="1F3763"/>
+          </a:solidFill>
+          <a:ln>
+            <a:noFill/>
+          </a:ln>
+          <a:effectLst/>
+        </p:spPr>
+        <p:style>
+          <a:lnRef idx="1">
+            <a:schemeClr val="accent1"/>
+          </a:lnRef>
+          <a:fillRef idx="3">
+            <a:schemeClr val="accent1"/>
+          </a:fillRef>
+          <a:effectRef idx="2">
+            <a:schemeClr val="accent1"/>
+          </a:effectRef>
+          <a:fontRef idx="minor">
+            <a:schemeClr val="lt1"/>
+          </a:fontRef>
+        </p:style>
+        <p:txBody>
+          <a:bodyPr rtlCol="0" anchor="ctr"/>
+          <a:lstStyle/>
+          <a:p>
+            <a:pPr algn="ctr"/>
+          </a:p>
+        </p:txBody>
+      </p:sp>
+      <p:sp>
+        <p:nvSpPr>
+          <p:cNvPr id="48" name="TextBox 47"/>
           <p:cNvSpPr txBox="1"/>
           <p:nvPr/>
         </p:nvSpPr>
         <p:spPr>
           <a:xfrm>
-            <a:off x="6114466" y="1272000"/>
-            <a:ext cx="2754933" cy="2548000"/>
+            <a:off x="6190466" y="1264000"/>
+            <a:ext cx="2664933" cy="694500"/>
           </a:xfrm>
           <a:prstGeom prst="rect">
             <a:avLst/>
@@ -23399,329 +23416,560 @@
           <a:noFill/>
         </p:spPr>
         <p:txBody>
-          <a:bodyPr wrap="square" anchor="t" lIns="0" rIns="0" tIns="0" bIns="0">
+          <a:bodyPr wrap="square" anchor="ctr" lIns="0" rIns="0" tIns="0" bIns="0">
             <a:spAutoFit/>
           </a:bodyPr>
           <a:lstStyle/>
           <a:p>
-            <a:pPr algn="l" indent="-110000" marL="110000">
-              <a:lnSpc>
-                <a:spcPct val="102000"/>
-              </a:lnSpc>
-              <a:spcBef>
-                <a:spcPts val="0"/>
-              </a:spcBef>
-              <a:spcAft>
-                <a:spcPts val="320"/>
+            <a:pPr algn="l">
+              <a:lnSpc>
+                <a:spcPct val="100000"/>
+              </a:lnSpc>
+              <a:spcBef>
+                <a:spcPts val="0"/>
+              </a:spcBef>
+              <a:spcAft>
+                <a:spcPts val="300"/>
               </a:spcAft>
             </a:pPr>
             <a:r>
-              <a:rPr sz="700" b="0" i="0">
+              <a:rPr sz="900" b="1" i="0">
                 <a:solidFill>
                   <a:srgbClr val="1F3763"/>
                 </a:solidFill>
                 <a:latin typeface="Manrope"/>
                 <a:cs typeface="Manrope"/>
               </a:rPr>
-              <a:t>● </a:t>
+              <a:t>Ledger   </a:t>
             </a:r>
             <a:r>
-              <a:rPr sz="720" b="1" i="0">
-                <a:solidFill>
-                  <a:srgbClr val="25303B"/>
+              <a:rPr sz="700" b="1" i="0">
+                <a:solidFill>
+                  <a:srgbClr val="6B7480"/>
                 </a:solidFill>
                 <a:latin typeface="Manrope"/>
                 <a:cs typeface="Manrope"/>
               </a:rPr>
-              <a:t>CM-828  </a:t>
+              <a:t>· 1 story</a:t>
             </a:r>
+          </a:p>
+          <a:p>
+            <a:pPr algn="l">
+              <a:lnSpc>
+                <a:spcPct val="108000"/>
+              </a:lnSpc>
+              <a:spcBef>
+                <a:spcPts val="0"/>
+              </a:spcBef>
+              <a:spcAft>
+                <a:spcPts val="0"/>
+              </a:spcAft>
+            </a:pPr>
             <a:r>
-              <a:rPr sz="720" b="0" i="0">
+              <a:rPr sz="760" b="0" i="0">
                 <a:solidFill>
                   <a:srgbClr val="25303B"/>
                 </a:solidFill>
                 <a:latin typeface="Manrope"/>
                 <a:cs typeface="Manrope"/>
               </a:rPr>
-              <a:t>Configurable LSP exposure limit + auto-disable on breach  </a:t>
+              <a:t>Add configurable LSP exposure limits with auto-disable on breach.</a:t>
             </a:r>
+          </a:p>
+        </p:txBody>
+      </p:sp>
+      <p:cxnSp>
+        <p:nvCxnSpPr>
+          <p:cNvPr id="49" name="Connector 48"/>
+          <p:cNvCxnSpPr/>
+          <p:nvPr/>
+        </p:nvCxnSpPr>
+        <p:spPr>
+          <a:xfrm>
+            <a:off x="6120466" y="1982500"/>
+            <a:ext cx="2724933" cy="0"/>
+          </a:xfrm>
+          <a:prstGeom prst="line">
+            <a:avLst/>
+          </a:prstGeom>
+          <a:ln w="6350">
+            <a:solidFill>
+              <a:srgbClr val="E4E8ED"/>
+            </a:solidFill>
+          </a:ln>
+          <a:effectLst/>
+        </p:spPr>
+        <p:style>
+          <a:lnRef idx="2">
+            <a:schemeClr val="accent1"/>
+          </a:lnRef>
+          <a:fillRef idx="0">
+            <a:schemeClr val="accent1"/>
+          </a:fillRef>
+          <a:effectRef idx="1">
+            <a:schemeClr val="accent1"/>
+          </a:effectRef>
+          <a:fontRef idx="minor">
+            <a:schemeClr val="tx1"/>
+          </a:fontRef>
+        </p:style>
+      </p:cxnSp>
+      <p:sp>
+        <p:nvSpPr>
+          <p:cNvPr id="50" name="Rounded Rectangle 49"/>
+          <p:cNvSpPr/>
+          <p:nvPr/>
+        </p:nvSpPr>
+        <p:spPr>
+          <a:xfrm>
+            <a:off x="6106466" y="2024500"/>
+            <a:ext cx="44000" cy="660500"/>
+          </a:xfrm>
+          <a:prstGeom prst="roundRect">
+            <a:avLst>
+              <a:gd name="adj" fmla="val 40000"/>
+            </a:avLst>
+          </a:prstGeom>
+          <a:solidFill>
+            <a:srgbClr val="26815C"/>
+          </a:solidFill>
+          <a:ln>
+            <a:noFill/>
+          </a:ln>
+          <a:effectLst/>
+        </p:spPr>
+        <p:style>
+          <a:lnRef idx="1">
+            <a:schemeClr val="accent1"/>
+          </a:lnRef>
+          <a:fillRef idx="3">
+            <a:schemeClr val="accent1"/>
+          </a:fillRef>
+          <a:effectRef idx="2">
+            <a:schemeClr val="accent1"/>
+          </a:effectRef>
+          <a:fontRef idx="minor">
+            <a:schemeClr val="lt1"/>
+          </a:fontRef>
+        </p:style>
+        <p:txBody>
+          <a:bodyPr rtlCol="0" anchor="ctr"/>
+          <a:lstStyle/>
+          <a:p>
+            <a:pPr algn="ctr"/>
+          </a:p>
+        </p:txBody>
+      </p:sp>
+      <p:sp>
+        <p:nvSpPr>
+          <p:cNvPr id="51" name="TextBox 50"/>
+          <p:cNvSpPr txBox="1"/>
+          <p:nvPr/>
+        </p:nvSpPr>
+        <p:spPr>
+          <a:xfrm>
+            <a:off x="6190466" y="2016500"/>
+            <a:ext cx="2664933" cy="694500"/>
+          </a:xfrm>
+          <a:prstGeom prst="rect">
+            <a:avLst/>
+          </a:prstGeom>
+          <a:noFill/>
+        </p:spPr>
+        <p:txBody>
+          <a:bodyPr wrap="square" anchor="ctr" lIns="0" rIns="0" tIns="0" bIns="0">
+            <a:spAutoFit/>
+          </a:bodyPr>
+          <a:lstStyle/>
+          <a:p>
+            <a:pPr algn="l">
+              <a:lnSpc>
+                <a:spcPct val="100000"/>
+              </a:lnSpc>
+              <a:spcBef>
+                <a:spcPts val="0"/>
+              </a:spcBef>
+              <a:spcAft>
+                <a:spcPts val="300"/>
+              </a:spcAft>
+            </a:pPr>
             <a:r>
-              <a:rPr sz="640" b="1" i="1">
-                <a:solidFill>
-                  <a:srgbClr val="6B7480"/>
+              <a:rPr sz="900" b="1" i="0">
+                <a:solidFill>
+                  <a:srgbClr val="26815C"/>
                 </a:solidFill>
                 <a:latin typeface="Manrope"/>
                 <a:cs typeface="Manrope"/>
               </a:rPr>
-              <a:t>Planned</a:t>
+              <a:t>Fulfilment %   </a:t>
+            </a:r>
+            <a:r>
+              <a:rPr sz="700" b="1" i="0">
+                <a:solidFill>
+                  <a:srgbClr val="6B7480"/>
+                </a:solidFill>
+                <a:latin typeface="Manrope"/>
+                <a:cs typeface="Manrope"/>
+              </a:rPr>
+              <a:t>· 2 stories</a:t>
             </a:r>
           </a:p>
           <a:p>
-            <a:pPr algn="l" indent="-110000" marL="110000">
-              <a:lnSpc>
-                <a:spcPct val="102000"/>
-              </a:lnSpc>
-              <a:spcBef>
-                <a:spcPts val="0"/>
-              </a:spcBef>
-              <a:spcAft>
-                <a:spcPts val="320"/>
+            <a:pPr algn="l">
+              <a:lnSpc>
+                <a:spcPct val="108000"/>
+              </a:lnSpc>
+              <a:spcBef>
+                <a:spcPts val="0"/>
+              </a:spcBef>
+              <a:spcAft>
+                <a:spcPts val="0"/>
               </a:spcAft>
             </a:pPr>
             <a:r>
-              <a:rPr sz="700" b="0" i="0">
-                <a:solidFill>
-                  <a:srgbClr val="26815C"/>
+              <a:rPr sz="760" b="0" i="0">
+                <a:solidFill>
+                  <a:srgbClr val="25303B"/>
                 </a:solidFill>
                 <a:latin typeface="Manrope"/>
                 <a:cs typeface="Manrope"/>
               </a:rPr>
-              <a:t>● </a:t>
+              <a:t>Scale fulfilment — agentic-AI calling for agents and a live LSP / PSA-CSM / city target dashboard.</a:t>
             </a:r>
+          </a:p>
+        </p:txBody>
+      </p:sp>
+      <p:cxnSp>
+        <p:nvCxnSpPr>
+          <p:cNvPr id="52" name="Connector 51"/>
+          <p:cNvCxnSpPr/>
+          <p:nvPr/>
+        </p:nvCxnSpPr>
+        <p:spPr>
+          <a:xfrm>
+            <a:off x="6120466" y="2735000"/>
+            <a:ext cx="2724933" cy="0"/>
+          </a:xfrm>
+          <a:prstGeom prst="line">
+            <a:avLst/>
+          </a:prstGeom>
+          <a:ln w="6350">
+            <a:solidFill>
+              <a:srgbClr val="E4E8ED"/>
+            </a:solidFill>
+          </a:ln>
+          <a:effectLst/>
+        </p:spPr>
+        <p:style>
+          <a:lnRef idx="2">
+            <a:schemeClr val="accent1"/>
+          </a:lnRef>
+          <a:fillRef idx="0">
+            <a:schemeClr val="accent1"/>
+          </a:fillRef>
+          <a:effectRef idx="1">
+            <a:schemeClr val="accent1"/>
+          </a:effectRef>
+          <a:fontRef idx="minor">
+            <a:schemeClr val="tx1"/>
+          </a:fontRef>
+        </p:style>
+      </p:cxnSp>
+      <p:sp>
+        <p:nvSpPr>
+          <p:cNvPr id="53" name="Rounded Rectangle 52"/>
+          <p:cNvSpPr/>
+          <p:nvPr/>
+        </p:nvSpPr>
+        <p:spPr>
+          <a:xfrm>
+            <a:off x="6106466" y="2777000"/>
+            <a:ext cx="44000" cy="660500"/>
+          </a:xfrm>
+          <a:prstGeom prst="roundRect">
+            <a:avLst>
+              <a:gd name="adj" fmla="val 40000"/>
+            </a:avLst>
+          </a:prstGeom>
+          <a:solidFill>
+            <a:srgbClr val="6043A3"/>
+          </a:solidFill>
+          <a:ln>
+            <a:noFill/>
+          </a:ln>
+          <a:effectLst/>
+        </p:spPr>
+        <p:style>
+          <a:lnRef idx="1">
+            <a:schemeClr val="accent1"/>
+          </a:lnRef>
+          <a:fillRef idx="3">
+            <a:schemeClr val="accent1"/>
+          </a:fillRef>
+          <a:effectRef idx="2">
+            <a:schemeClr val="accent1"/>
+          </a:effectRef>
+          <a:fontRef idx="minor">
+            <a:schemeClr val="lt1"/>
+          </a:fontRef>
+        </p:style>
+        <p:txBody>
+          <a:bodyPr rtlCol="0" anchor="ctr"/>
+          <a:lstStyle/>
+          <a:p>
+            <a:pPr algn="ctr"/>
+          </a:p>
+        </p:txBody>
+      </p:sp>
+      <p:sp>
+        <p:nvSpPr>
+          <p:cNvPr id="54" name="TextBox 53"/>
+          <p:cNvSpPr txBox="1"/>
+          <p:nvPr/>
+        </p:nvSpPr>
+        <p:spPr>
+          <a:xfrm>
+            <a:off x="6190466" y="2769000"/>
+            <a:ext cx="2664933" cy="694500"/>
+          </a:xfrm>
+          <a:prstGeom prst="rect">
+            <a:avLst/>
+          </a:prstGeom>
+          <a:noFill/>
+        </p:spPr>
+        <p:txBody>
+          <a:bodyPr wrap="square" anchor="ctr" lIns="0" rIns="0" tIns="0" bIns="0">
+            <a:spAutoFit/>
+          </a:bodyPr>
+          <a:lstStyle/>
+          <a:p>
+            <a:pPr algn="l">
+              <a:lnSpc>
+                <a:spcPct val="100000"/>
+              </a:lnSpc>
+              <a:spcBef>
+                <a:spcPts val="0"/>
+              </a:spcBef>
+              <a:spcAft>
+                <a:spcPts val="300"/>
+              </a:spcAft>
+            </a:pPr>
             <a:r>
-              <a:rPr sz="720" b="0" i="0">
-                <a:solidFill>
-                  <a:srgbClr val="25303B"/>
+              <a:rPr sz="900" b="1" i="0">
+                <a:solidFill>
+                  <a:srgbClr val="6043A3"/>
                 </a:solidFill>
                 <a:latin typeface="Manrope"/>
                 <a:cs typeface="Manrope"/>
               </a:rPr>
-              <a:t>Agentic-AI calling for fulfilment agents  </a:t>
+              <a:t>DAU   </a:t>
             </a:r>
             <a:r>
-              <a:rPr sz="640" b="1" i="1">
+              <a:rPr sz="700" b="1" i="0">
                 <a:solidFill>
                   <a:srgbClr val="6B7480"/>
                 </a:solidFill>
                 <a:latin typeface="Manrope"/>
                 <a:cs typeface="Manrope"/>
               </a:rPr>
-              <a:t>Planned</a:t>
+              <a:t>· 1 story</a:t>
             </a:r>
           </a:p>
           <a:p>
-            <a:pPr algn="l" indent="-110000" marL="110000">
-              <a:lnSpc>
-                <a:spcPct val="102000"/>
-              </a:lnSpc>
-              <a:spcBef>
-                <a:spcPts val="0"/>
-              </a:spcBef>
-              <a:spcAft>
-                <a:spcPts val="320"/>
+            <a:pPr algn="l">
+              <a:lnSpc>
+                <a:spcPct val="108000"/>
+              </a:lnSpc>
+              <a:spcBef>
+                <a:spcPts val="0"/>
+              </a:spcBef>
+              <a:spcAft>
+                <a:spcPts val="0"/>
               </a:spcAft>
             </a:pPr>
             <a:r>
-              <a:rPr sz="700" b="0" i="0">
-                <a:solidFill>
-                  <a:srgbClr val="26815C"/>
+              <a:rPr sz="760" b="0" i="0">
+                <a:solidFill>
+                  <a:srgbClr val="25303B"/>
                 </a:solidFill>
                 <a:latin typeface="Manrope"/>
                 <a:cs typeface="Manrope"/>
               </a:rPr>
-              <a:t>● </a:t>
+              <a:t>Capture trip charges directly in the FO App with an approval flow.</a:t>
             </a:r>
+          </a:p>
+        </p:txBody>
+      </p:sp>
+      <p:cxnSp>
+        <p:nvCxnSpPr>
+          <p:cNvPr id="55" name="Connector 54"/>
+          <p:cNvCxnSpPr/>
+          <p:nvPr/>
+        </p:nvCxnSpPr>
+        <p:spPr>
+          <a:xfrm>
+            <a:off x="6120466" y="3487500"/>
+            <a:ext cx="2724933" cy="0"/>
+          </a:xfrm>
+          <a:prstGeom prst="line">
+            <a:avLst/>
+          </a:prstGeom>
+          <a:ln w="6350">
+            <a:solidFill>
+              <a:srgbClr val="E4E8ED"/>
+            </a:solidFill>
+          </a:ln>
+          <a:effectLst/>
+        </p:spPr>
+        <p:style>
+          <a:lnRef idx="2">
+            <a:schemeClr val="accent1"/>
+          </a:lnRef>
+          <a:fillRef idx="0">
+            <a:schemeClr val="accent1"/>
+          </a:fillRef>
+          <a:effectRef idx="1">
+            <a:schemeClr val="accent1"/>
+          </a:effectRef>
+          <a:fontRef idx="minor">
+            <a:schemeClr val="tx1"/>
+          </a:fontRef>
+        </p:style>
+      </p:cxnSp>
+      <p:sp>
+        <p:nvSpPr>
+          <p:cNvPr id="56" name="Rounded Rectangle 55"/>
+          <p:cNvSpPr/>
+          <p:nvPr/>
+        </p:nvSpPr>
+        <p:spPr>
+          <a:xfrm>
+            <a:off x="6106466" y="3529500"/>
+            <a:ext cx="44000" cy="660500"/>
+          </a:xfrm>
+          <a:prstGeom prst="roundRect">
+            <a:avLst>
+              <a:gd name="adj" fmla="val 40000"/>
+            </a:avLst>
+          </a:prstGeom>
+          <a:solidFill>
+            <a:srgbClr val="C77D0A"/>
+          </a:solidFill>
+          <a:ln>
+            <a:noFill/>
+          </a:ln>
+          <a:effectLst/>
+        </p:spPr>
+        <p:style>
+          <a:lnRef idx="1">
+            <a:schemeClr val="accent1"/>
+          </a:lnRef>
+          <a:fillRef idx="3">
+            <a:schemeClr val="accent1"/>
+          </a:fillRef>
+          <a:effectRef idx="2">
+            <a:schemeClr val="accent1"/>
+          </a:effectRef>
+          <a:fontRef idx="minor">
+            <a:schemeClr val="lt1"/>
+          </a:fontRef>
+        </p:style>
+        <p:txBody>
+          <a:bodyPr rtlCol="0" anchor="ctr"/>
+          <a:lstStyle/>
+          <a:p>
+            <a:pPr algn="ctr"/>
+          </a:p>
+        </p:txBody>
+      </p:sp>
+      <p:sp>
+        <p:nvSpPr>
+          <p:cNvPr id="57" name="TextBox 56"/>
+          <p:cNvSpPr txBox="1"/>
+          <p:nvPr/>
+        </p:nvSpPr>
+        <p:spPr>
+          <a:xfrm>
+            <a:off x="6190466" y="3521500"/>
+            <a:ext cx="2664933" cy="694500"/>
+          </a:xfrm>
+          <a:prstGeom prst="rect">
+            <a:avLst/>
+          </a:prstGeom>
+          <a:noFill/>
+        </p:spPr>
+        <p:txBody>
+          <a:bodyPr wrap="square" anchor="ctr" lIns="0" rIns="0" tIns="0" bIns="0">
+            <a:spAutoFit/>
+          </a:bodyPr>
+          <a:lstStyle/>
+          <a:p>
+            <a:pPr algn="l">
+              <a:lnSpc>
+                <a:spcPct val="100000"/>
+              </a:lnSpc>
+              <a:spcBef>
+                <a:spcPts val="0"/>
+              </a:spcBef>
+              <a:spcAft>
+                <a:spcPts val="300"/>
+              </a:spcAft>
+            </a:pPr>
             <a:r>
-              <a:rPr sz="720" b="1" i="0">
-                <a:solidFill>
-                  <a:srgbClr val="25303B"/>
+              <a:rPr sz="900" b="1" i="0">
+                <a:solidFill>
+                  <a:srgbClr val="C77D0A"/>
                 </a:solidFill>
                 <a:latin typeface="Manrope"/>
                 <a:cs typeface="Manrope"/>
               </a:rPr>
-              <a:t>CM-829  </a:t>
+              <a:t>Reduce Ops Bandwidth   </a:t>
             </a:r>
             <a:r>
-              <a:rPr sz="720" b="0" i="0">
-                <a:solidFill>
-                  <a:srgbClr val="25303B"/>
+              <a:rPr sz="700" b="1" i="0">
+                <a:solidFill>
+                  <a:srgbClr val="6B7480"/>
                 </a:solidFill>
                 <a:latin typeface="Manrope"/>
                 <a:cs typeface="Manrope"/>
               </a:rPr>
-              <a:t>Live target dashboard — LSP / PSA-CSM / City-wise  </a:t>
+              <a:t>· 2 stories</a:t>
             </a:r>
+          </a:p>
+          <a:p>
+            <a:pPr algn="l">
+              <a:lnSpc>
+                <a:spcPct val="108000"/>
+              </a:lnSpc>
+              <a:spcBef>
+                <a:spcPts val="0"/>
+              </a:spcBef>
+              <a:spcAft>
+                <a:spcPts val="0"/>
+              </a:spcAft>
+            </a:pPr>
             <a:r>
-              <a:rPr sz="640" b="1" i="1">
-                <a:solidFill>
-                  <a:srgbClr val="6B7480"/>
+              <a:rPr sz="760" b="0" i="0">
+                <a:solidFill>
+                  <a:srgbClr val="25303B"/>
                 </a:solidFill>
                 <a:latin typeface="Manrope"/>
                 <a:cs typeface="Manrope"/>
               </a:rPr>
-              <a:t>Planned</a:t>
-            </a:r>
-          </a:p>
-          <a:p>
-            <a:pPr algn="l" indent="-110000" marL="110000">
-              <a:lnSpc>
-                <a:spcPct val="102000"/>
-              </a:lnSpc>
-              <a:spcBef>
-                <a:spcPts val="0"/>
-              </a:spcBef>
-              <a:spcAft>
-                <a:spcPts val="320"/>
-              </a:spcAft>
-            </a:pPr>
-            <a:r>
-              <a:rPr sz="700" b="0" i="0">
-                <a:solidFill>
-                  <a:srgbClr val="6043A3"/>
-                </a:solidFill>
-                <a:latin typeface="Manrope"/>
-                <a:cs typeface="Manrope"/>
-              </a:rPr>
-              <a:t>● </a:t>
-            </a:r>
-            <a:r>
-              <a:rPr sz="720" b="1" i="0">
-                <a:solidFill>
-                  <a:srgbClr val="25303B"/>
-                </a:solidFill>
-                <a:latin typeface="Manrope"/>
-                <a:cs typeface="Manrope"/>
-              </a:rPr>
-              <a:t>CM-820  </a:t>
-            </a:r>
-            <a:r>
-              <a:rPr sz="720" b="0" i="0">
-                <a:solidFill>
-                  <a:srgbClr val="25303B"/>
-                </a:solidFill>
-                <a:latin typeface="Manrope"/>
-                <a:cs typeface="Manrope"/>
-              </a:rPr>
-              <a:t>FO App: capture trip charges directly with approval flow  </a:t>
-            </a:r>
-            <a:r>
-              <a:rPr sz="640" b="1" i="1">
-                <a:solidFill>
-                  <a:srgbClr val="6043A3"/>
-                </a:solidFill>
-                <a:latin typeface="Manrope"/>
-                <a:cs typeface="Manrope"/>
-              </a:rPr>
-              <a:t>Prioritised</a:t>
-            </a:r>
-          </a:p>
-          <a:p>
-            <a:pPr algn="l" indent="-110000" marL="110000">
-              <a:lnSpc>
-                <a:spcPct val="102000"/>
-              </a:lnSpc>
-              <a:spcBef>
-                <a:spcPts val="0"/>
-              </a:spcBef>
-              <a:spcAft>
-                <a:spcPts val="320"/>
-              </a:spcAft>
-            </a:pPr>
-            <a:r>
-              <a:rPr sz="700" b="0" i="0">
-                <a:solidFill>
-                  <a:srgbClr val="C77D0A"/>
-                </a:solidFill>
-                <a:latin typeface="Manrope"/>
-                <a:cs typeface="Manrope"/>
-              </a:rPr>
-              <a:t>● </a:t>
-            </a:r>
-            <a:r>
-              <a:rPr sz="720" b="1" i="0">
-                <a:solidFill>
-                  <a:srgbClr val="25303B"/>
-                </a:solidFill>
-                <a:latin typeface="Manrope"/>
-                <a:cs typeface="Manrope"/>
-              </a:rPr>
-              <a:t>CM-827  </a:t>
-            </a:r>
-            <a:r>
-              <a:rPr sz="720" b="0" i="0">
-                <a:solidFill>
-                  <a:srgbClr val="25303B"/>
-                </a:solidFill>
-                <a:latin typeface="Manrope"/>
-                <a:cs typeface="Manrope"/>
-              </a:rPr>
-              <a:t>Automate compliance document generation  </a:t>
-            </a:r>
-            <a:r>
-              <a:rPr sz="640" b="1" i="1">
-                <a:solidFill>
-                  <a:srgbClr val="6B7480"/>
-                </a:solidFill>
-                <a:latin typeface="Manrope"/>
-                <a:cs typeface="Manrope"/>
-              </a:rPr>
-              <a:t>Planned</a:t>
-            </a:r>
-          </a:p>
-          <a:p>
-            <a:pPr algn="l" indent="-110000" marL="110000">
-              <a:lnSpc>
-                <a:spcPct val="102000"/>
-              </a:lnSpc>
-              <a:spcBef>
-                <a:spcPts val="0"/>
-              </a:spcBef>
-              <a:spcAft>
-                <a:spcPts val="320"/>
-              </a:spcAft>
-            </a:pPr>
-            <a:r>
-              <a:rPr sz="700" b="0" i="0">
-                <a:solidFill>
-                  <a:srgbClr val="C77D0A"/>
-                </a:solidFill>
-                <a:latin typeface="Manrope"/>
-                <a:cs typeface="Manrope"/>
-              </a:rPr>
-              <a:t>● </a:t>
-            </a:r>
-            <a:r>
-              <a:rPr sz="720" b="1" i="0">
-                <a:solidFill>
-                  <a:srgbClr val="25303B"/>
-                </a:solidFill>
-                <a:latin typeface="Manrope"/>
-                <a:cs typeface="Manrope"/>
-              </a:rPr>
-              <a:t>CM-822  </a:t>
-            </a:r>
-            <a:r>
-              <a:rPr sz="720" b="0" i="0">
-                <a:solidFill>
-                  <a:srgbClr val="25303B"/>
-                </a:solidFill>
-                <a:latin typeface="Manrope"/>
-                <a:cs typeface="Manrope"/>
-              </a:rPr>
-              <a:t>Automate POD audit via OCR  </a:t>
-            </a:r>
-            <a:r>
-              <a:rPr sz="640" b="1" i="1">
-                <a:solidFill>
-                  <a:srgbClr val="6043A3"/>
-                </a:solidFill>
-                <a:latin typeface="Manrope"/>
-                <a:cs typeface="Manrope"/>
-              </a:rPr>
-              <a:t>Prioritised</a:t>
+              <a:t>Automate compliance-document generation and POD audit via OCR.</a:t>
             </a:r>
           </a:p>
         </p:txBody>
       </p:sp>
       <p:sp>
         <p:nvSpPr>
-          <p:cNvPr id="28" name="Rounded Rectangle 27"/>
+          <p:cNvPr id="58" name="Rounded Rectangle 57"/>
           <p:cNvSpPr/>
           <p:nvPr/>
         </p:nvSpPr>
         <p:spPr>
           <a:xfrm>
-            <a:off x="228600" y="3860000"/>
+            <a:off x="228600" y="4340000"/>
             <a:ext cx="8686800" cy="530000"/>
           </a:xfrm>
           <a:prstGeom prst="roundRect">
@@ -23761,13 +24009,13 @@
       </p:sp>
       <p:sp>
         <p:nvSpPr>
-          <p:cNvPr id="29" name="TextBox 28"/>
+          <p:cNvPr id="59" name="TextBox 58"/>
           <p:cNvSpPr txBox="1"/>
           <p:nvPr/>
         </p:nvSpPr>
         <p:spPr>
           <a:xfrm>
-            <a:off x="318600" y="3894000"/>
+            <a:off x="318600" y="4374000"/>
             <a:ext cx="8506800" cy="470000"/>
           </a:xfrm>
           <a:prstGeom prst="rect">

</xml_diff>

<commit_message>
Roadmap slide: add Linear-reconciled status per goal
Add status chips to all 12 goal cells on the execution-plan slide from
Linear (Carrier Matching): July Ledger shipped; Fulfilment & Ops part-
shipped; DAU in build; Aug/Sep planned. Status key added to notes band.

Co-Authored-By: Claude Opus 4.8 <noreply@anthropic.com>
Claude-Session: https://claude.ai/code/session_01HTHNkMyy3hCJ7Wqf5x3kDZ
</commit_message>
<xml_diff>
--- a/board_review_q2_2026/TML_Review_CM_AprMayJun_2026_BoardReview.pptx
+++ b/board_review_q2_2026/TML_Review_CM_AprMayJun_2026_BoardReview.pptx
@@ -21936,6 +21936,16 @@
               </a:rPr>
               <a:t>· 5 stories</a:t>
             </a:r>
+            <a:r>
+              <a:rPr sz="700" b="1">
+                <a:solidFill>
+                  <a:srgbClr val="1E7A46"/>
+                </a:solidFill>
+                <a:latin typeface="Manrope"/>
+                <a:cs typeface="Manrope"/>
+              </a:rPr>
+              <a:t>   ✓ Shipped</a:t>
+            </a:r>
           </a:p>
           <a:p>
             <a:pPr algn="l">
@@ -22097,6 +22107,16 @@
               </a:rPr>
               <a:t>· 3 stories</a:t>
             </a:r>
+            <a:r>
+              <a:rPr sz="700" b="1">
+                <a:solidFill>
+                  <a:srgbClr val="0F766E"/>
+                </a:solidFill>
+                <a:latin typeface="Manrope"/>
+                <a:cs typeface="Manrope"/>
+              </a:rPr>
+              <a:t>   ◐ Part shipped</a:t>
+            </a:r>
           </a:p>
           <a:p>
             <a:pPr algn="l">
@@ -22258,6 +22278,16 @@
               </a:rPr>
               <a:t>· 1 story</a:t>
             </a:r>
+            <a:r>
+              <a:rPr sz="700" b="1">
+                <a:solidFill>
+                  <a:srgbClr val="3E4C63"/>
+                </a:solidFill>
+                <a:latin typeface="Manrope"/>
+                <a:cs typeface="Manrope"/>
+              </a:rPr>
+              <a:t>   ◐ In build</a:t>
+            </a:r>
           </a:p>
           <a:p>
             <a:pPr algn="l">
@@ -22418,6 +22448,16 @@
                 <a:cs typeface="Manrope"/>
               </a:rPr>
               <a:t>· 3 stories</a:t>
+            </a:r>
+            <a:r>
+              <a:rPr sz="700" b="1">
+                <a:solidFill>
+                  <a:srgbClr val="0F766E"/>
+                </a:solidFill>
+                <a:latin typeface="Manrope"/>
+                <a:cs typeface="Manrope"/>
+              </a:rPr>
+              <a:t>   ◐ Part shipped</a:t>
             </a:r>
           </a:p>
           <a:p>
@@ -22694,6 +22734,16 @@
               </a:rPr>
               <a:t>· 4 stories</a:t>
             </a:r>
+            <a:r>
+              <a:rPr sz="700" b="1">
+                <a:solidFill>
+                  <a:srgbClr val="3E4C63"/>
+                </a:solidFill>
+                <a:latin typeface="Manrope"/>
+                <a:cs typeface="Manrope"/>
+              </a:rPr>
+              <a:t>   ◐ In build</a:t>
+            </a:r>
           </a:p>
           <a:p>
             <a:pPr algn="l">
@@ -22855,6 +22905,16 @@
               </a:rPr>
               <a:t>· 5 stories</a:t>
             </a:r>
+            <a:r>
+              <a:rPr sz="700" b="1">
+                <a:solidFill>
+                  <a:srgbClr val="8A939E"/>
+                </a:solidFill>
+                <a:latin typeface="Manrope"/>
+                <a:cs typeface="Manrope"/>
+              </a:rPr>
+              <a:t>   ○ Planned</a:t>
+            </a:r>
           </a:p>
           <a:p>
             <a:pPr algn="l">
@@ -23016,6 +23076,16 @@
               </a:rPr>
               <a:t>· 1 story</a:t>
             </a:r>
+            <a:r>
+              <a:rPr sz="700" b="1">
+                <a:solidFill>
+                  <a:srgbClr val="8A939E"/>
+                </a:solidFill>
+                <a:latin typeface="Manrope"/>
+                <a:cs typeface="Manrope"/>
+              </a:rPr>
+              <a:t>   ○ Planned</a:t>
+            </a:r>
           </a:p>
           <a:p>
             <a:pPr algn="l">
@@ -23176,6 +23246,16 @@
                 <a:cs typeface="Manrope"/>
               </a:rPr>
               <a:t>· 1 story</a:t>
+            </a:r>
+            <a:r>
+              <a:rPr sz="700" b="1">
+                <a:solidFill>
+                  <a:srgbClr val="8A939E"/>
+                </a:solidFill>
+                <a:latin typeface="Manrope"/>
+                <a:cs typeface="Manrope"/>
+              </a:rPr>
+              <a:t>   ○ Planned</a:t>
             </a:r>
           </a:p>
           <a:p>
@@ -23452,6 +23532,16 @@
               </a:rPr>
               <a:t>· 1 story</a:t>
             </a:r>
+            <a:r>
+              <a:rPr sz="700" b="1">
+                <a:solidFill>
+                  <a:srgbClr val="8A939E"/>
+                </a:solidFill>
+                <a:latin typeface="Manrope"/>
+                <a:cs typeface="Manrope"/>
+              </a:rPr>
+              <a:t>   ○ Planned</a:t>
+            </a:r>
           </a:p>
           <a:p>
             <a:pPr algn="l">
@@ -23613,6 +23703,16 @@
               </a:rPr>
               <a:t>· 2 stories</a:t>
             </a:r>
+            <a:r>
+              <a:rPr sz="700" b="1">
+                <a:solidFill>
+                  <a:srgbClr val="8A939E"/>
+                </a:solidFill>
+                <a:latin typeface="Manrope"/>
+                <a:cs typeface="Manrope"/>
+              </a:rPr>
+              <a:t>   ○ Planned</a:t>
+            </a:r>
           </a:p>
           <a:p>
             <a:pPr algn="l">
@@ -23774,6 +23874,16 @@
               </a:rPr>
               <a:t>· 1 story</a:t>
             </a:r>
+            <a:r>
+              <a:rPr sz="700" b="1">
+                <a:solidFill>
+                  <a:srgbClr val="8A939E"/>
+                </a:solidFill>
+                <a:latin typeface="Manrope"/>
+                <a:cs typeface="Manrope"/>
+              </a:rPr>
+              <a:t>   ○ Planned</a:t>
+            </a:r>
           </a:p>
           <a:p>
             <a:pPr algn="l">
@@ -23935,6 +24045,16 @@
               </a:rPr>
               <a:t>· 2 stories</a:t>
             </a:r>
+            <a:r>
+              <a:rPr sz="700" b="1">
+                <a:solidFill>
+                  <a:srgbClr val="8A939E"/>
+                </a:solidFill>
+                <a:latin typeface="Manrope"/>
+                <a:cs typeface="Manrope"/>
+              </a:rPr>
+              <a:t>   ○ Planned</a:t>
+            </a:r>
           </a:p>
           <a:p>
             <a:pPr algn="l">
@@ -24082,6 +24202,53 @@
                 <a:cs typeface="Manrope"/>
               </a:rPr>
               <a:t>Network-lane conversion (Q1 FY27 actuals): Apr 13.7% → May 11.2% → Jun 17.1% — entering Q2 at ~17%, the plan above targets a 20% exit.</a:t>
+            </a:r>
+          </a:p>
+          <a:p>
+            <a:pPr>
+              <a:spcBef>
+                <a:spcPts val="300"/>
+              </a:spcBef>
+            </a:pPr>
+            <a:r>
+              <a:rPr sz="750" b="1">
+                <a:solidFill>
+                  <a:srgbClr val="25303B"/>
+                </a:solidFill>
+                <a:latin typeface="Manrope"/>
+                <a:cs typeface="Manrope"/>
+              </a:rPr>
+              <a:t>Status per Linear (Aug'26):  </a:t>
+            </a:r>
+            <a:r>
+              <a:rPr sz="750" b="1">
+                <a:solidFill>
+                  <a:srgbClr val="1E7A46"/>
+                </a:solidFill>
+                <a:latin typeface="Manrope"/>
+                <a:cs typeface="Manrope"/>
+              </a:rPr>
+              <a:t>✓ Shipped   </a:t>
+            </a:r>
+            <a:r>
+              <a:rPr sz="750" b="1">
+                <a:solidFill>
+                  <a:srgbClr val="0F766E"/>
+                </a:solidFill>
+                <a:latin typeface="Manrope"/>
+                <a:cs typeface="Manrope"/>
+              </a:rPr>
+              <a:t>◐ In build / part shipped   </a:t>
+            </a:r>
+            <a:r>
+              <a:rPr sz="750" b="1">
+                <a:solidFill>
+                  <a:srgbClr val="8A939E"/>
+                </a:solidFill>
+                <a:latin typeface="Manrope"/>
+                <a:cs typeface="Manrope"/>
+              </a:rPr>
+              <a:t>○ Planned</a:t>
             </a:r>
           </a:p>
         </p:txBody>

</xml_diff>

<commit_message>
Roadmap slide: drop April from network-lane conversion trend
Conversion trend now shows May 11.2% -> Jun 17.1% (April removed) in both
the legend note and leadership-notes band.

Co-Authored-By: Claude Opus 4.8 <noreply@anthropic.com>
Claude-Session: https://claude.ai/code/session_01HTHNkMyy3hCJ7Wqf5x3kDZ
</commit_message>
<xml_diff>
--- a/board_review_q2_2026/TML_Review_CM_AprMayJun_2026_BoardReview.pptx
+++ b/board_review_q2_2026/TML_Review_CM_AprMayJun_2026_BoardReview.pptx
@@ -21682,7 +21682,7 @@
                 <a:latin typeface="Manrope"/>
                 <a:cs typeface="Manrope"/>
               </a:rPr>
-              <a:t>Apr 13.7% → May 11.2% → Jun 17.1%  →  Q2 exit 20%</a:t>
+              <a:t>May 11.2% → Jun 17.1%  →  Q2 exit 20%</a:t>
             </a:r>
           </a:p>
         </p:txBody>
@@ -24201,7 +24201,7 @@
                 <a:latin typeface="Manrope"/>
                 <a:cs typeface="Manrope"/>
               </a:rPr>
-              <a:t>Network-lane conversion (Q1 FY27 actuals): Apr 13.7% → May 11.2% → Jun 17.1% — entering Q2 at ~17%, the plan above targets a 20% exit.</a:t>
+              <a:t>Network-lane conversion (Q1 FY27): May 11.2% → Jun 17.1% — entering Q2 at ~17%, the plan above targets a 20% exit.</a:t>
             </a:r>
           </a:p>
           <a:p>

</xml_diff>

<commit_message>
Board slide 1: refresh Apr-Jun Delivery column from Linear
Replace generic delivery bullets with real Apr-Jun key deliveries per
project (Product Stories + released dev items) from Carrier Matching:
FO App bid/POD features, smarter matching, agentic AI inventory calling,
Vahan/ULIP + WhatsApp automation, ledger design finalised. Outcome metric
retained per row.

Co-Authored-By: Claude Opus 4.8 <noreply@anthropic.com>
Claude-Session: https://claude.ai/code/session_01HTHNkMyy3hCJ7Wqf5x3kDZ
</commit_message>
<xml_diff>
--- a/board_review_q2_2026/TML_Review_CM_AprMayJun_2026_BoardReview.pptx
+++ b/board_review_q2_2026/TML_Review_CM_AprMayJun_2026_BoardReview.pptx
@@ -13543,14 +13543,14 @@
               </a:spcAft>
             </a:pPr>
             <a:r>
-              <a:rPr sz="819" b="0" i="0">
+              <a:rPr sz="780" b="0" i="0">
                 <a:solidFill>
                   <a:srgbClr val="25303B"/>
                 </a:solidFill>
                 <a:latin typeface="Manrope"/>
                 <a:cs typeface="Manrope"/>
               </a:rPr>
-              <a:t>•  Shipped better load experience &amp; payment visibility</a:t>
+              <a:t>•  My Bids + bid-status alerts; advance-pay banner</a:t>
             </a:r>
           </a:p>
           <a:p>
@@ -13566,14 +13566,14 @@
               </a:spcAft>
             </a:pPr>
             <a:r>
-              <a:rPr sz="819" b="1" i="0">
-                <a:solidFill>
-                  <a:srgbClr val="26815C"/>
+              <a:rPr sz="780" b="0" i="0">
+                <a:solidFill>
+                  <a:srgbClr val="25303B"/>
                 </a:solidFill>
                 <a:latin typeface="Manrope"/>
                 <a:cs typeface="Manrope"/>
               </a:rPr>
-              <a:t>•  DAU 178 → 252 (+42%); crossed 250/day</a:t>
+              <a:t>•  Full POD details, status &amp; dispute alerts</a:t>
             </a:r>
           </a:p>
           <a:p>
@@ -13589,14 +13589,14 @@
               </a:spcAft>
             </a:pPr>
             <a:r>
-              <a:rPr sz="819" b="0" i="0">
+              <a:rPr sz="780" b="0" i="0">
                 <a:solidFill>
                   <a:srgbClr val="25303B"/>
                 </a:solidFill>
                 <a:latin typeface="Manrope"/>
                 <a:cs typeface="Manrope"/>
               </a:rPr>
-              <a:t>•  MAU 1,027 → 1,325 (+29%); Installs → 1,935</a:t>
+              <a:t>•  Exact loading address post-win; demand alerts</a:t>
             </a:r>
           </a:p>
           <a:p>
@@ -13612,14 +13612,14 @@
               </a:spcAft>
             </a:pPr>
             <a:r>
-              <a:rPr sz="819" b="0" i="0">
-                <a:solidFill>
-                  <a:srgbClr val="25303B"/>
+              <a:rPr sz="780" b="1" i="0">
+                <a:solidFill>
+                  <a:srgbClr val="26815C"/>
                 </a:solidFill>
                 <a:latin typeface="Manrope"/>
                 <a:cs typeface="Manrope"/>
               </a:rPr>
-              <a:t>•  Stickiness 17.3% → 19.0%</a:t>
+              <a:t>•  DAU 178 → 252 (+42%); MAU → 1,325; Installs → 1,935</a:t>
             </a:r>
           </a:p>
         </p:txBody>
@@ -13889,14 +13889,14 @@
               </a:spcAft>
             </a:pPr>
             <a:r>
-              <a:rPr sz="819" b="0" i="0">
+              <a:rPr sz="780" b="0" i="0">
                 <a:solidFill>
                   <a:srgbClr val="25303B"/>
                 </a:solidFill>
                 <a:latin typeface="Manrope"/>
                 <a:cs typeface="Manrope"/>
               </a:rPr>
-              <a:t>•  Matching, bid ranges &amp; live visibility shipped</a:t>
+              <a:t>•  Smarter matching: origin + normalised veh-type</a:t>
             </a:r>
           </a:p>
           <a:p>
@@ -13912,14 +13912,14 @@
               </a:spcAft>
             </a:pPr>
             <a:r>
-              <a:rPr sz="819" b="1" i="0">
-                <a:solidFill>
-                  <a:srgbClr val="26815C"/>
+              <a:rPr sz="780" b="0" i="0">
+                <a:solidFill>
+                  <a:srgbClr val="25303B"/>
                 </a:solidFill>
                 <a:latin typeface="Manrope"/>
                 <a:cs typeface="Manrope"/>
               </a:rPr>
-              <a:t>•  June rebound — Bids 477 → 725 (+52%)</a:t>
+              <a:t>•  Split availability lane-wise; enrich suppliers</a:t>
             </a:r>
           </a:p>
           <a:p>
@@ -13935,14 +13935,14 @@
               </a:spcAft>
             </a:pPr>
             <a:r>
-              <a:rPr sz="819" b="1" i="0">
-                <a:solidFill>
-                  <a:srgbClr val="26815C"/>
+              <a:rPr sz="780" b="0" i="0">
+                <a:solidFill>
+                  <a:srgbClr val="25303B"/>
                 </a:solidFill>
                 <a:latin typeface="Manrope"/>
                 <a:cs typeface="Manrope"/>
               </a:rPr>
-              <a:t>•  Placeable fulfilment 17.3% → 24.9%</a:t>
+              <a:t>•  Duplicate-demand guard; agent onboarding</a:t>
             </a:r>
           </a:p>
           <a:p>
@@ -13958,14 +13958,14 @@
               </a:spcAft>
             </a:pPr>
             <a:r>
-              <a:rPr sz="819" b="0" i="0">
-                <a:solidFill>
-                  <a:srgbClr val="25303B"/>
+              <a:rPr sz="780" b="1" i="0">
+                <a:solidFill>
+                  <a:srgbClr val="26815C"/>
                 </a:solidFill>
                 <a:latin typeface="Manrope"/>
                 <a:cs typeface="Manrope"/>
               </a:rPr>
-              <a:t>•  Unique FO bidders 189 → 267</a:t>
+              <a:t>•  Bids 477 → 725 (+52%); fulfilment 17.3 → 24.9%</a:t>
             </a:r>
           </a:p>
         </p:txBody>
@@ -14235,14 +14235,14 @@
               </a:spcAft>
             </a:pPr>
             <a:r>
-              <a:rPr sz="819" b="1" i="0">
+              <a:rPr sz="780" b="1" i="0">
                 <a:solidFill>
                   <a:srgbClr val="26815C"/>
                 </a:solidFill>
                 <a:latin typeface="Manrope"/>
                 <a:cs typeface="Manrope"/>
               </a:rPr>
-              <a:t>•  AI drives ~65% of inventory (869 of 1,341 in Jun)</a:t>
+              <a:t>•  Agentic AI inventory calling — multi-lingual</a:t>
             </a:r>
           </a:p>
           <a:p>
@@ -14258,14 +14258,14 @@
               </a:spcAft>
             </a:pPr>
             <a:r>
-              <a:rPr sz="819" b="0" i="0">
+              <a:rPr sz="780" b="0" i="0">
                 <a:solidFill>
                   <a:srgbClr val="25303B"/>
                 </a:solidFill>
                 <a:latin typeface="Manrope"/>
                 <a:cs typeface="Manrope"/>
               </a:rPr>
-              <a:t>•  Agent inv. 728 → 1,043 peak; manual 1,098 → 472</a:t>
+              <a:t>•  GPS potential-inv detection; alt O/D capture</a:t>
             </a:r>
           </a:p>
           <a:p>
@@ -14281,14 +14281,37 @@
               </a:spcAft>
             </a:pPr>
             <a:r>
-              <a:rPr sz="819" b="0" i="0">
+              <a:rPr sz="780" b="0" i="0">
                 <a:solidFill>
                   <a:srgbClr val="25303B"/>
                 </a:solidFill>
                 <a:latin typeface="Manrope"/>
                 <a:cs typeface="Manrope"/>
               </a:rPr>
-              <a:t>•  Gap: total inventory &amp; conversion fell 23.9% → 11.4%</a:t>
+              <a:t>•  WhatsApp fallback + callback; Live Eval Agent</a:t>
+            </a:r>
+          </a:p>
+          <a:p>
+            <a:pPr algn="l" indent="-137160" marL="137160">
+              <a:lnSpc>
+                <a:spcPct val="102000"/>
+              </a:lnSpc>
+              <a:spcBef>
+                <a:spcPts val="0"/>
+              </a:spcBef>
+              <a:spcAft>
+                <a:spcPts val="250"/>
+              </a:spcAft>
+            </a:pPr>
+            <a:r>
+              <a:rPr sz="780" b="1" i="0">
+                <a:solidFill>
+                  <a:srgbClr val="26815C"/>
+                </a:solidFill>
+                <a:latin typeface="Manrope"/>
+                <a:cs typeface="Manrope"/>
+              </a:rPr>
+              <a:t>•  AI drives ~65% of inventory (869 of 1,341)</a:t>
             </a:r>
           </a:p>
         </p:txBody>
@@ -14558,14 +14581,14 @@
               </a:spcAft>
             </a:pPr>
             <a:r>
-              <a:rPr sz="819" b="0" i="0">
+              <a:rPr sz="780" b="0" i="0">
                 <a:solidFill>
                   <a:srgbClr val="25303B"/>
                 </a:solidFill>
                 <a:latin typeface="Manrope"/>
                 <a:cs typeface="Manrope"/>
               </a:rPr>
-              <a:t>•  Automated Vahan verification &amp; journey updates in LSP WhatsApp [May]</a:t>
+              <a:t>•  Automated Vahan verification via ULIP</a:t>
             </a:r>
           </a:p>
           <a:p>
@@ -14581,14 +14604,14 @@
               </a:spcAft>
             </a:pPr>
             <a:r>
-              <a:rPr sz="819" b="1" i="0">
-                <a:solidFill>
-                  <a:srgbClr val="26815C"/>
+              <a:rPr sz="780" b="0" i="0">
+                <a:solidFill>
+                  <a:srgbClr val="25303B"/>
                 </a:solidFill>
                 <a:latin typeface="Manrope"/>
                 <a:cs typeface="Manrope"/>
               </a:rPr>
-              <a:t>•  Agent calls scaled to 16k/mo; ~10 hrs/day CT effort saved</a:t>
+              <a:t>•  Auto WhatsApp trip-link + loading-memo to LSP</a:t>
             </a:r>
           </a:p>
           <a:p>
@@ -14604,14 +14627,37 @@
               </a:spcAft>
             </a:pPr>
             <a:r>
-              <a:rPr sz="819" b="1" i="0">
-                <a:solidFill>
-                  <a:srgbClr val="26815C"/>
+              <a:rPr sz="780" b="0" i="0">
+                <a:solidFill>
+                  <a:srgbClr val="25303B"/>
                 </a:solidFill>
                 <a:latin typeface="Manrope"/>
                 <a:cs typeface="Manrope"/>
               </a:rPr>
-              <a:t>•  ~15% reduction in City Team resource cost</a:t>
+              <a:t>•  System STA auto-calc; adv-pay %; OCR approval</a:t>
+            </a:r>
+          </a:p>
+          <a:p>
+            <a:pPr algn="l" indent="-137160" marL="137160">
+              <a:lnSpc>
+                <a:spcPct val="102000"/>
+              </a:lnSpc>
+              <a:spcBef>
+                <a:spcPts val="0"/>
+              </a:spcBef>
+              <a:spcAft>
+                <a:spcPts val="250"/>
+              </a:spcAft>
+            </a:pPr>
+            <a:r>
+              <a:rPr sz="780" b="1" i="0">
+                <a:solidFill>
+                  <a:srgbClr val="26815C"/>
+                </a:solidFill>
+                <a:latin typeface="Manrope"/>
+                <a:cs typeface="Manrope"/>
+              </a:rPr>
+              <a:t>•  ~10 hrs/day CT saved; ~15% cost reduction</a:t>
             </a:r>
           </a:p>
         </p:txBody>
@@ -14881,14 +14927,14 @@
               </a:spcAft>
             </a:pPr>
             <a:r>
-              <a:rPr sz="819" b="1" i="0">
+              <a:rPr sz="780" b="1" i="0">
                 <a:solidFill>
                   <a:srgbClr val="26815C"/>
                 </a:solidFill>
                 <a:latin typeface="Manrope"/>
                 <a:cs typeface="Manrope"/>
               </a:rPr>
-              <a:t>•  Initiative picked up in June</a:t>
+              <a:t>•  Ledger design finalised — build-vs-buy decision</a:t>
             </a:r>
           </a:p>
           <a:p>
@@ -14904,14 +14950,14 @@
               </a:spcAft>
             </a:pPr>
             <a:r>
-              <a:rPr sz="819" b="0" i="0">
+              <a:rPr sz="780" b="0" i="0">
                 <a:solidFill>
                   <a:srgbClr val="25303B"/>
                 </a:solidFill>
                 <a:latin typeface="Manrope"/>
                 <a:cs typeface="Manrope"/>
               </a:rPr>
-              <a:t>•  Scoping trip-level &amp; party-level ledger design</a:t>
+              <a:t>•  Phased plan; trip &amp; party-level ledger design</a:t>
             </a:r>
           </a:p>
         </p:txBody>

</xml_diff>